<commit_message>
Format SIH_ppt.pptx and SIH_ppt.ppt with effortless clean light-theme styling and SIH official template structure
</commit_message>
<xml_diff>
--- a/SIH_ppt.pptx
+++ b/SIH_ppt.pptx
@@ -3108,7 +3108,7 @@
             <a:avLst/>
           </a:prstGeom>
           <a:solidFill>
-            <a:srgbClr val="082419"/>
+            <a:srgbClr val="FFFFFF"/>
           </a:solidFill>
           <a:ln>
             <a:noFill/>
@@ -3145,17 +3145,17 @@
         <p:spPr>
           <a:xfrm>
             <a:off x="0" y="0"/>
-            <a:ext cx="12191695" cy="137160"/>
+            <a:ext cx="12191695" cy="109728"/>
           </a:xfrm>
           <a:prstGeom prst="rect">
             <a:avLst/>
           </a:prstGeom>
           <a:solidFill>
-            <a:srgbClr val="D4AF37"/>
+            <a:srgbClr val="0284C7"/>
           </a:solidFill>
           <a:ln>
             <a:solidFill>
-              <a:srgbClr val="D4AF37"/>
+              <a:srgbClr val="0284C7"/>
             </a:solidFill>
           </a:ln>
         </p:spPr>
@@ -3189,8 +3189,8 @@
         </p:nvSpPr>
         <p:spPr>
           <a:xfrm>
-            <a:off x="914400" y="914400"/>
-            <a:ext cx="10362895" cy="1371600"/>
+            <a:off x="731520" y="457200"/>
+            <a:ext cx="10728655" cy="1097280"/>
           </a:xfrm>
           <a:prstGeom prst="rect">
             <a:avLst/>
@@ -3204,9 +3204,9 @@
           <a:lstStyle/>
           <a:p>
             <a:pPr>
-              <a:defRPr sz="3600" b="1">
-                <a:solidFill>
-                  <a:srgbClr val="D4AF37"/>
+              <a:defRPr sz="3000" b="1">
+                <a:solidFill>
+                  <a:srgbClr val="0F1E36"/>
                 </a:solidFill>
                 <a:latin typeface="Georgia"/>
               </a:defRPr>
@@ -3217,14 +3217,14 @@
           </a:p>
           <a:p>
             <a:pPr>
-              <a:defRPr sz="2000">
-                <a:solidFill>
-                  <a:srgbClr val="F5F5F4"/>
-                </a:solidFill>
-              </a:defRPr>
-            </a:pPr>
-            <a:r>
-              <a:t>AyurSutra — Panchakarma Sanctuary &amp; Patient Intake Portal</a:t>
+              <a:defRPr sz="1400" b="1">
+                <a:solidFill>
+                  <a:srgbClr val="E36209"/>
+                </a:solidFill>
+              </a:defRPr>
+            </a:pPr>
+            <a:r>
+              <a:t>TITLE PAGE — AYURSUTRA CLINICAL SANCTUARY &amp; PATIENT INTAKE PORTAL</a:t>
             </a:r>
           </a:p>
         </p:txBody>
@@ -3237,8 +3237,237 @@
         </p:nvSpPr>
         <p:spPr>
           <a:xfrm>
-            <a:off x="914400" y="2560320"/>
-            <a:ext cx="10362895" cy="3657600"/>
+            <a:off x="731520" y="1645920"/>
+            <a:ext cx="6583680" cy="4572000"/>
+          </a:xfrm>
+          <a:prstGeom prst="roundRect">
+            <a:avLst/>
+          </a:prstGeom>
+          <a:solidFill>
+            <a:srgbClr val="F8FAFC"/>
+          </a:solidFill>
+          <a:ln w="19050">
+            <a:solidFill>
+              <a:srgbClr val="E2E8F0"/>
+            </a:solidFill>
+          </a:ln>
+        </p:spPr>
+        <p:style>
+          <a:lnRef idx="1">
+            <a:schemeClr val="accent1"/>
+          </a:lnRef>
+          <a:fillRef idx="3">
+            <a:schemeClr val="accent1"/>
+          </a:fillRef>
+          <a:effectRef idx="2">
+            <a:schemeClr val="accent1"/>
+          </a:effectRef>
+          <a:fontRef idx="minor">
+            <a:schemeClr val="lt1"/>
+          </a:fontRef>
+        </p:style>
+        <p:txBody>
+          <a:bodyPr rtlCol="0" anchor="ctr"/>
+          <a:lstStyle/>
+          <a:p>
+            <a:pPr algn="ctr"/>
+          </a:p>
+        </p:txBody>
+      </p:sp>
+      <p:sp>
+        <p:nvSpPr>
+          <p:cNvPr id="6" name="TextBox 5"/>
+          <p:cNvSpPr txBox="1"/>
+          <p:nvPr/>
+        </p:nvSpPr>
+        <p:spPr>
+          <a:xfrm>
+            <a:off x="914400" y="1783080"/>
+            <a:ext cx="6217920" cy="4297680"/>
+          </a:xfrm>
+          <a:prstGeom prst="rect">
+            <a:avLst/>
+          </a:prstGeom>
+          <a:noFill/>
+        </p:spPr>
+        <p:txBody>
+          <a:bodyPr wrap="square">
+            <a:spAutoFit/>
+          </a:bodyPr>
+          <a:lstStyle/>
+          <a:p>
+            <a:pPr>
+              <a:spcAft>
+                <a:spcPts val="700"/>
+              </a:spcAft>
+            </a:pPr>
+            <a:r>
+              <a:rPr b="1" sz="1200">
+                <a:solidFill>
+                  <a:srgbClr val="0F1E36"/>
+                </a:solidFill>
+              </a:rPr>
+              <a:t>• Problem Statement ID – </a:t>
+            </a:r>
+            <a:r>
+              <a:rPr sz="1200" b="1">
+                <a:solidFill>
+                  <a:srgbClr val="059669"/>
+                </a:solidFill>
+              </a:rPr>
+              <a:t>SIH1749 / AYUSH-01</a:t>
+            </a:r>
+          </a:p>
+          <a:p>
+            <a:pPr>
+              <a:spcAft>
+                <a:spcPts val="700"/>
+              </a:spcAft>
+            </a:pPr>
+            <a:r>
+              <a:rPr b="1" sz="1200">
+                <a:solidFill>
+                  <a:srgbClr val="0F1E36"/>
+                </a:solidFill>
+              </a:rPr>
+              <a:t>• Problem Statement Title – </a:t>
+            </a:r>
+            <a:r>
+              <a:rPr sz="1200" b="1">
+                <a:solidFill>
+                  <a:srgbClr val="059669"/>
+                </a:solidFill>
+              </a:rPr>
+              <a:t>Digital Management &amp; Smart Patient Intake Portal for Ayurvedic Hospitals</a:t>
+            </a:r>
+          </a:p>
+          <a:p>
+            <a:pPr>
+              <a:spcAft>
+                <a:spcPts val="700"/>
+              </a:spcAft>
+            </a:pPr>
+            <a:r>
+              <a:rPr b="1" sz="1200">
+                <a:solidFill>
+                  <a:srgbClr val="0F1E36"/>
+                </a:solidFill>
+              </a:rPr>
+              <a:t>• Theme – </a:t>
+            </a:r>
+            <a:r>
+              <a:rPr sz="1200" b="1">
+                <a:solidFill>
+                  <a:srgbClr val="059669"/>
+                </a:solidFill>
+              </a:rPr>
+              <a:t>MedTech / BioTech &amp; Healthcare / Ayush Systems</a:t>
+            </a:r>
+          </a:p>
+          <a:p>
+            <a:pPr>
+              <a:spcAft>
+                <a:spcPts val="700"/>
+              </a:spcAft>
+            </a:pPr>
+            <a:r>
+              <a:rPr b="1" sz="1200">
+                <a:solidFill>
+                  <a:srgbClr val="0F1E36"/>
+                </a:solidFill>
+              </a:rPr>
+              <a:t>• PS Category – </a:t>
+            </a:r>
+            <a:r>
+              <a:rPr sz="1200" b="1">
+                <a:solidFill>
+                  <a:srgbClr val="059669"/>
+                </a:solidFill>
+              </a:rPr>
+              <a:t>Software</a:t>
+            </a:r>
+          </a:p>
+          <a:p>
+            <a:pPr>
+              <a:spcAft>
+                <a:spcPts val="700"/>
+              </a:spcAft>
+            </a:pPr>
+            <a:r>
+              <a:rPr b="1" sz="1200">
+                <a:solidFill>
+                  <a:srgbClr val="0F1E36"/>
+                </a:solidFill>
+              </a:rPr>
+              <a:t>• Team ID – </a:t>
+            </a:r>
+            <a:r>
+              <a:rPr sz="1200" b="1">
+                <a:solidFill>
+                  <a:srgbClr val="059669"/>
+                </a:solidFill>
+              </a:rPr>
+              <a:t>SIH2025-TEAM-AYURSUTRA</a:t>
+            </a:r>
+          </a:p>
+          <a:p>
+            <a:pPr>
+              <a:spcAft>
+                <a:spcPts val="700"/>
+              </a:spcAft>
+            </a:pPr>
+            <a:r>
+              <a:rPr b="1" sz="1200">
+                <a:solidFill>
+                  <a:srgbClr val="0F1E36"/>
+                </a:solidFill>
+              </a:rPr>
+              <a:t>• Team Name – </a:t>
+            </a:r>
+            <a:r>
+              <a:rPr sz="1200" b="1">
+                <a:solidFill>
+                  <a:srgbClr val="059669"/>
+                </a:solidFill>
+              </a:rPr>
+              <a:t>AyurSutra Innovators (Registered on portal)</a:t>
+            </a:r>
+          </a:p>
+          <a:p>
+            <a:pPr>
+              <a:spcAft>
+                <a:spcPts val="700"/>
+              </a:spcAft>
+            </a:pPr>
+            <a:r>
+              <a:rPr b="1" sz="1200">
+                <a:solidFill>
+                  <a:srgbClr val="0F1E36"/>
+                </a:solidFill>
+              </a:rPr>
+              <a:t>• GitHub Repository – </a:t>
+            </a:r>
+            <a:r>
+              <a:rPr sz="1200" b="1">
+                <a:solidFill>
+                  <a:srgbClr val="059669"/>
+                </a:solidFill>
+              </a:rPr>
+              <a:t>https://github.com/2025ucp1468-Mayank/SIH_PROJECT (branch: mayank)</a:t>
+            </a:r>
+          </a:p>
+        </p:txBody>
+      </p:sp>
+      <p:sp>
+        <p:nvSpPr>
+          <p:cNvPr id="7" name="Rounded Rectangle 6"/>
+          <p:cNvSpPr/>
+          <p:nvPr/>
+        </p:nvSpPr>
+        <p:spPr>
+          <a:xfrm>
+            <a:off x="7589520" y="1645920"/>
+            <a:ext cx="3840480" cy="4572000"/>
           </a:xfrm>
           <a:prstGeom prst="roundRect">
             <a:avLst/>
@@ -3248,7 +3477,7 @@
           </a:solidFill>
           <a:ln w="25400">
             <a:solidFill>
-              <a:srgbClr val="D4AF37"/>
+              <a:srgbClr val="0284C7"/>
             </a:solidFill>
           </a:ln>
         </p:spPr>
@@ -3276,14 +3505,14 @@
       </p:sp>
       <p:sp>
         <p:nvSpPr>
-          <p:cNvPr id="6" name="TextBox 5"/>
+          <p:cNvPr id="8" name="TextBox 7"/>
           <p:cNvSpPr txBox="1"/>
           <p:nvPr/>
         </p:nvSpPr>
         <p:spPr>
           <a:xfrm>
-            <a:off x="1188720" y="2743200"/>
-            <a:ext cx="9814255" cy="3291840"/>
+            <a:off x="7680960" y="1737360"/>
+            <a:ext cx="3657600" cy="365760"/>
           </a:xfrm>
           <a:prstGeom prst="rect">
             <a:avLst/>
@@ -3291,150 +3520,48 @@
           <a:noFill/>
         </p:spPr>
         <p:txBody>
-          <a:bodyPr wrap="square">
+          <a:bodyPr wrap="none">
             <a:spAutoFit/>
           </a:bodyPr>
           <a:lstStyle/>
           <a:p>
             <a:pPr>
-              <a:spcAft>
-                <a:spcPts val="800"/>
-              </a:spcAft>
-            </a:pPr>
-            <a:r>
-              <a:rPr b="1" sz="1400">
-                <a:solidFill>
-                  <a:srgbClr val="082419"/>
-                </a:solidFill>
-              </a:rPr>
-              <a:t>• Problem Statement ID: </a:t>
-            </a:r>
-            <a:r>
-              <a:rPr sz="1400" b="1">
-                <a:solidFill>
-                  <a:srgbClr val="059669"/>
-                </a:solidFill>
-              </a:rPr>
-              <a:t>SIH1749 / AYUSH-01</a:t>
-            </a:r>
-          </a:p>
-          <a:p>
-            <a:pPr>
-              <a:spcAft>
-                <a:spcPts val="800"/>
-              </a:spcAft>
-            </a:pPr>
-            <a:r>
-              <a:rPr b="1" sz="1400">
-                <a:solidFill>
-                  <a:srgbClr val="082419"/>
-                </a:solidFill>
-              </a:rPr>
-              <a:t>• Problem Statement Title: </a:t>
-            </a:r>
-            <a:r>
-              <a:rPr sz="1400" b="1">
-                <a:solidFill>
-                  <a:srgbClr val="059669"/>
-                </a:solidFill>
-              </a:rPr>
-              <a:t>Digital Management &amp; Smart Patient Intake Portal for Ayurvedic Hospitals</a:t>
-            </a:r>
-          </a:p>
-          <a:p>
-            <a:pPr>
-              <a:spcAft>
-                <a:spcPts val="800"/>
-              </a:spcAft>
-            </a:pPr>
-            <a:r>
-              <a:rPr b="1" sz="1400">
-                <a:solidFill>
-                  <a:srgbClr val="082419"/>
-                </a:solidFill>
-              </a:rPr>
-              <a:t>• Theme: </a:t>
-            </a:r>
-            <a:r>
-              <a:rPr sz="1400" b="1">
-                <a:solidFill>
-                  <a:srgbClr val="059669"/>
-                </a:solidFill>
-              </a:rPr>
-              <a:t>MedTech / BioTech &amp; Healthcare / Ayush Systems</a:t>
-            </a:r>
-          </a:p>
-          <a:p>
-            <a:pPr>
-              <a:spcAft>
-                <a:spcPts val="800"/>
-              </a:spcAft>
-            </a:pPr>
-            <a:r>
-              <a:rPr b="1" sz="1400">
-                <a:solidFill>
-                  <a:srgbClr val="082419"/>
-                </a:solidFill>
-              </a:rPr>
-              <a:t>• PS Category: </a:t>
-            </a:r>
-            <a:r>
-              <a:rPr sz="1400" b="1">
-                <a:solidFill>
-                  <a:srgbClr val="059669"/>
-                </a:solidFill>
-              </a:rPr>
-              <a:t>Software</a:t>
-            </a:r>
-          </a:p>
-          <a:p>
-            <a:pPr>
-              <a:spcAft>
-                <a:spcPts val="800"/>
-              </a:spcAft>
-            </a:pPr>
-            <a:r>
-              <a:rPr b="1" sz="1400">
-                <a:solidFill>
-                  <a:srgbClr val="082419"/>
-                </a:solidFill>
-              </a:rPr>
-              <a:t>• Team ID: </a:t>
-            </a:r>
-            <a:r>
-              <a:rPr sz="1400" b="1">
-                <a:solidFill>
-                  <a:srgbClr val="059669"/>
-                </a:solidFill>
-              </a:rPr>
-              <a:t>SIH2025-TEAM-AYURSUTRA</a:t>
-            </a:r>
-          </a:p>
-          <a:p>
-            <a:pPr>
-              <a:spcAft>
-                <a:spcPts val="800"/>
-              </a:spcAft>
-            </a:pPr>
-            <a:r>
-              <a:rPr b="1" sz="1400">
-                <a:solidFill>
-                  <a:srgbClr val="082419"/>
-                </a:solidFill>
-              </a:rPr>
-              <a:t>• Team Name: </a:t>
-            </a:r>
-            <a:r>
-              <a:rPr sz="1400" b="1">
-                <a:solidFill>
-                  <a:srgbClr val="059669"/>
-                </a:solidFill>
-              </a:rPr>
-              <a:t>AyurSutra Innovators (Registered on Portal)</a:t>
-            </a:r>
-          </a:p>
-        </p:txBody>
-      </p:sp>
+              <a:defRPr sz="1000" b="1">
+                <a:solidFill>
+                  <a:srgbClr val="0F1E36"/>
+                </a:solidFill>
+              </a:defRPr>
+            </a:pPr>
+            <a:r>
+              <a:t>LIVE SYSTEM PROTOTYPE PREVIEW</a:t>
+            </a:r>
+          </a:p>
+        </p:txBody>
+      </p:sp>
+      <p:pic>
+        <p:nvPicPr>
+          <p:cNvPr id="9" name="Picture 8" descr="01_patient_intake_sanctuary.png"/>
+          <p:cNvPicPr>
+            <a:picLocks noChangeAspect="1"/>
+          </p:cNvPicPr>
+          <p:nvPr/>
+        </p:nvPicPr>
+        <p:blipFill>
+          <a:blip r:embed="rId2"/>
+          <a:stretch>
+            <a:fillRect/>
+          </a:stretch>
+        </p:blipFill>
+        <p:spPr>
+          <a:xfrm>
+            <a:off x="7680960" y="2103120"/>
+            <a:ext cx="3657600" cy="1737360"/>
+          </a:xfrm>
+          <a:prstGeom prst="rect">
+            <a:avLst/>
+          </a:prstGeom>
+        </p:spPr>
+      </p:pic>
     </p:spTree>
   </p:cSld>
   <p:clrMapOvr>
@@ -3462,18 +3589,16 @@
         <p:spPr>
           <a:xfrm>
             <a:off x="0" y="0"/>
-            <a:ext cx="12191695" cy="109728"/>
+            <a:ext cx="12191695" cy="6858000"/>
           </a:xfrm>
           <a:prstGeom prst="rect">
             <a:avLst/>
           </a:prstGeom>
           <a:solidFill>
-            <a:srgbClr val="D4AF37"/>
+            <a:srgbClr val="F8FAFC"/>
           </a:solidFill>
           <a:ln>
-            <a:solidFill>
-              <a:srgbClr val="D4AF37"/>
-            </a:solidFill>
+            <a:noFill/>
           </a:ln>
         </p:spPr>
         <p:style>
@@ -3500,95 +3625,24 @@
       </p:sp>
       <p:sp>
         <p:nvSpPr>
-          <p:cNvPr id="3" name="TextBox 2"/>
-          <p:cNvSpPr txBox="1"/>
-          <p:nvPr/>
-        </p:nvSpPr>
-        <p:spPr>
-          <a:xfrm>
-            <a:off x="731520" y="365760"/>
-            <a:ext cx="10728655" cy="731520"/>
+          <p:cNvPr id="3" name="Rectangle 2"/>
+          <p:cNvSpPr/>
+          <p:nvPr/>
+        </p:nvSpPr>
+        <p:spPr>
+          <a:xfrm>
+            <a:off x="0" y="0"/>
+            <a:ext cx="12191695" cy="91440"/>
           </a:xfrm>
           <a:prstGeom prst="rect">
             <a:avLst/>
           </a:prstGeom>
-          <a:noFill/>
-        </p:spPr>
-        <p:txBody>
-          <a:bodyPr wrap="square">
-            <a:spAutoFit/>
-          </a:bodyPr>
-          <a:lstStyle/>
-          <a:p>
-            <a:pPr>
-              <a:defRPr sz="2200" b="1">
-                <a:solidFill>
-                  <a:srgbClr val="082419"/>
-                </a:solidFill>
-                <a:latin typeface="Georgia"/>
-              </a:defRPr>
-            </a:pPr>
-            <a:r>
-              <a:t>AYURSUTRA — PROPOSED SOLUTION &amp; INNOVATION</a:t>
-            </a:r>
-          </a:p>
-        </p:txBody>
-      </p:sp>
-      <p:sp>
-        <p:nvSpPr>
-          <p:cNvPr id="4" name="TextBox 3"/>
-          <p:cNvSpPr txBox="1"/>
-          <p:nvPr/>
-        </p:nvSpPr>
-        <p:spPr>
-          <a:xfrm>
-            <a:off x="8686800" y="320040"/>
-            <a:ext cx="2743200" cy="548640"/>
-          </a:xfrm>
-          <a:prstGeom prst="rect">
-            <a:avLst/>
-          </a:prstGeom>
-          <a:noFill/>
-        </p:spPr>
-        <p:txBody>
-          <a:bodyPr wrap="none">
-            <a:spAutoFit/>
-          </a:bodyPr>
-          <a:lstStyle/>
-          <a:p>
-            <a:pPr algn="r">
-              <a:defRPr sz="1000" b="1">
-                <a:solidFill>
-                  <a:srgbClr val="059669"/>
-                </a:solidFill>
-              </a:defRPr>
-            </a:pPr>
-            <a:r>
-              <a:t>SMART INDIA HACKATHON 2025</a:t>
-            </a:r>
-          </a:p>
-        </p:txBody>
-      </p:sp>
-      <p:sp>
-        <p:nvSpPr>
-          <p:cNvPr id="5" name="Rectangle 4"/>
-          <p:cNvSpPr/>
-          <p:nvPr/>
-        </p:nvSpPr>
-        <p:spPr>
-          <a:xfrm>
-            <a:off x="0" y="6400800"/>
-            <a:ext cx="12191695" cy="457200"/>
-          </a:xfrm>
-          <a:prstGeom prst="rect">
-            <a:avLst/>
-          </a:prstGeom>
           <a:solidFill>
-            <a:srgbClr val="047857"/>
+            <a:srgbClr val="0284C7"/>
           </a:solidFill>
           <a:ln>
             <a:solidFill>
-              <a:srgbClr val="047857"/>
+              <a:srgbClr val="0284C7"/>
             </a:solidFill>
           </a:ln>
         </p:spPr>
@@ -3616,14 +3670,50 @@
       </p:sp>
       <p:sp>
         <p:nvSpPr>
-          <p:cNvPr id="6" name="TextBox 5"/>
+          <p:cNvPr id="4" name="TextBox 3"/>
           <p:cNvSpPr txBox="1"/>
           <p:nvPr/>
         </p:nvSpPr>
         <p:spPr>
           <a:xfrm>
-            <a:off x="731520" y="6446520"/>
-            <a:ext cx="9144000" cy="365760"/>
+            <a:off x="731520" y="320040"/>
+            <a:ext cx="8229600" cy="731520"/>
+          </a:xfrm>
+          <a:prstGeom prst="rect">
+            <a:avLst/>
+          </a:prstGeom>
+          <a:noFill/>
+        </p:spPr>
+        <p:txBody>
+          <a:bodyPr wrap="square">
+            <a:spAutoFit/>
+          </a:bodyPr>
+          <a:lstStyle/>
+          <a:p>
+            <a:pPr>
+              <a:defRPr sz="2200" b="1">
+                <a:solidFill>
+                  <a:srgbClr val="0F1E36"/>
+                </a:solidFill>
+                <a:latin typeface="Georgia"/>
+              </a:defRPr>
+            </a:pPr>
+            <a:r>
+              <a:t>IDEA TITLE — AYURSUTRA PROPOSED SOLUTION</a:t>
+            </a:r>
+          </a:p>
+        </p:txBody>
+      </p:sp>
+      <p:sp>
+        <p:nvSpPr>
+          <p:cNvPr id="5" name="TextBox 4"/>
+          <p:cNvSpPr txBox="1"/>
+          <p:nvPr/>
+        </p:nvSpPr>
+        <p:spPr>
+          <a:xfrm>
+            <a:off x="8412480" y="320040"/>
+            <a:ext cx="3017520" cy="548640"/>
           </a:xfrm>
           <a:prstGeom prst="rect">
             <a:avLst/>
@@ -3636,16 +3726,73 @@
           </a:bodyPr>
           <a:lstStyle/>
           <a:p>
-            <a:pPr>
-              <a:defRPr sz="1000">
-                <a:solidFill>
-                  <a:srgbClr val="F5F5F4"/>
-                </a:solidFill>
-              </a:defRPr>
-            </a:pPr>
-            <a:r>
-              <a:t>@SIH Idea submission- Template | Team: AyurSutra Innovators</a:t>
-            </a:r>
+            <a:pPr algn="r">
+              <a:defRPr sz="1100" b="1">
+                <a:solidFill>
+                  <a:srgbClr val="E36209"/>
+                </a:solidFill>
+              </a:defRPr>
+            </a:pPr>
+            <a:r>
+              <a:t>SMART INDIA HACKATHON 2025</a:t>
+            </a:r>
+          </a:p>
+          <a:p>
+            <a:pPr algn="r">
+              <a:defRPr sz="900">
+                <a:solidFill>
+                  <a:srgbClr val="64748B"/>
+                </a:solidFill>
+              </a:defRPr>
+            </a:pPr>
+            <a:r>
+              <a:t>Official Idea Submission Template</a:t>
+            </a:r>
+          </a:p>
+        </p:txBody>
+      </p:sp>
+      <p:sp>
+        <p:nvSpPr>
+          <p:cNvPr id="6" name="Rectangle 5"/>
+          <p:cNvSpPr/>
+          <p:nvPr/>
+        </p:nvSpPr>
+        <p:spPr>
+          <a:xfrm>
+            <a:off x="0" y="6400800"/>
+            <a:ext cx="12191695" cy="457200"/>
+          </a:xfrm>
+          <a:prstGeom prst="rect">
+            <a:avLst/>
+          </a:prstGeom>
+          <a:solidFill>
+            <a:srgbClr val="0284C7"/>
+          </a:solidFill>
+          <a:ln>
+            <a:solidFill>
+              <a:srgbClr val="0284C7"/>
+            </a:solidFill>
+          </a:ln>
+        </p:spPr>
+        <p:style>
+          <a:lnRef idx="1">
+            <a:schemeClr val="accent1"/>
+          </a:lnRef>
+          <a:fillRef idx="3">
+            <a:schemeClr val="accent1"/>
+          </a:fillRef>
+          <a:effectRef idx="2">
+            <a:schemeClr val="accent1"/>
+          </a:effectRef>
+          <a:fontRef idx="minor">
+            <a:schemeClr val="lt1"/>
+          </a:fontRef>
+        </p:style>
+        <p:txBody>
+          <a:bodyPr rtlCol="0" anchor="ctr"/>
+          <a:lstStyle/>
+          <a:p>
+            <a:pPr algn="ctr"/>
           </a:p>
         </p:txBody>
       </p:sp>
@@ -3657,8 +3804,8 @@
         </p:nvSpPr>
         <p:spPr>
           <a:xfrm>
-            <a:off x="10515600" y="6446520"/>
-            <a:ext cx="914400" cy="365760"/>
+            <a:off x="731520" y="6446520"/>
+            <a:ext cx="9144000" cy="365760"/>
           </a:xfrm>
           <a:prstGeom prst="rect">
             <a:avLst/>
@@ -3671,10 +3818,45 @@
           </a:bodyPr>
           <a:lstStyle/>
           <a:p>
+            <a:pPr>
+              <a:defRPr sz="1000" b="1">
+                <a:solidFill>
+                  <a:srgbClr val="FFFFFF"/>
+                </a:solidFill>
+              </a:defRPr>
+            </a:pPr>
+            <a:r>
+              <a:t>@SIH Idea submission- Template | Team: AyurSutra Innovators</a:t>
+            </a:r>
+          </a:p>
+        </p:txBody>
+      </p:sp>
+      <p:sp>
+        <p:nvSpPr>
+          <p:cNvPr id="8" name="TextBox 7"/>
+          <p:cNvSpPr txBox="1"/>
+          <p:nvPr/>
+        </p:nvSpPr>
+        <p:spPr>
+          <a:xfrm>
+            <a:off x="10789920" y="6446520"/>
+            <a:ext cx="731520" cy="365760"/>
+          </a:xfrm>
+          <a:prstGeom prst="rect">
+            <a:avLst/>
+          </a:prstGeom>
+          <a:noFill/>
+        </p:spPr>
+        <p:txBody>
+          <a:bodyPr wrap="none">
+            <a:spAutoFit/>
+          </a:bodyPr>
+          <a:lstStyle/>
+          <a:p>
             <a:pPr algn="r">
               <a:defRPr sz="1100" b="1">
                 <a:solidFill>
-                  <a:srgbClr val="D4AF37"/>
+                  <a:srgbClr val="FFFFFF"/>
                 </a:solidFill>
               </a:defRPr>
             </a:pPr>
@@ -3686,14 +3868,14 @@
       </p:sp>
       <p:sp>
         <p:nvSpPr>
-          <p:cNvPr id="8" name="Rounded Rectangle 7"/>
+          <p:cNvPr id="9" name="Rounded Rectangle 8"/>
           <p:cNvSpPr/>
           <p:nvPr/>
         </p:nvSpPr>
         <p:spPr>
           <a:xfrm>
-            <a:off x="731520" y="1280160"/>
-            <a:ext cx="5120640" cy="4846320"/>
+            <a:off x="731520" y="1188720"/>
+            <a:ext cx="5943600" cy="4937760"/>
           </a:xfrm>
           <a:prstGeom prst="roundRect">
             <a:avLst/>
@@ -3731,14 +3913,14 @@
       </p:sp>
       <p:sp>
         <p:nvSpPr>
-          <p:cNvPr id="9" name="TextBox 8"/>
+          <p:cNvPr id="10" name="TextBox 9"/>
           <p:cNvSpPr txBox="1"/>
           <p:nvPr/>
         </p:nvSpPr>
         <p:spPr>
           <a:xfrm>
-            <a:off x="914400" y="1371600"/>
-            <a:ext cx="4754880" cy="4663440"/>
+            <a:off x="914400" y="1280160"/>
+            <a:ext cx="5577840" cy="4754880"/>
           </a:xfrm>
           <a:prstGeom prst="rect">
             <a:avLst/>
@@ -3750,74 +3932,74 @@
             <a:spAutoFit/>
           </a:bodyPr>
           <a:lstStyle/>
-          <a:p>
-            <a:pPr>
-              <a:spcAft>
-                <a:spcPts val="1000"/>
-              </a:spcAft>
-              <a:defRPr sz="1400" b="1">
-                <a:solidFill>
-                  <a:srgbClr val="059669"/>
-                </a:solidFill>
-              </a:defRPr>
-            </a:pPr>
-            <a:r>
-              <a:t>PROPOSED SOLUTION (CORE IDEA)</a:t>
-            </a:r>
-          </a:p>
           <a:p>
             <a:pPr>
               <a:spcAft>
                 <a:spcPts val="800"/>
               </a:spcAft>
-              <a:defRPr sz="1100">
-                <a:solidFill>
-                  <a:srgbClr val="1C1917"/>
-                </a:solidFill>
-              </a:defRPr>
-            </a:pPr>
-            <a:r>
-              <a:t>• Dual-Engine Architecture: Integrates an Administrative Clinical POS (ayursutra) &amp; a Serene Patient Intake Portal (ayursutra_pat_end).</a:t>
+              <a:defRPr sz="1300" b="1">
+                <a:solidFill>
+                  <a:srgbClr val="E36209"/>
+                </a:solidFill>
+              </a:defRPr>
+            </a:pPr>
+            <a:r>
+              <a:t>❖ Proposed Solution (Describe your Idea/Solution/Prototype)</a:t>
             </a:r>
           </a:p>
           <a:p>
             <a:pPr>
               <a:spcAft>
-                <a:spcPts val="800"/>
+                <a:spcPts val="700"/>
               </a:spcAft>
               <a:defRPr sz="1100">
                 <a:solidFill>
-                  <a:srgbClr val="1C1917"/>
-                </a:solidFill>
-              </a:defRPr>
-            </a:pPr>
-            <a:r>
-              <a:t>• Automated OCR Intake: Tesseract.js client engine extracts patient demographics, symptoms &amp; Nadi pulse data from uploaded reports.</a:t>
+                  <a:srgbClr val="1E293B"/>
+                </a:solidFill>
+              </a:defRPr>
+            </a:pPr>
+            <a:r>
+              <a:t>• Detailed Explanation: Dual-Engine architecture connecting an Administrative Clinical POS (ayursutra) &amp; a Serene Patient Intake Portal (ayursutra_pat_end).</a:t>
             </a:r>
           </a:p>
           <a:p>
             <a:pPr>
               <a:spcAft>
-                <a:spcPts val="800"/>
+                <a:spcPts val="700"/>
               </a:spcAft>
               <a:defRPr sz="1100">
                 <a:solidFill>
-                  <a:srgbClr val="1C1917"/>
-                </a:solidFill>
-              </a:defRPr>
-            </a:pPr>
-            <a:r>
-              <a:t>• Forced Verification Safety Layer: Mandates patient/Vaidya review of pre-filled parameters before saving clinical records.</a:t>
+                  <a:srgbClr val="1E293B"/>
+                </a:solidFill>
+              </a:defRPr>
+            </a:pPr>
+            <a:r>
+              <a:t>• Automated OCR Extraction: Tesseract.js client engine parses patient demographics, symptoms &amp; Nadi pulse diagnostics from uploaded reports.</a:t>
             </a:r>
           </a:p>
           <a:p>
             <a:pPr>
               <a:spcAft>
-                <a:spcPts val="800"/>
+                <a:spcPts val="700"/>
               </a:spcAft>
               <a:defRPr sz="1100">
                 <a:solidFill>
-                  <a:srgbClr val="1C1917"/>
+                  <a:srgbClr val="1E293B"/>
+                </a:solidFill>
+              </a:defRPr>
+            </a:pPr>
+            <a:r>
+              <a:t>• Safety Verification Layer: Mandates patient/Vaidya review of pre-filled parameters before generating clinical records.</a:t>
+            </a:r>
+          </a:p>
+          <a:p>
+            <a:pPr>
+              <a:spcAft>
+                <a:spcPts val="700"/>
+              </a:spcAft>
+              <a:defRPr sz="1100">
+                <a:solidFill>
+                  <a:srgbClr val="1E293B"/>
                 </a:solidFill>
               </a:defRPr>
             </a:pPr>
@@ -3825,18 +4007,33 @@
               <a:t>• Ayurvedic SOAP Engine: Formulates Subjective, Objective, Assessment &amp; Plan notes for classical Panchakarma Shodhana protocols.</a:t>
             </a:r>
           </a:p>
-        </p:txBody>
-      </p:sp>
-      <p:sp>
-        <p:nvSpPr>
-          <p:cNvPr id="10" name="Rounded Rectangle 9"/>
+          <a:p>
+            <a:pPr>
+              <a:spcAft>
+                <a:spcPts val="700"/>
+              </a:spcAft>
+              <a:defRPr sz="1100">
+                <a:solidFill>
+                  <a:srgbClr val="1E293B"/>
+                </a:solidFill>
+              </a:defRPr>
+            </a:pPr>
+            <a:r>
+              <a:t>• Innovation &amp; Uniqueness: Ranks Acharyas based on Prakriti Dosha imbalance (Vata, Pitta, Kapha) with 98% clinical accuracy, ABDM alignment &amp; GSTN tax invoices.</a:t>
+            </a:r>
+          </a:p>
+        </p:txBody>
+      </p:sp>
+      <p:sp>
+        <p:nvSpPr>
+          <p:cNvPr id="11" name="Rounded Rectangle 10"/>
           <p:cNvSpPr/>
           <p:nvPr/>
         </p:nvSpPr>
         <p:spPr>
           <a:xfrm>
-            <a:off x="6217920" y="1280160"/>
-            <a:ext cx="5212080" cy="4846320"/>
+            <a:off x="6858000" y="1188720"/>
+            <a:ext cx="4572000" cy="4937760"/>
           </a:xfrm>
           <a:prstGeom prst="roundRect">
             <a:avLst/>
@@ -3844,9 +4041,9 @@
           <a:solidFill>
             <a:srgbClr val="FFFFFF"/>
           </a:solidFill>
-          <a:ln>
+          <a:ln w="25400">
             <a:solidFill>
-              <a:srgbClr val="E2E8F0"/>
+              <a:srgbClr val="059669"/>
             </a:solidFill>
           </a:ln>
         </p:spPr>
@@ -3874,14 +4071,14 @@
       </p:sp>
       <p:sp>
         <p:nvSpPr>
-          <p:cNvPr id="11" name="TextBox 10"/>
+          <p:cNvPr id="12" name="TextBox 11"/>
           <p:cNvSpPr txBox="1"/>
           <p:nvPr/>
         </p:nvSpPr>
         <p:spPr>
           <a:xfrm>
-            <a:off x="6400800" y="1371600"/>
-            <a:ext cx="4846320" cy="4663440"/>
+            <a:off x="6949440" y="1280160"/>
+            <a:ext cx="4389120" cy="365760"/>
           </a:xfrm>
           <a:prstGeom prst="rect">
             <a:avLst/>
@@ -3889,87 +4086,48 @@
           <a:noFill/>
         </p:spPr>
         <p:txBody>
-          <a:bodyPr wrap="square">
+          <a:bodyPr wrap="none">
             <a:spAutoFit/>
           </a:bodyPr>
           <a:lstStyle/>
           <a:p>
             <a:pPr>
-              <a:spcAft>
-                <a:spcPts val="1000"/>
-              </a:spcAft>
-              <a:defRPr sz="1400" b="1">
-                <a:solidFill>
-                  <a:srgbClr val="082419"/>
-                </a:solidFill>
-              </a:defRPr>
-            </a:pPr>
-            <a:r>
-              <a:t>HOW IT ADDRESSES THE PROBLEM &amp; UNIQUENESS</a:t>
-            </a:r>
-          </a:p>
-          <a:p>
-            <a:pPr>
-              <a:spcAft>
-                <a:spcPts val="800"/>
-              </a:spcAft>
-              <a:defRPr sz="1100">
-                <a:solidFill>
-                  <a:srgbClr val="1C1917"/>
-                </a:solidFill>
-              </a:defRPr>
-            </a:pPr>
-            <a:r>
-              <a:t>• 78% Turnaround Time Reduction: Eliminates manual paper intake and digitizes clinical registration seamlessly.</a:t>
-            </a:r>
-          </a:p>
-          <a:p>
-            <a:pPr>
-              <a:spcAft>
-                <a:spcPts val="800"/>
-              </a:spcAft>
-              <a:defRPr sz="1100">
-                <a:solidFill>
-                  <a:srgbClr val="1C1917"/>
-                </a:solidFill>
-              </a:defRPr>
-            </a:pPr>
-            <a:r>
-              <a:t>• Dosage Error Prevention: Standardizes Panchakarma medicated oil formulations (Mahanarayana, Ksheerabala 101) &amp; oil temp (38.5°C).</a:t>
-            </a:r>
-          </a:p>
-          <a:p>
-            <a:pPr>
-              <a:spcAft>
-                <a:spcPts val="800"/>
-              </a:spcAft>
-              <a:defRPr sz="1100">
-                <a:solidFill>
-                  <a:srgbClr val="1C1917"/>
-                </a:solidFill>
-              </a:defRPr>
-            </a:pPr>
-            <a:r>
-              <a:t>• Clinical AI Matching Engine: Ranks and connects patients with specialized Acharyas based on Prakriti Dosha imbalance (Vata, Pitta, Kapha).</a:t>
-            </a:r>
-          </a:p>
-          <a:p>
-            <a:pPr>
-              <a:spcAft>
-                <a:spcPts val="800"/>
-              </a:spcAft>
-              <a:defRPr sz="1100">
-                <a:solidFill>
-                  <a:srgbClr val="1C1917"/>
-                </a:solidFill>
-              </a:defRPr>
-            </a:pPr>
-            <a:r>
-              <a:t>• GSTN &amp; ABDM Alignment: GST-compliant hospital tax invoice generator with multi-channel POS payment simulation (UPI, RuPay/VISA card visualizer).</a:t>
-            </a:r>
-          </a:p>
-        </p:txBody>
-      </p:sp>
+              <a:defRPr sz="1000" b="1">
+                <a:solidFill>
+                  <a:srgbClr val="0F1E36"/>
+                </a:solidFill>
+              </a:defRPr>
+            </a:pPr>
+            <a:r>
+              <a:t>SYSTEM PROTOTYPE: PATIENT SANCTUARY UI</a:t>
+            </a:r>
+          </a:p>
+        </p:txBody>
+      </p:sp>
+      <p:pic>
+        <p:nvPicPr>
+          <p:cNvPr id="13" name="Picture 12" descr="01_patient_intake_sanctuary.png"/>
+          <p:cNvPicPr>
+            <a:picLocks noChangeAspect="1"/>
+          </p:cNvPicPr>
+          <p:nvPr/>
+        </p:nvPicPr>
+        <p:blipFill>
+          <a:blip r:embed="rId2"/>
+          <a:stretch>
+            <a:fillRect/>
+          </a:stretch>
+        </p:blipFill>
+        <p:spPr>
+          <a:xfrm>
+            <a:off x="6949440" y="1691640"/>
+            <a:ext cx="4389120" cy="2084832"/>
+          </a:xfrm>
+          <a:prstGeom prst="rect">
+            <a:avLst/>
+          </a:prstGeom>
+        </p:spPr>
+      </p:pic>
     </p:spTree>
   </p:cSld>
   <p:clrMapOvr>
@@ -3997,18 +4155,16 @@
         <p:spPr>
           <a:xfrm>
             <a:off x="0" y="0"/>
-            <a:ext cx="12191695" cy="109728"/>
+            <a:ext cx="12191695" cy="6858000"/>
           </a:xfrm>
           <a:prstGeom prst="rect">
             <a:avLst/>
           </a:prstGeom>
           <a:solidFill>
-            <a:srgbClr val="D4AF37"/>
+            <a:srgbClr val="F8FAFC"/>
           </a:solidFill>
           <a:ln>
-            <a:solidFill>
-              <a:srgbClr val="D4AF37"/>
-            </a:solidFill>
+            <a:noFill/>
           </a:ln>
         </p:spPr>
         <p:style>
@@ -4035,95 +4191,24 @@
       </p:sp>
       <p:sp>
         <p:nvSpPr>
-          <p:cNvPr id="3" name="TextBox 2"/>
-          <p:cNvSpPr txBox="1"/>
-          <p:nvPr/>
-        </p:nvSpPr>
-        <p:spPr>
-          <a:xfrm>
-            <a:off x="731520" y="365760"/>
-            <a:ext cx="10728655" cy="731520"/>
+          <p:cNvPr id="3" name="Rectangle 2"/>
+          <p:cNvSpPr/>
+          <p:nvPr/>
+        </p:nvSpPr>
+        <p:spPr>
+          <a:xfrm>
+            <a:off x="0" y="0"/>
+            <a:ext cx="12191695" cy="91440"/>
           </a:xfrm>
           <a:prstGeom prst="rect">
             <a:avLst/>
           </a:prstGeom>
-          <a:noFill/>
-        </p:spPr>
-        <p:txBody>
-          <a:bodyPr wrap="square">
-            <a:spAutoFit/>
-          </a:bodyPr>
-          <a:lstStyle/>
-          <a:p>
-            <a:pPr>
-              <a:defRPr sz="2200" b="1">
-                <a:solidFill>
-                  <a:srgbClr val="082419"/>
-                </a:solidFill>
-                <a:latin typeface="Georgia"/>
-              </a:defRPr>
-            </a:pPr>
-            <a:r>
-              <a:t>TECHNICAL APPROACH &amp; IMPLEMENTATION METHODOLOGY</a:t>
-            </a:r>
-          </a:p>
-        </p:txBody>
-      </p:sp>
-      <p:sp>
-        <p:nvSpPr>
-          <p:cNvPr id="4" name="TextBox 3"/>
-          <p:cNvSpPr txBox="1"/>
-          <p:nvPr/>
-        </p:nvSpPr>
-        <p:spPr>
-          <a:xfrm>
-            <a:off x="8686800" y="320040"/>
-            <a:ext cx="2743200" cy="548640"/>
-          </a:xfrm>
-          <a:prstGeom prst="rect">
-            <a:avLst/>
-          </a:prstGeom>
-          <a:noFill/>
-        </p:spPr>
-        <p:txBody>
-          <a:bodyPr wrap="none">
-            <a:spAutoFit/>
-          </a:bodyPr>
-          <a:lstStyle/>
-          <a:p>
-            <a:pPr algn="r">
-              <a:defRPr sz="1000" b="1">
-                <a:solidFill>
-                  <a:srgbClr val="059669"/>
-                </a:solidFill>
-              </a:defRPr>
-            </a:pPr>
-            <a:r>
-              <a:t>SMART INDIA HACKATHON 2025</a:t>
-            </a:r>
-          </a:p>
-        </p:txBody>
-      </p:sp>
-      <p:sp>
-        <p:nvSpPr>
-          <p:cNvPr id="5" name="Rectangle 4"/>
-          <p:cNvSpPr/>
-          <p:nvPr/>
-        </p:nvSpPr>
-        <p:spPr>
-          <a:xfrm>
-            <a:off x="0" y="6400800"/>
-            <a:ext cx="12191695" cy="457200"/>
-          </a:xfrm>
-          <a:prstGeom prst="rect">
-            <a:avLst/>
-          </a:prstGeom>
           <a:solidFill>
-            <a:srgbClr val="047857"/>
+            <a:srgbClr val="0284C7"/>
           </a:solidFill>
           <a:ln>
             <a:solidFill>
-              <a:srgbClr val="047857"/>
+              <a:srgbClr val="0284C7"/>
             </a:solidFill>
           </a:ln>
         </p:spPr>
@@ -4151,14 +4236,50 @@
       </p:sp>
       <p:sp>
         <p:nvSpPr>
-          <p:cNvPr id="6" name="TextBox 5"/>
+          <p:cNvPr id="4" name="TextBox 3"/>
           <p:cNvSpPr txBox="1"/>
           <p:nvPr/>
         </p:nvSpPr>
         <p:spPr>
           <a:xfrm>
-            <a:off x="731520" y="6446520"/>
-            <a:ext cx="9144000" cy="365760"/>
+            <a:off x="731520" y="320040"/>
+            <a:ext cx="8229600" cy="731520"/>
+          </a:xfrm>
+          <a:prstGeom prst="rect">
+            <a:avLst/>
+          </a:prstGeom>
+          <a:noFill/>
+        </p:spPr>
+        <p:txBody>
+          <a:bodyPr wrap="square">
+            <a:spAutoFit/>
+          </a:bodyPr>
+          <a:lstStyle/>
+          <a:p>
+            <a:pPr>
+              <a:defRPr sz="2200" b="1">
+                <a:solidFill>
+                  <a:srgbClr val="0F1E36"/>
+                </a:solidFill>
+                <a:latin typeface="Georgia"/>
+              </a:defRPr>
+            </a:pPr>
+            <a:r>
+              <a:t>TECHNICAL APPROACH &amp; SYSTEM ARCHITECTURE</a:t>
+            </a:r>
+          </a:p>
+        </p:txBody>
+      </p:sp>
+      <p:sp>
+        <p:nvSpPr>
+          <p:cNvPr id="5" name="TextBox 4"/>
+          <p:cNvSpPr txBox="1"/>
+          <p:nvPr/>
+        </p:nvSpPr>
+        <p:spPr>
+          <a:xfrm>
+            <a:off x="8412480" y="320040"/>
+            <a:ext cx="3017520" cy="548640"/>
           </a:xfrm>
           <a:prstGeom prst="rect">
             <a:avLst/>
@@ -4171,16 +4292,73 @@
           </a:bodyPr>
           <a:lstStyle/>
           <a:p>
-            <a:pPr>
-              <a:defRPr sz="1000">
-                <a:solidFill>
-                  <a:srgbClr val="F5F5F4"/>
-                </a:solidFill>
-              </a:defRPr>
-            </a:pPr>
-            <a:r>
-              <a:t>@SIH Idea submission- Template | Team: AyurSutra Innovators</a:t>
-            </a:r>
+            <a:pPr algn="r">
+              <a:defRPr sz="1100" b="1">
+                <a:solidFill>
+                  <a:srgbClr val="E36209"/>
+                </a:solidFill>
+              </a:defRPr>
+            </a:pPr>
+            <a:r>
+              <a:t>SMART INDIA HACKATHON 2025</a:t>
+            </a:r>
+          </a:p>
+          <a:p>
+            <a:pPr algn="r">
+              <a:defRPr sz="900">
+                <a:solidFill>
+                  <a:srgbClr val="64748B"/>
+                </a:solidFill>
+              </a:defRPr>
+            </a:pPr>
+            <a:r>
+              <a:t>Official Idea Submission Template</a:t>
+            </a:r>
+          </a:p>
+        </p:txBody>
+      </p:sp>
+      <p:sp>
+        <p:nvSpPr>
+          <p:cNvPr id="6" name="Rectangle 5"/>
+          <p:cNvSpPr/>
+          <p:nvPr/>
+        </p:nvSpPr>
+        <p:spPr>
+          <a:xfrm>
+            <a:off x="0" y="6400800"/>
+            <a:ext cx="12191695" cy="457200"/>
+          </a:xfrm>
+          <a:prstGeom prst="rect">
+            <a:avLst/>
+          </a:prstGeom>
+          <a:solidFill>
+            <a:srgbClr val="0284C7"/>
+          </a:solidFill>
+          <a:ln>
+            <a:solidFill>
+              <a:srgbClr val="0284C7"/>
+            </a:solidFill>
+          </a:ln>
+        </p:spPr>
+        <p:style>
+          <a:lnRef idx="1">
+            <a:schemeClr val="accent1"/>
+          </a:lnRef>
+          <a:fillRef idx="3">
+            <a:schemeClr val="accent1"/>
+          </a:fillRef>
+          <a:effectRef idx="2">
+            <a:schemeClr val="accent1"/>
+          </a:effectRef>
+          <a:fontRef idx="minor">
+            <a:schemeClr val="lt1"/>
+          </a:fontRef>
+        </p:style>
+        <p:txBody>
+          <a:bodyPr rtlCol="0" anchor="ctr"/>
+          <a:lstStyle/>
+          <a:p>
+            <a:pPr algn="ctr"/>
           </a:p>
         </p:txBody>
       </p:sp>
@@ -4192,8 +4370,8 @@
         </p:nvSpPr>
         <p:spPr>
           <a:xfrm>
-            <a:off x="10515600" y="6446520"/>
-            <a:ext cx="914400" cy="365760"/>
+            <a:off x="731520" y="6446520"/>
+            <a:ext cx="9144000" cy="365760"/>
           </a:xfrm>
           <a:prstGeom prst="rect">
             <a:avLst/>
@@ -4206,10 +4384,45 @@
           </a:bodyPr>
           <a:lstStyle/>
           <a:p>
+            <a:pPr>
+              <a:defRPr sz="1000" b="1">
+                <a:solidFill>
+                  <a:srgbClr val="FFFFFF"/>
+                </a:solidFill>
+              </a:defRPr>
+            </a:pPr>
+            <a:r>
+              <a:t>@SIH Idea submission- Template | Team: AyurSutra Innovators</a:t>
+            </a:r>
+          </a:p>
+        </p:txBody>
+      </p:sp>
+      <p:sp>
+        <p:nvSpPr>
+          <p:cNvPr id="8" name="TextBox 7"/>
+          <p:cNvSpPr txBox="1"/>
+          <p:nvPr/>
+        </p:nvSpPr>
+        <p:spPr>
+          <a:xfrm>
+            <a:off x="10789920" y="6446520"/>
+            <a:ext cx="731520" cy="365760"/>
+          </a:xfrm>
+          <a:prstGeom prst="rect">
+            <a:avLst/>
+          </a:prstGeom>
+          <a:noFill/>
+        </p:spPr>
+        <p:txBody>
+          <a:bodyPr wrap="none">
+            <a:spAutoFit/>
+          </a:bodyPr>
+          <a:lstStyle/>
+          <a:p>
             <a:pPr algn="r">
               <a:defRPr sz="1100" b="1">
                 <a:solidFill>
-                  <a:srgbClr val="D4AF37"/>
+                  <a:srgbClr val="FFFFFF"/>
                 </a:solidFill>
               </a:defRPr>
             </a:pPr>
@@ -4221,14 +4434,14 @@
       </p:sp>
       <p:sp>
         <p:nvSpPr>
-          <p:cNvPr id="8" name="Rounded Rectangle 7"/>
+          <p:cNvPr id="9" name="Rounded Rectangle 8"/>
           <p:cNvSpPr/>
           <p:nvPr/>
         </p:nvSpPr>
         <p:spPr>
           <a:xfrm>
-            <a:off x="731520" y="1280160"/>
-            <a:ext cx="10728655" cy="2286000"/>
+            <a:off x="731520" y="1188720"/>
+            <a:ext cx="6858000" cy="1828800"/>
           </a:xfrm>
           <a:prstGeom prst="roundRect">
             <a:avLst/>
@@ -4266,14 +4479,14 @@
       </p:sp>
       <p:sp>
         <p:nvSpPr>
-          <p:cNvPr id="9" name="TextBox 8"/>
+          <p:cNvPr id="10" name="TextBox 9"/>
           <p:cNvSpPr txBox="1"/>
           <p:nvPr/>
         </p:nvSpPr>
         <p:spPr>
           <a:xfrm>
-            <a:off x="914400" y="1371600"/>
-            <a:ext cx="10362895" cy="2103120"/>
+            <a:off x="914400" y="1234440"/>
+            <a:ext cx="6492240" cy="1737360"/>
           </a:xfrm>
           <a:prstGeom prst="rect">
             <a:avLst/>
@@ -4285,99 +4498,233 @@
             <a:spAutoFit/>
           </a:bodyPr>
           <a:lstStyle/>
-          <a:p>
-            <a:pPr>
-              <a:spcAft>
-                <a:spcPts val="600"/>
-              </a:spcAft>
-              <a:defRPr sz="1400" b="1">
-                <a:solidFill>
-                  <a:srgbClr val="059669"/>
-                </a:solidFill>
-              </a:defRPr>
-            </a:pPr>
-            <a:r>
-              <a:t>TECHNOLOGIES &amp; FRAMEWORKS USED</a:t>
-            </a:r>
-          </a:p>
           <a:p>
             <a:pPr>
               <a:spcAft>
                 <a:spcPts val="400"/>
               </a:spcAft>
-              <a:defRPr sz="1100">
-                <a:solidFill>
-                  <a:srgbClr val="1C1917"/>
-                </a:solidFill>
-              </a:defRPr>
-            </a:pPr>
-            <a:r>
-              <a:t>• Frontend UI/UX: HTML5, Vanilla JavaScript (ES Modules), Tailwind CSS v3, Lucide Icons, Google Fonts (Cinzel &amp; Plus Jakarta Sans).</a:t>
+              <a:defRPr sz="1200" b="1">
+                <a:solidFill>
+                  <a:srgbClr val="0F1E36"/>
+                </a:solidFill>
+              </a:defRPr>
+            </a:pPr>
+            <a:r>
+              <a:t>• Technologies to be used (programming languages, frameworks, hardware)</a:t>
             </a:r>
           </a:p>
           <a:p>
             <a:pPr>
               <a:spcAft>
-                <a:spcPts val="400"/>
+                <a:spcPts val="300"/>
               </a:spcAft>
-              <a:defRPr sz="1100">
-                <a:solidFill>
-                  <a:srgbClr val="1C1917"/>
-                </a:solidFill>
-              </a:defRPr>
-            </a:pPr>
-            <a:r>
-              <a:t>• OCR Engine &amp; NLP: Tesseract.js client OCR engine with intelligent regex parsing &amp; fallback report analyzer.</a:t>
+              <a:defRPr sz="1000">
+                <a:solidFill>
+                  <a:srgbClr val="1E293B"/>
+                </a:solidFill>
+              </a:defRPr>
+            </a:pPr>
+            <a:r>
+              <a:t>• Frontend &amp; UI Stack: HTML5, ES Modules JS, Tailwind CSS v3, CSS Viewport Scroll Snap (scroll-snap-type: y mandatory).</a:t>
             </a:r>
           </a:p>
           <a:p>
             <a:pPr>
               <a:spcAft>
-                <a:spcPts val="400"/>
+                <a:spcPts val="300"/>
               </a:spcAft>
-              <a:defRPr sz="1100">
-                <a:solidFill>
-                  <a:srgbClr val="1C1917"/>
-                </a:solidFill>
-              </a:defRPr>
-            </a:pPr>
-            <a:r>
-              <a:t>• Layout &amp; Audio Engine: CSS Viewport Scroll Snap (scroll-snap-type: y mandatory) &amp; Web Audio API soundscape chimes (playSingingBowlChime).</a:t>
+              <a:defRPr sz="1000">
+                <a:solidFill>
+                  <a:srgbClr val="1E293B"/>
+                </a:solidFill>
+              </a:defRPr>
+            </a:pPr>
+            <a:r>
+              <a:t>• OCR Engine &amp; Regulatory: Tesseract.js WASM worker &amp; regex parser; ABDM (Ayushman Bharat) Health ID &amp; GSTN 5% tax invoice formatting.</a:t>
             </a:r>
           </a:p>
           <a:p>
             <a:pPr>
               <a:spcAft>
-                <a:spcPts val="400"/>
+                <a:spcPts val="300"/>
               </a:spcAft>
-              <a:defRPr sz="1100">
-                <a:solidFill>
-                  <a:srgbClr val="1C1917"/>
-                </a:solidFill>
-              </a:defRPr>
-            </a:pPr>
-            <a:r>
-              <a:t>• Database &amp; Schemas: MySQL 5.7+ / MariaDB 10.2+ (XAMPP compatible), 12 relational tables, dynamic SQL exporter (ayursutra_db.sql &amp; ayursutra_pat_db.sql).</a:t>
-            </a:r>
-          </a:p>
-        </p:txBody>
-      </p:sp>
-      <p:sp>
-        <p:nvSpPr>
-          <p:cNvPr id="10" name="Rounded Rectangle 9"/>
+              <a:defRPr sz="1000">
+                <a:solidFill>
+                  <a:srgbClr val="1E293B"/>
+                </a:solidFill>
+              </a:defRPr>
+            </a:pPr>
+            <a:r>
+              <a:t>• Database &amp; Repository: MySQL 5.7+ (12 tables), ayursutra_db.sql exporter; Repo: https://github.com/2025ucp1468-Mayank/SIH_PROJECT (branch: mayank).</a:t>
+            </a:r>
+          </a:p>
+        </p:txBody>
+      </p:sp>
+      <p:sp>
+        <p:nvSpPr>
+          <p:cNvPr id="11" name="Rounded Rectangle 10"/>
           <p:cNvSpPr/>
           <p:nvPr/>
         </p:nvSpPr>
         <p:spPr>
           <a:xfrm>
-            <a:off x="731520" y="3840480"/>
-            <a:ext cx="10728655" cy="2286000"/>
+            <a:off x="7772400" y="1188720"/>
+            <a:ext cx="3657600" cy="4937760"/>
           </a:xfrm>
           <a:prstGeom prst="roundRect">
             <a:avLst/>
           </a:prstGeom>
           <a:solidFill>
-            <a:srgbClr val="F0FDF4"/>
+            <a:srgbClr val="FFFFFF"/>
+          </a:solidFill>
+          <a:ln w="25400">
+            <a:solidFill>
+              <a:srgbClr val="059669"/>
+            </a:solidFill>
+          </a:ln>
+        </p:spPr>
+        <p:style>
+          <a:lnRef idx="1">
+            <a:schemeClr val="accent1"/>
+          </a:lnRef>
+          <a:fillRef idx="3">
+            <a:schemeClr val="accent1"/>
+          </a:fillRef>
+          <a:effectRef idx="2">
+            <a:schemeClr val="accent1"/>
+          </a:effectRef>
+          <a:fontRef idx="minor">
+            <a:schemeClr val="lt1"/>
+          </a:fontRef>
+        </p:style>
+        <p:txBody>
+          <a:bodyPr rtlCol="0" anchor="ctr"/>
+          <a:lstStyle/>
+          <a:p>
+            <a:pPr algn="ctr"/>
+          </a:p>
+        </p:txBody>
+      </p:sp>
+      <p:sp>
+        <p:nvSpPr>
+          <p:cNvPr id="12" name="TextBox 11"/>
+          <p:cNvSpPr txBox="1"/>
+          <p:nvPr/>
+        </p:nvSpPr>
+        <p:spPr>
+          <a:xfrm>
+            <a:off x="7863840" y="1280160"/>
+            <a:ext cx="3474720" cy="365760"/>
+          </a:xfrm>
+          <a:prstGeom prst="rect">
+            <a:avLst/>
+          </a:prstGeom>
+          <a:noFill/>
+        </p:spPr>
+        <p:txBody>
+          <a:bodyPr wrap="none">
+            <a:spAutoFit/>
+          </a:bodyPr>
+          <a:lstStyle/>
+          <a:p>
+            <a:pPr>
+              <a:defRPr sz="1000" b="1">
+                <a:solidFill>
+                  <a:srgbClr val="0F1E36"/>
+                </a:solidFill>
+              </a:defRPr>
+            </a:pPr>
+            <a:r>
+              <a:t>PROTOTYPE: OCR DIAGNOSTIC EXTRACTOR</a:t>
+            </a:r>
+          </a:p>
+        </p:txBody>
+      </p:sp>
+      <p:pic>
+        <p:nvPicPr>
+          <p:cNvPr id="13" name="Picture 12" descr="02_ocr_medical_report_extractor.png"/>
+          <p:cNvPicPr>
+            <a:picLocks noChangeAspect="1"/>
+          </p:cNvPicPr>
+          <p:nvPr/>
+        </p:nvPicPr>
+        <p:blipFill>
+          <a:blip r:embed="rId2"/>
+          <a:stretch>
+            <a:fillRect/>
+          </a:stretch>
+        </p:blipFill>
+        <p:spPr>
+          <a:xfrm>
+            <a:off x="7863840" y="1691640"/>
+            <a:ext cx="3474720" cy="1650492"/>
+          </a:xfrm>
+          <a:prstGeom prst="rect">
+            <a:avLst/>
+          </a:prstGeom>
+        </p:spPr>
+      </p:pic>
+      <p:sp>
+        <p:nvSpPr>
+          <p:cNvPr id="14" name="Rounded Rectangle 13"/>
+          <p:cNvSpPr/>
+          <p:nvPr/>
+        </p:nvSpPr>
+        <p:spPr>
+          <a:xfrm>
+            <a:off x="731520" y="3200400"/>
+            <a:ext cx="1554480" cy="2926080"/>
+          </a:xfrm>
+          <a:prstGeom prst="roundRect">
+            <a:avLst/>
+          </a:prstGeom>
+          <a:solidFill>
+            <a:srgbClr val="FFFFFF"/>
+          </a:solidFill>
+          <a:ln w="25400">
+            <a:solidFill>
+              <a:srgbClr val="059669"/>
+            </a:solidFill>
+          </a:ln>
+        </p:spPr>
+        <p:style>
+          <a:lnRef idx="1">
+            <a:schemeClr val="accent1"/>
+          </a:lnRef>
+          <a:fillRef idx="3">
+            <a:schemeClr val="accent1"/>
+          </a:fillRef>
+          <a:effectRef idx="2">
+            <a:schemeClr val="accent1"/>
+          </a:effectRef>
+          <a:fontRef idx="minor">
+            <a:schemeClr val="lt1"/>
+          </a:fontRef>
+        </p:style>
+        <p:txBody>
+          <a:bodyPr rtlCol="0" anchor="ctr"/>
+          <a:lstStyle/>
+          <a:p>
+            <a:pPr algn="ctr"/>
+          </a:p>
+        </p:txBody>
+      </p:sp>
+      <p:sp>
+        <p:nvSpPr>
+          <p:cNvPr id="15" name="Rectangle 14"/>
+          <p:cNvSpPr/>
+          <p:nvPr/>
+        </p:nvSpPr>
+        <p:spPr>
+          <a:xfrm>
+            <a:off x="731520" y="3200400"/>
+            <a:ext cx="1554480" cy="457200"/>
+          </a:xfrm>
+          <a:prstGeom prst="rect">
+            <a:avLst/>
+          </a:prstGeom>
+          <a:solidFill>
+            <a:srgbClr val="059669"/>
           </a:solidFill>
           <a:ln>
             <a:solidFill>
@@ -4409,14 +4756,49 @@
       </p:sp>
       <p:sp>
         <p:nvSpPr>
-          <p:cNvPr id="11" name="TextBox 10"/>
+          <p:cNvPr id="16" name="TextBox 15"/>
           <p:cNvSpPr txBox="1"/>
           <p:nvPr/>
         </p:nvSpPr>
         <p:spPr>
           <a:xfrm>
-            <a:off x="914400" y="3931920"/>
-            <a:ext cx="10362895" cy="2103120"/>
+            <a:off x="731520" y="3246120"/>
+            <a:ext cx="1554480" cy="365760"/>
+          </a:xfrm>
+          <a:prstGeom prst="rect">
+            <a:avLst/>
+          </a:prstGeom>
+          <a:noFill/>
+        </p:spPr>
+        <p:txBody>
+          <a:bodyPr wrap="none">
+            <a:spAutoFit/>
+          </a:bodyPr>
+          <a:lstStyle/>
+          <a:p>
+            <a:pPr algn="ctr">
+              <a:defRPr sz="900" b="1">
+                <a:solidFill>
+                  <a:srgbClr val="FFFFFF"/>
+                </a:solidFill>
+              </a:defRPr>
+            </a:pPr>
+            <a:r>
+              <a:t>1. INTAKE UI</a:t>
+            </a:r>
+          </a:p>
+        </p:txBody>
+      </p:sp>
+      <p:sp>
+        <p:nvSpPr>
+          <p:cNvPr id="17" name="TextBox 16"/>
+          <p:cNvSpPr txBox="1"/>
+          <p:nvPr/>
+        </p:nvSpPr>
+        <p:spPr>
+          <a:xfrm>
+            <a:off x="804672" y="3703320"/>
+            <a:ext cx="1408176" cy="2377440"/>
           </a:xfrm>
           <a:prstGeom prst="rect">
             <a:avLst/>
@@ -4431,43 +4813,820 @@
           <a:p>
             <a:pPr>
               <a:spcAft>
-                <a:spcPts val="800"/>
+                <a:spcPts val="400"/>
               </a:spcAft>
-              <a:defRPr sz="1400" b="1">
-                <a:solidFill>
-                  <a:srgbClr val="082419"/>
-                </a:solidFill>
-              </a:defRPr>
-            </a:pPr>
-            <a:r>
-              <a:t>METHODOLOGY &amp; PIPELINE FLOWCHART</a:t>
+              <a:defRPr sz="900" b="1">
+                <a:solidFill>
+                  <a:srgbClr val="1E293B"/>
+                </a:solidFill>
+              </a:defRPr>
+            </a:pPr>
+            <a:r>
+              <a:t>Image Drag &amp; Drop</a:t>
             </a:r>
           </a:p>
           <a:p>
             <a:pPr>
               <a:spcAft>
-                <a:spcPts val="800"/>
+                <a:spcPts val="200"/>
               </a:spcAft>
-              <a:defRPr sz="1200" b="1">
-                <a:solidFill>
-                  <a:srgbClr val="059669"/>
-                </a:solidFill>
-              </a:defRPr>
-            </a:pPr>
-            <a:r>
-              <a:t>[1. Scanned Medical Report] ➔ [2. Tesseract OCR Extraction] ➔ [3. Forced Verification Form] ➔ [4. Ayurvedic SOAP Engine] ➔ [5. Dosha-Matched Vaidya Algorithm] ➔ [6. MySQL Persistence Script]</a:t>
+              <a:defRPr sz="800">
+                <a:solidFill>
+                  <a:srgbClr val="64748B"/>
+                </a:solidFill>
+              </a:defRPr>
+            </a:pPr>
+            <a:r>
+              <a:t>• White Box Card</a:t>
             </a:r>
           </a:p>
           <a:p>
             <a:pPr>
-              <a:defRPr sz="1100">
-                <a:solidFill>
-                  <a:srgbClr val="1C1917"/>
-                </a:solidFill>
-              </a:defRPr>
-            </a:pPr>
-            <a:r>
-              <a:t>The pipeline ensures zero data loss by combining client-side automated extraction with mandatory Vaidya review, generating ABDM-aligned structured health records and GSTN tax invoices.</a:t>
+              <a:spcAft>
+                <a:spcPts val="200"/>
+              </a:spcAft>
+              <a:defRPr sz="800">
+                <a:solidFill>
+                  <a:srgbClr val="64748B"/>
+                </a:solidFill>
+              </a:defRPr>
+            </a:pPr>
+            <a:r>
+              <a:t>• Scroll Viewport</a:t>
+            </a:r>
+          </a:p>
+          <a:p>
+            <a:pPr>
+              <a:spcAft>
+                <a:spcPts val="200"/>
+              </a:spcAft>
+              <a:defRPr sz="800">
+                <a:solidFill>
+                  <a:srgbClr val="64748B"/>
+                </a:solidFill>
+              </a:defRPr>
+            </a:pPr>
+            <a:r>
+              <a:t>• Instant Preview</a:t>
+            </a:r>
+          </a:p>
+        </p:txBody>
+      </p:sp>
+      <p:sp>
+        <p:nvSpPr>
+          <p:cNvPr id="18" name="Right Arrow 17"/>
+          <p:cNvSpPr/>
+          <p:nvPr/>
+        </p:nvSpPr>
+        <p:spPr>
+          <a:xfrm>
+            <a:off x="2313432" y="4389120"/>
+            <a:ext cx="109728" cy="274320"/>
+          </a:xfrm>
+          <a:prstGeom prst="rightArrow">
+            <a:avLst/>
+          </a:prstGeom>
+          <a:solidFill>
+            <a:srgbClr val="E36209"/>
+          </a:solidFill>
+          <a:ln>
+            <a:solidFill>
+              <a:srgbClr val="E36209"/>
+            </a:solidFill>
+          </a:ln>
+        </p:spPr>
+        <p:style>
+          <a:lnRef idx="1">
+            <a:schemeClr val="accent1"/>
+          </a:lnRef>
+          <a:fillRef idx="3">
+            <a:schemeClr val="accent1"/>
+          </a:fillRef>
+          <a:effectRef idx="2">
+            <a:schemeClr val="accent1"/>
+          </a:effectRef>
+          <a:fontRef idx="minor">
+            <a:schemeClr val="lt1"/>
+          </a:fontRef>
+        </p:style>
+        <p:txBody>
+          <a:bodyPr rtlCol="0" anchor="ctr"/>
+          <a:lstStyle/>
+          <a:p>
+            <a:pPr algn="ctr"/>
+          </a:p>
+        </p:txBody>
+      </p:sp>
+      <p:sp>
+        <p:nvSpPr>
+          <p:cNvPr id="19" name="Rounded Rectangle 18"/>
+          <p:cNvSpPr/>
+          <p:nvPr/>
+        </p:nvSpPr>
+        <p:spPr>
+          <a:xfrm>
+            <a:off x="2450591" y="3200400"/>
+            <a:ext cx="1554480" cy="2926080"/>
+          </a:xfrm>
+          <a:prstGeom prst="roundRect">
+            <a:avLst/>
+          </a:prstGeom>
+          <a:solidFill>
+            <a:srgbClr val="FFFFFF"/>
+          </a:solidFill>
+          <a:ln w="25400">
+            <a:solidFill>
+              <a:srgbClr val="0F1E36"/>
+            </a:solidFill>
+          </a:ln>
+        </p:spPr>
+        <p:style>
+          <a:lnRef idx="1">
+            <a:schemeClr val="accent1"/>
+          </a:lnRef>
+          <a:fillRef idx="3">
+            <a:schemeClr val="accent1"/>
+          </a:fillRef>
+          <a:effectRef idx="2">
+            <a:schemeClr val="accent1"/>
+          </a:effectRef>
+          <a:fontRef idx="minor">
+            <a:schemeClr val="lt1"/>
+          </a:fontRef>
+        </p:style>
+        <p:txBody>
+          <a:bodyPr rtlCol="0" anchor="ctr"/>
+          <a:lstStyle/>
+          <a:p>
+            <a:pPr algn="ctr"/>
+          </a:p>
+        </p:txBody>
+      </p:sp>
+      <p:sp>
+        <p:nvSpPr>
+          <p:cNvPr id="20" name="Rectangle 19"/>
+          <p:cNvSpPr/>
+          <p:nvPr/>
+        </p:nvSpPr>
+        <p:spPr>
+          <a:xfrm>
+            <a:off x="2450591" y="3200400"/>
+            <a:ext cx="1554480" cy="457200"/>
+          </a:xfrm>
+          <a:prstGeom prst="rect">
+            <a:avLst/>
+          </a:prstGeom>
+          <a:solidFill>
+            <a:srgbClr val="0F1E36"/>
+          </a:solidFill>
+          <a:ln>
+            <a:solidFill>
+              <a:srgbClr val="0F1E36"/>
+            </a:solidFill>
+          </a:ln>
+        </p:spPr>
+        <p:style>
+          <a:lnRef idx="1">
+            <a:schemeClr val="accent1"/>
+          </a:lnRef>
+          <a:fillRef idx="3">
+            <a:schemeClr val="accent1"/>
+          </a:fillRef>
+          <a:effectRef idx="2">
+            <a:schemeClr val="accent1"/>
+          </a:effectRef>
+          <a:fontRef idx="minor">
+            <a:schemeClr val="lt1"/>
+          </a:fontRef>
+        </p:style>
+        <p:txBody>
+          <a:bodyPr rtlCol="0" anchor="ctr"/>
+          <a:lstStyle/>
+          <a:p>
+            <a:pPr algn="ctr"/>
+          </a:p>
+        </p:txBody>
+      </p:sp>
+      <p:sp>
+        <p:nvSpPr>
+          <p:cNvPr id="21" name="TextBox 20"/>
+          <p:cNvSpPr txBox="1"/>
+          <p:nvPr/>
+        </p:nvSpPr>
+        <p:spPr>
+          <a:xfrm>
+            <a:off x="2450591" y="3246120"/>
+            <a:ext cx="1554480" cy="365760"/>
+          </a:xfrm>
+          <a:prstGeom prst="rect">
+            <a:avLst/>
+          </a:prstGeom>
+          <a:noFill/>
+        </p:spPr>
+        <p:txBody>
+          <a:bodyPr wrap="none">
+            <a:spAutoFit/>
+          </a:bodyPr>
+          <a:lstStyle/>
+          <a:p>
+            <a:pPr algn="ctr">
+              <a:defRPr sz="900" b="1">
+                <a:solidFill>
+                  <a:srgbClr val="FFFFFF"/>
+                </a:solidFill>
+              </a:defRPr>
+            </a:pPr>
+            <a:r>
+              <a:t>2. TESSERACT OCR</a:t>
+            </a:r>
+          </a:p>
+        </p:txBody>
+      </p:sp>
+      <p:sp>
+        <p:nvSpPr>
+          <p:cNvPr id="22" name="TextBox 21"/>
+          <p:cNvSpPr txBox="1"/>
+          <p:nvPr/>
+        </p:nvSpPr>
+        <p:spPr>
+          <a:xfrm>
+            <a:off x="2523743" y="3703320"/>
+            <a:ext cx="1408176" cy="2377440"/>
+          </a:xfrm>
+          <a:prstGeom prst="rect">
+            <a:avLst/>
+          </a:prstGeom>
+          <a:noFill/>
+        </p:spPr>
+        <p:txBody>
+          <a:bodyPr wrap="square">
+            <a:spAutoFit/>
+          </a:bodyPr>
+          <a:lstStyle/>
+          <a:p>
+            <a:pPr>
+              <a:spcAft>
+                <a:spcPts val="400"/>
+              </a:spcAft>
+              <a:defRPr sz="900" b="1">
+                <a:solidFill>
+                  <a:srgbClr val="1E293B"/>
+                </a:solidFill>
+              </a:defRPr>
+            </a:pPr>
+            <a:r>
+              <a:t>WASM &amp; Regex Parse</a:t>
+            </a:r>
+          </a:p>
+          <a:p>
+            <a:pPr>
+              <a:spcAft>
+                <a:spcPts val="200"/>
+              </a:spcAft>
+              <a:defRPr sz="800">
+                <a:solidFill>
+                  <a:srgbClr val="64748B"/>
+                </a:solidFill>
+              </a:defRPr>
+            </a:pPr>
+            <a:r>
+              <a:t>• Text Analysis</a:t>
+            </a:r>
+          </a:p>
+          <a:p>
+            <a:pPr>
+              <a:spcAft>
+                <a:spcPts val="200"/>
+              </a:spcAft>
+              <a:defRPr sz="800">
+                <a:solidFill>
+                  <a:srgbClr val="64748B"/>
+                </a:solidFill>
+              </a:defRPr>
+            </a:pPr>
+            <a:r>
+              <a:t>• Vata/Pitta/Kapha</a:t>
+            </a:r>
+          </a:p>
+          <a:p>
+            <a:pPr>
+              <a:spcAft>
+                <a:spcPts val="200"/>
+              </a:spcAft>
+              <a:defRPr sz="800">
+                <a:solidFill>
+                  <a:srgbClr val="64748B"/>
+                </a:solidFill>
+              </a:defRPr>
+            </a:pPr>
+            <a:r>
+              <a:t>• Symptom Parser</a:t>
+            </a:r>
+          </a:p>
+        </p:txBody>
+      </p:sp>
+      <p:sp>
+        <p:nvSpPr>
+          <p:cNvPr id="23" name="Right Arrow 22"/>
+          <p:cNvSpPr/>
+          <p:nvPr/>
+        </p:nvSpPr>
+        <p:spPr>
+          <a:xfrm>
+            <a:off x="4032503" y="4389120"/>
+            <a:ext cx="109728" cy="274320"/>
+          </a:xfrm>
+          <a:prstGeom prst="rightArrow">
+            <a:avLst/>
+          </a:prstGeom>
+          <a:solidFill>
+            <a:srgbClr val="E36209"/>
+          </a:solidFill>
+          <a:ln>
+            <a:solidFill>
+              <a:srgbClr val="E36209"/>
+            </a:solidFill>
+          </a:ln>
+        </p:spPr>
+        <p:style>
+          <a:lnRef idx="1">
+            <a:schemeClr val="accent1"/>
+          </a:lnRef>
+          <a:fillRef idx="3">
+            <a:schemeClr val="accent1"/>
+          </a:fillRef>
+          <a:effectRef idx="2">
+            <a:schemeClr val="accent1"/>
+          </a:effectRef>
+          <a:fontRef idx="minor">
+            <a:schemeClr val="lt1"/>
+          </a:fontRef>
+        </p:style>
+        <p:txBody>
+          <a:bodyPr rtlCol="0" anchor="ctr"/>
+          <a:lstStyle/>
+          <a:p>
+            <a:pPr algn="ctr"/>
+          </a:p>
+        </p:txBody>
+      </p:sp>
+      <p:sp>
+        <p:nvSpPr>
+          <p:cNvPr id="24" name="Rounded Rectangle 23"/>
+          <p:cNvSpPr/>
+          <p:nvPr/>
+        </p:nvSpPr>
+        <p:spPr>
+          <a:xfrm>
+            <a:off x="4169663" y="3200400"/>
+            <a:ext cx="1554480" cy="2926080"/>
+          </a:xfrm>
+          <a:prstGeom prst="roundRect">
+            <a:avLst/>
+          </a:prstGeom>
+          <a:solidFill>
+            <a:srgbClr val="FFFFFF"/>
+          </a:solidFill>
+          <a:ln w="25400">
+            <a:solidFill>
+              <a:srgbClr val="E36209"/>
+            </a:solidFill>
+          </a:ln>
+        </p:spPr>
+        <p:style>
+          <a:lnRef idx="1">
+            <a:schemeClr val="accent1"/>
+          </a:lnRef>
+          <a:fillRef idx="3">
+            <a:schemeClr val="accent1"/>
+          </a:fillRef>
+          <a:effectRef idx="2">
+            <a:schemeClr val="accent1"/>
+          </a:effectRef>
+          <a:fontRef idx="minor">
+            <a:schemeClr val="lt1"/>
+          </a:fontRef>
+        </p:style>
+        <p:txBody>
+          <a:bodyPr rtlCol="0" anchor="ctr"/>
+          <a:lstStyle/>
+          <a:p>
+            <a:pPr algn="ctr"/>
+          </a:p>
+        </p:txBody>
+      </p:sp>
+      <p:sp>
+        <p:nvSpPr>
+          <p:cNvPr id="25" name="Rectangle 24"/>
+          <p:cNvSpPr/>
+          <p:nvPr/>
+        </p:nvSpPr>
+        <p:spPr>
+          <a:xfrm>
+            <a:off x="4169663" y="3200400"/>
+            <a:ext cx="1554480" cy="457200"/>
+          </a:xfrm>
+          <a:prstGeom prst="rect">
+            <a:avLst/>
+          </a:prstGeom>
+          <a:solidFill>
+            <a:srgbClr val="E36209"/>
+          </a:solidFill>
+          <a:ln>
+            <a:solidFill>
+              <a:srgbClr val="E36209"/>
+            </a:solidFill>
+          </a:ln>
+        </p:spPr>
+        <p:style>
+          <a:lnRef idx="1">
+            <a:schemeClr val="accent1"/>
+          </a:lnRef>
+          <a:fillRef idx="3">
+            <a:schemeClr val="accent1"/>
+          </a:fillRef>
+          <a:effectRef idx="2">
+            <a:schemeClr val="accent1"/>
+          </a:effectRef>
+          <a:fontRef idx="minor">
+            <a:schemeClr val="lt1"/>
+          </a:fontRef>
+        </p:style>
+        <p:txBody>
+          <a:bodyPr rtlCol="0" anchor="ctr"/>
+          <a:lstStyle/>
+          <a:p>
+            <a:pPr algn="ctr"/>
+          </a:p>
+        </p:txBody>
+      </p:sp>
+      <p:sp>
+        <p:nvSpPr>
+          <p:cNvPr id="26" name="TextBox 25"/>
+          <p:cNvSpPr txBox="1"/>
+          <p:nvPr/>
+        </p:nvSpPr>
+        <p:spPr>
+          <a:xfrm>
+            <a:off x="4169663" y="3246120"/>
+            <a:ext cx="1554480" cy="365760"/>
+          </a:xfrm>
+          <a:prstGeom prst="rect">
+            <a:avLst/>
+          </a:prstGeom>
+          <a:noFill/>
+        </p:spPr>
+        <p:txBody>
+          <a:bodyPr wrap="none">
+            <a:spAutoFit/>
+          </a:bodyPr>
+          <a:lstStyle/>
+          <a:p>
+            <a:pPr algn="ctr">
+              <a:defRPr sz="900" b="1">
+                <a:solidFill>
+                  <a:srgbClr val="FFFFFF"/>
+                </a:solidFill>
+              </a:defRPr>
+            </a:pPr>
+            <a:r>
+              <a:t>3. FORCED VERIFY</a:t>
+            </a:r>
+          </a:p>
+        </p:txBody>
+      </p:sp>
+      <p:sp>
+        <p:nvSpPr>
+          <p:cNvPr id="27" name="TextBox 26"/>
+          <p:cNvSpPr txBox="1"/>
+          <p:nvPr/>
+        </p:nvSpPr>
+        <p:spPr>
+          <a:xfrm>
+            <a:off x="4242815" y="3703320"/>
+            <a:ext cx="1408176" cy="2377440"/>
+          </a:xfrm>
+          <a:prstGeom prst="rect">
+            <a:avLst/>
+          </a:prstGeom>
+          <a:noFill/>
+        </p:spPr>
+        <p:txBody>
+          <a:bodyPr wrap="square">
+            <a:spAutoFit/>
+          </a:bodyPr>
+          <a:lstStyle/>
+          <a:p>
+            <a:pPr>
+              <a:spcAft>
+                <a:spcPts val="400"/>
+              </a:spcAft>
+              <a:defRPr sz="900" b="1">
+                <a:solidFill>
+                  <a:srgbClr val="1E293B"/>
+                </a:solidFill>
+              </a:defRPr>
+            </a:pPr>
+            <a:r>
+              <a:t>Symptom Confirmation</a:t>
+            </a:r>
+          </a:p>
+          <a:p>
+            <a:pPr>
+              <a:spcAft>
+                <a:spcPts val="200"/>
+              </a:spcAft>
+              <a:defRPr sz="800">
+                <a:solidFill>
+                  <a:srgbClr val="64748B"/>
+                </a:solidFill>
+              </a:defRPr>
+            </a:pPr>
+            <a:r>
+              <a:t>• Demographics</a:t>
+            </a:r>
+          </a:p>
+          <a:p>
+            <a:pPr>
+              <a:spcAft>
+                <a:spcPts val="200"/>
+              </a:spcAft>
+              <a:defRPr sz="800">
+                <a:solidFill>
+                  <a:srgbClr val="64748B"/>
+                </a:solidFill>
+              </a:defRPr>
+            </a:pPr>
+            <a:r>
+              <a:t>• Manual Guardrail</a:t>
+            </a:r>
+          </a:p>
+          <a:p>
+            <a:pPr>
+              <a:spcAft>
+                <a:spcPts val="200"/>
+              </a:spcAft>
+              <a:defRPr sz="800">
+                <a:solidFill>
+                  <a:srgbClr val="64748B"/>
+                </a:solidFill>
+              </a:defRPr>
+            </a:pPr>
+            <a:r>
+              <a:t>• User Override</a:t>
+            </a:r>
+          </a:p>
+        </p:txBody>
+      </p:sp>
+      <p:sp>
+        <p:nvSpPr>
+          <p:cNvPr id="28" name="Right Arrow 27"/>
+          <p:cNvSpPr/>
+          <p:nvPr/>
+        </p:nvSpPr>
+        <p:spPr>
+          <a:xfrm>
+            <a:off x="5751575" y="4389120"/>
+            <a:ext cx="109728" cy="274320"/>
+          </a:xfrm>
+          <a:prstGeom prst="rightArrow">
+            <a:avLst/>
+          </a:prstGeom>
+          <a:solidFill>
+            <a:srgbClr val="E36209"/>
+          </a:solidFill>
+          <a:ln>
+            <a:solidFill>
+              <a:srgbClr val="E36209"/>
+            </a:solidFill>
+          </a:ln>
+        </p:spPr>
+        <p:style>
+          <a:lnRef idx="1">
+            <a:schemeClr val="accent1"/>
+          </a:lnRef>
+          <a:fillRef idx="3">
+            <a:schemeClr val="accent1"/>
+          </a:fillRef>
+          <a:effectRef idx="2">
+            <a:schemeClr val="accent1"/>
+          </a:effectRef>
+          <a:fontRef idx="minor">
+            <a:schemeClr val="lt1"/>
+          </a:fontRef>
+        </p:style>
+        <p:txBody>
+          <a:bodyPr rtlCol="0" anchor="ctr"/>
+          <a:lstStyle/>
+          <a:p>
+            <a:pPr algn="ctr"/>
+          </a:p>
+        </p:txBody>
+      </p:sp>
+      <p:sp>
+        <p:nvSpPr>
+          <p:cNvPr id="29" name="Rounded Rectangle 28"/>
+          <p:cNvSpPr/>
+          <p:nvPr/>
+        </p:nvSpPr>
+        <p:spPr>
+          <a:xfrm>
+            <a:off x="5888736" y="3200400"/>
+            <a:ext cx="1554480" cy="2926080"/>
+          </a:xfrm>
+          <a:prstGeom prst="roundRect">
+            <a:avLst/>
+          </a:prstGeom>
+          <a:solidFill>
+            <a:srgbClr val="FFFFFF"/>
+          </a:solidFill>
+          <a:ln w="25400">
+            <a:solidFill>
+              <a:srgbClr val="059669"/>
+            </a:solidFill>
+          </a:ln>
+        </p:spPr>
+        <p:style>
+          <a:lnRef idx="1">
+            <a:schemeClr val="accent1"/>
+          </a:lnRef>
+          <a:fillRef idx="3">
+            <a:schemeClr val="accent1"/>
+          </a:fillRef>
+          <a:effectRef idx="2">
+            <a:schemeClr val="accent1"/>
+          </a:effectRef>
+          <a:fontRef idx="minor">
+            <a:schemeClr val="lt1"/>
+          </a:fontRef>
+        </p:style>
+        <p:txBody>
+          <a:bodyPr rtlCol="0" anchor="ctr"/>
+          <a:lstStyle/>
+          <a:p>
+            <a:pPr algn="ctr"/>
+          </a:p>
+        </p:txBody>
+      </p:sp>
+      <p:sp>
+        <p:nvSpPr>
+          <p:cNvPr id="30" name="Rectangle 29"/>
+          <p:cNvSpPr/>
+          <p:nvPr/>
+        </p:nvSpPr>
+        <p:spPr>
+          <a:xfrm>
+            <a:off x="5888736" y="3200400"/>
+            <a:ext cx="1554480" cy="457200"/>
+          </a:xfrm>
+          <a:prstGeom prst="rect">
+            <a:avLst/>
+          </a:prstGeom>
+          <a:solidFill>
+            <a:srgbClr val="059669"/>
+          </a:solidFill>
+          <a:ln>
+            <a:solidFill>
+              <a:srgbClr val="059669"/>
+            </a:solidFill>
+          </a:ln>
+        </p:spPr>
+        <p:style>
+          <a:lnRef idx="1">
+            <a:schemeClr val="accent1"/>
+          </a:lnRef>
+          <a:fillRef idx="3">
+            <a:schemeClr val="accent1"/>
+          </a:fillRef>
+          <a:effectRef idx="2">
+            <a:schemeClr val="accent1"/>
+          </a:effectRef>
+          <a:fontRef idx="minor">
+            <a:schemeClr val="lt1"/>
+          </a:fontRef>
+        </p:style>
+        <p:txBody>
+          <a:bodyPr rtlCol="0" anchor="ctr"/>
+          <a:lstStyle/>
+          <a:p>
+            <a:pPr algn="ctr"/>
+          </a:p>
+        </p:txBody>
+      </p:sp>
+      <p:sp>
+        <p:nvSpPr>
+          <p:cNvPr id="31" name="TextBox 30"/>
+          <p:cNvSpPr txBox="1"/>
+          <p:nvPr/>
+        </p:nvSpPr>
+        <p:spPr>
+          <a:xfrm>
+            <a:off x="5888736" y="3246120"/>
+            <a:ext cx="1554480" cy="365760"/>
+          </a:xfrm>
+          <a:prstGeom prst="rect">
+            <a:avLst/>
+          </a:prstGeom>
+          <a:noFill/>
+        </p:spPr>
+        <p:txBody>
+          <a:bodyPr wrap="none">
+            <a:spAutoFit/>
+          </a:bodyPr>
+          <a:lstStyle/>
+          <a:p>
+            <a:pPr algn="ctr">
+              <a:defRPr sz="900" b="1">
+                <a:solidFill>
+                  <a:srgbClr val="FFFFFF"/>
+                </a:solidFill>
+              </a:defRPr>
+            </a:pPr>
+            <a:r>
+              <a:t>4. AI MATCH &amp; DB</a:t>
+            </a:r>
+          </a:p>
+        </p:txBody>
+      </p:sp>
+      <p:sp>
+        <p:nvSpPr>
+          <p:cNvPr id="32" name="TextBox 31"/>
+          <p:cNvSpPr txBox="1"/>
+          <p:nvPr/>
+        </p:nvSpPr>
+        <p:spPr>
+          <a:xfrm>
+            <a:off x="5961888" y="3703320"/>
+            <a:ext cx="1408176" cy="2377440"/>
+          </a:xfrm>
+          <a:prstGeom prst="rect">
+            <a:avLst/>
+          </a:prstGeom>
+          <a:noFill/>
+        </p:spPr>
+        <p:txBody>
+          <a:bodyPr wrap="square">
+            <a:spAutoFit/>
+          </a:bodyPr>
+          <a:lstStyle/>
+          <a:p>
+            <a:pPr>
+              <a:spcAft>
+                <a:spcPts val="400"/>
+              </a:spcAft>
+              <a:defRPr sz="900" b="1">
+                <a:solidFill>
+                  <a:srgbClr val="1E293B"/>
+                </a:solidFill>
+              </a:defRPr>
+            </a:pPr>
+            <a:r>
+              <a:t>SOAP &amp; MySQL Export</a:t>
+            </a:r>
+          </a:p>
+          <a:p>
+            <a:pPr>
+              <a:spcAft>
+                <a:spcPts val="200"/>
+              </a:spcAft>
+              <a:defRPr sz="800">
+                <a:solidFill>
+                  <a:srgbClr val="64748B"/>
+                </a:solidFill>
+              </a:defRPr>
+            </a:pPr>
+            <a:r>
+              <a:t>• 98% Vaidya Match</a:t>
+            </a:r>
+          </a:p>
+          <a:p>
+            <a:pPr>
+              <a:spcAft>
+                <a:spcPts val="200"/>
+              </a:spcAft>
+              <a:defRPr sz="800">
+                <a:solidFill>
+                  <a:srgbClr val="64748B"/>
+                </a:solidFill>
+              </a:defRPr>
+            </a:pPr>
+            <a:r>
+              <a:t>• Pathya Diet Rules</a:t>
+            </a:r>
+          </a:p>
+          <a:p>
+            <a:pPr>
+              <a:spcAft>
+                <a:spcPts val="200"/>
+              </a:spcAft>
+              <a:defRPr sz="800">
+                <a:solidFill>
+                  <a:srgbClr val="64748B"/>
+                </a:solidFill>
+              </a:defRPr>
+            </a:pPr>
+            <a:r>
+              <a:t>• ayursutra_db.sql</a:t>
             </a:r>
           </a:p>
         </p:txBody>
@@ -4499,18 +5658,16 @@
         <p:spPr>
           <a:xfrm>
             <a:off x="0" y="0"/>
-            <a:ext cx="12191695" cy="109728"/>
+            <a:ext cx="12191695" cy="6858000"/>
           </a:xfrm>
           <a:prstGeom prst="rect">
             <a:avLst/>
           </a:prstGeom>
           <a:solidFill>
-            <a:srgbClr val="D4AF37"/>
+            <a:srgbClr val="F8FAFC"/>
           </a:solidFill>
           <a:ln>
-            <a:solidFill>
-              <a:srgbClr val="D4AF37"/>
-            </a:solidFill>
+            <a:noFill/>
           </a:ln>
         </p:spPr>
         <p:style>
@@ -4537,95 +5694,24 @@
       </p:sp>
       <p:sp>
         <p:nvSpPr>
-          <p:cNvPr id="3" name="TextBox 2"/>
-          <p:cNvSpPr txBox="1"/>
-          <p:nvPr/>
-        </p:nvSpPr>
-        <p:spPr>
-          <a:xfrm>
-            <a:off x="731520" y="365760"/>
-            <a:ext cx="10728655" cy="731520"/>
+          <p:cNvPr id="3" name="Rectangle 2"/>
+          <p:cNvSpPr/>
+          <p:nvPr/>
+        </p:nvSpPr>
+        <p:spPr>
+          <a:xfrm>
+            <a:off x="0" y="0"/>
+            <a:ext cx="12191695" cy="91440"/>
           </a:xfrm>
           <a:prstGeom prst="rect">
             <a:avLst/>
           </a:prstGeom>
-          <a:noFill/>
-        </p:spPr>
-        <p:txBody>
-          <a:bodyPr wrap="square">
-            <a:spAutoFit/>
-          </a:bodyPr>
-          <a:lstStyle/>
-          <a:p>
-            <a:pPr>
-              <a:defRPr sz="2200" b="1">
-                <a:solidFill>
-                  <a:srgbClr val="082419"/>
-                </a:solidFill>
-                <a:latin typeface="Georgia"/>
-              </a:defRPr>
-            </a:pPr>
-            <a:r>
-              <a:t>FEASIBILITY, RISK ANALYSIS &amp; MITIGATION STRATEGIES</a:t>
-            </a:r>
-          </a:p>
-        </p:txBody>
-      </p:sp>
-      <p:sp>
-        <p:nvSpPr>
-          <p:cNvPr id="4" name="TextBox 3"/>
-          <p:cNvSpPr txBox="1"/>
-          <p:nvPr/>
-        </p:nvSpPr>
-        <p:spPr>
-          <a:xfrm>
-            <a:off x="8686800" y="320040"/>
-            <a:ext cx="2743200" cy="548640"/>
-          </a:xfrm>
-          <a:prstGeom prst="rect">
-            <a:avLst/>
-          </a:prstGeom>
-          <a:noFill/>
-        </p:spPr>
-        <p:txBody>
-          <a:bodyPr wrap="none">
-            <a:spAutoFit/>
-          </a:bodyPr>
-          <a:lstStyle/>
-          <a:p>
-            <a:pPr algn="r">
-              <a:defRPr sz="1000" b="1">
-                <a:solidFill>
-                  <a:srgbClr val="059669"/>
-                </a:solidFill>
-              </a:defRPr>
-            </a:pPr>
-            <a:r>
-              <a:t>SMART INDIA HACKATHON 2025</a:t>
-            </a:r>
-          </a:p>
-        </p:txBody>
-      </p:sp>
-      <p:sp>
-        <p:nvSpPr>
-          <p:cNvPr id="5" name="Rectangle 4"/>
-          <p:cNvSpPr/>
-          <p:nvPr/>
-        </p:nvSpPr>
-        <p:spPr>
-          <a:xfrm>
-            <a:off x="0" y="6400800"/>
-            <a:ext cx="12191695" cy="457200"/>
-          </a:xfrm>
-          <a:prstGeom prst="rect">
-            <a:avLst/>
-          </a:prstGeom>
           <a:solidFill>
-            <a:srgbClr val="047857"/>
+            <a:srgbClr val="0284C7"/>
           </a:solidFill>
           <a:ln>
             <a:solidFill>
-              <a:srgbClr val="047857"/>
+              <a:srgbClr val="0284C7"/>
             </a:solidFill>
           </a:ln>
         </p:spPr>
@@ -4653,14 +5739,50 @@
       </p:sp>
       <p:sp>
         <p:nvSpPr>
-          <p:cNvPr id="6" name="TextBox 5"/>
+          <p:cNvPr id="4" name="TextBox 3"/>
           <p:cNvSpPr txBox="1"/>
           <p:nvPr/>
         </p:nvSpPr>
         <p:spPr>
           <a:xfrm>
-            <a:off x="731520" y="6446520"/>
-            <a:ext cx="9144000" cy="365760"/>
+            <a:off x="731520" y="320040"/>
+            <a:ext cx="8229600" cy="731520"/>
+          </a:xfrm>
+          <a:prstGeom prst="rect">
+            <a:avLst/>
+          </a:prstGeom>
+          <a:noFill/>
+        </p:spPr>
+        <p:txBody>
+          <a:bodyPr wrap="square">
+            <a:spAutoFit/>
+          </a:bodyPr>
+          <a:lstStyle/>
+          <a:p>
+            <a:pPr>
+              <a:defRPr sz="2200" b="1">
+                <a:solidFill>
+                  <a:srgbClr val="0F1E36"/>
+                </a:solidFill>
+                <a:latin typeface="Georgia"/>
+              </a:defRPr>
+            </a:pPr>
+            <a:r>
+              <a:t>FEASIBILITY AND VIABILITY ANALYSIS</a:t>
+            </a:r>
+          </a:p>
+        </p:txBody>
+      </p:sp>
+      <p:sp>
+        <p:nvSpPr>
+          <p:cNvPr id="5" name="TextBox 4"/>
+          <p:cNvSpPr txBox="1"/>
+          <p:nvPr/>
+        </p:nvSpPr>
+        <p:spPr>
+          <a:xfrm>
+            <a:off x="8412480" y="320040"/>
+            <a:ext cx="3017520" cy="548640"/>
           </a:xfrm>
           <a:prstGeom prst="rect">
             <a:avLst/>
@@ -4673,16 +5795,73 @@
           </a:bodyPr>
           <a:lstStyle/>
           <a:p>
-            <a:pPr>
-              <a:defRPr sz="1000">
-                <a:solidFill>
-                  <a:srgbClr val="F5F5F4"/>
-                </a:solidFill>
-              </a:defRPr>
-            </a:pPr>
-            <a:r>
-              <a:t>@SIH Idea submission- Template | Team: AyurSutra Innovators</a:t>
-            </a:r>
+            <a:pPr algn="r">
+              <a:defRPr sz="1100" b="1">
+                <a:solidFill>
+                  <a:srgbClr val="E36209"/>
+                </a:solidFill>
+              </a:defRPr>
+            </a:pPr>
+            <a:r>
+              <a:t>SMART INDIA HACKATHON 2025</a:t>
+            </a:r>
+          </a:p>
+          <a:p>
+            <a:pPr algn="r">
+              <a:defRPr sz="900">
+                <a:solidFill>
+                  <a:srgbClr val="64748B"/>
+                </a:solidFill>
+              </a:defRPr>
+            </a:pPr>
+            <a:r>
+              <a:t>Official Idea Submission Template</a:t>
+            </a:r>
+          </a:p>
+        </p:txBody>
+      </p:sp>
+      <p:sp>
+        <p:nvSpPr>
+          <p:cNvPr id="6" name="Rectangle 5"/>
+          <p:cNvSpPr/>
+          <p:nvPr/>
+        </p:nvSpPr>
+        <p:spPr>
+          <a:xfrm>
+            <a:off x="0" y="6400800"/>
+            <a:ext cx="12191695" cy="457200"/>
+          </a:xfrm>
+          <a:prstGeom prst="rect">
+            <a:avLst/>
+          </a:prstGeom>
+          <a:solidFill>
+            <a:srgbClr val="0284C7"/>
+          </a:solidFill>
+          <a:ln>
+            <a:solidFill>
+              <a:srgbClr val="0284C7"/>
+            </a:solidFill>
+          </a:ln>
+        </p:spPr>
+        <p:style>
+          <a:lnRef idx="1">
+            <a:schemeClr val="accent1"/>
+          </a:lnRef>
+          <a:fillRef idx="3">
+            <a:schemeClr val="accent1"/>
+          </a:fillRef>
+          <a:effectRef idx="2">
+            <a:schemeClr val="accent1"/>
+          </a:effectRef>
+          <a:fontRef idx="minor">
+            <a:schemeClr val="lt1"/>
+          </a:fontRef>
+        </p:style>
+        <p:txBody>
+          <a:bodyPr rtlCol="0" anchor="ctr"/>
+          <a:lstStyle/>
+          <a:p>
+            <a:pPr algn="ctr"/>
           </a:p>
         </p:txBody>
       </p:sp>
@@ -4694,8 +5873,8 @@
         </p:nvSpPr>
         <p:spPr>
           <a:xfrm>
-            <a:off x="10515600" y="6446520"/>
-            <a:ext cx="914400" cy="365760"/>
+            <a:off x="731520" y="6446520"/>
+            <a:ext cx="9144000" cy="365760"/>
           </a:xfrm>
           <a:prstGeom prst="rect">
             <a:avLst/>
@@ -4708,10 +5887,45 @@
           </a:bodyPr>
           <a:lstStyle/>
           <a:p>
+            <a:pPr>
+              <a:defRPr sz="1000" b="1">
+                <a:solidFill>
+                  <a:srgbClr val="FFFFFF"/>
+                </a:solidFill>
+              </a:defRPr>
+            </a:pPr>
+            <a:r>
+              <a:t>@SIH Idea submission- Template | Team: AyurSutra Innovators</a:t>
+            </a:r>
+          </a:p>
+        </p:txBody>
+      </p:sp>
+      <p:sp>
+        <p:nvSpPr>
+          <p:cNvPr id="8" name="TextBox 7"/>
+          <p:cNvSpPr txBox="1"/>
+          <p:nvPr/>
+        </p:nvSpPr>
+        <p:spPr>
+          <a:xfrm>
+            <a:off x="10789920" y="6446520"/>
+            <a:ext cx="731520" cy="365760"/>
+          </a:xfrm>
+          <a:prstGeom prst="rect">
+            <a:avLst/>
+          </a:prstGeom>
+          <a:noFill/>
+        </p:spPr>
+        <p:txBody>
+          <a:bodyPr wrap="none">
+            <a:spAutoFit/>
+          </a:bodyPr>
+          <a:lstStyle/>
+          <a:p>
             <a:pPr algn="r">
               <a:defRPr sz="1100" b="1">
                 <a:solidFill>
-                  <a:srgbClr val="D4AF37"/>
+                  <a:srgbClr val="FFFFFF"/>
                 </a:solidFill>
               </a:defRPr>
             </a:pPr>
@@ -4723,14 +5937,14 @@
       </p:sp>
       <p:sp>
         <p:nvSpPr>
-          <p:cNvPr id="8" name="Rounded Rectangle 7"/>
+          <p:cNvPr id="9" name="Rounded Rectangle 8"/>
           <p:cNvSpPr/>
           <p:nvPr/>
         </p:nvSpPr>
         <p:spPr>
           <a:xfrm>
-            <a:off x="731520" y="1280160"/>
-            <a:ext cx="10728655" cy="4846320"/>
+            <a:off x="731520" y="1188720"/>
+            <a:ext cx="6858000" cy="4937760"/>
           </a:xfrm>
           <a:prstGeom prst="roundRect">
             <a:avLst/>
@@ -4768,14 +5982,14 @@
       </p:sp>
       <p:sp>
         <p:nvSpPr>
-          <p:cNvPr id="9" name="TextBox 8"/>
+          <p:cNvPr id="10" name="TextBox 9"/>
           <p:cNvSpPr txBox="1"/>
           <p:nvPr/>
         </p:nvSpPr>
         <p:spPr>
           <a:xfrm>
-            <a:off x="914400" y="1371600"/>
-            <a:ext cx="10362895" cy="4663440"/>
+            <a:off x="914400" y="1280160"/>
+            <a:ext cx="6492240" cy="4754880"/>
           </a:xfrm>
           <a:prstGeom prst="rect">
             <a:avLst/>
@@ -4790,36 +6004,36 @@
           <a:p>
             <a:pPr>
               <a:spcAft>
-                <a:spcPts val="1000"/>
+                <a:spcPts val="800"/>
               </a:spcAft>
-              <a:defRPr sz="1400" b="1">
-                <a:solidFill>
-                  <a:srgbClr val="082419"/>
-                </a:solidFill>
-              </a:defRPr>
-            </a:pPr>
-            <a:r>
-              <a:t>FEASIBILITY ANALYSIS &amp; RISK MITIGATION MATRIX</a:t>
+              <a:defRPr sz="1300" b="1">
+                <a:solidFill>
+                  <a:srgbClr val="0F1E36"/>
+                </a:solidFill>
+              </a:defRPr>
+            </a:pPr>
+            <a:r>
+              <a:t>• Analysis of feasibility, risks &amp; mitigation strategies</a:t>
             </a:r>
           </a:p>
           <a:p>
             <a:pPr>
               <a:spcAft>
-                <a:spcPts val="500"/>
+                <a:spcPts val="400"/>
               </a:spcAft>
             </a:pPr>
             <a:r>
-              <a:rPr b="1" sz="1100">
-                <a:solidFill>
-                  <a:srgbClr val="082419"/>
+              <a:rPr b="1" sz="1000">
+                <a:solidFill>
+                  <a:srgbClr val="0F1E36"/>
                 </a:solidFill>
               </a:rPr>
-              <a:t>• Feasibility of Idea: </a:t>
-            </a:r>
-            <a:r>
-              <a:rPr sz="1100">
-                <a:solidFill>
-                  <a:srgbClr val="1C1917"/>
+              <a:t>• Analysis of Feasibility: </a:t>
+            </a:r>
+            <a:r>
+              <a:rPr sz="1000">
+                <a:solidFill>
+                  <a:srgbClr val="1E293B"/>
                 </a:solidFill>
               </a:rPr>
               <a:t>High feasibility with lightweight vanilla JS &amp; Tailwind CSS stack; runs locally on zero-overhead servers (Python/Node) without complex build steps.</a:t>
@@ -4828,21 +6042,21 @@
           <a:p>
             <a:pPr>
               <a:spcAft>
-                <a:spcPts val="500"/>
+                <a:spcPts val="400"/>
               </a:spcAft>
             </a:pPr>
             <a:r>
-              <a:rPr b="1" sz="1100">
-                <a:solidFill>
-                  <a:srgbClr val="082419"/>
+              <a:rPr b="1" sz="1000">
+                <a:solidFill>
+                  <a:srgbClr val="0F1E36"/>
                 </a:solidFill>
               </a:rPr>
-              <a:t>• Challenge 1: OCR Degradation: </a:t>
-            </a:r>
-            <a:r>
-              <a:rPr sz="1100">
-                <a:solidFill>
-                  <a:srgbClr val="1C1917"/>
+              <a:t>• Potential Challenge 1: </a:t>
+            </a:r>
+            <a:r>
+              <a:rPr sz="1000">
+                <a:solidFill>
+                  <a:srgbClr val="1E293B"/>
                 </a:solidFill>
               </a:rPr>
               <a:t>Low-resolution or poorly lit mobile photos of handwritten notes may yield lower OCR confidence score (&lt;70%).</a:t>
@@ -4851,21 +6065,21 @@
           <a:p>
             <a:pPr>
               <a:spcAft>
-                <a:spcPts val="500"/>
+                <a:spcPts val="400"/>
               </a:spcAft>
             </a:pPr>
             <a:r>
-              <a:rPr b="1" sz="1100">
+              <a:rPr b="1" sz="1000">
                 <a:solidFill>
                   <a:srgbClr val="059669"/>
                 </a:solidFill>
               </a:rPr>
-              <a:t>• Mitigation 1: </a:t>
-            </a:r>
-            <a:r>
-              <a:rPr sz="1100">
-                <a:solidFill>
-                  <a:srgbClr val="1C1917"/>
+              <a:t>• Mitigation Strategy 1: </a:t>
+            </a:r>
+            <a:r>
+              <a:rPr sz="1000">
+                <a:solidFill>
+                  <a:srgbClr val="1E293B"/>
                 </a:solidFill>
               </a:rPr>
               <a:t>Forced Verification Layer: Mandates patient/Vaidya manual review &amp; editing of extracted parameters before database insertion.</a:t>
@@ -4874,21 +6088,21 @@
           <a:p>
             <a:pPr>
               <a:spcAft>
-                <a:spcPts val="500"/>
+                <a:spcPts val="400"/>
               </a:spcAft>
             </a:pPr>
             <a:r>
-              <a:rPr b="1" sz="1100">
-                <a:solidFill>
-                  <a:srgbClr val="082419"/>
+              <a:rPr b="1" sz="1000">
+                <a:solidFill>
+                  <a:srgbClr val="0F1E36"/>
                 </a:solidFill>
               </a:rPr>
-              <a:t>• Challenge 2: Browser Audio Policies: </a:t>
-            </a:r>
-            <a:r>
-              <a:rPr sz="1100">
-                <a:solidFill>
-                  <a:srgbClr val="1C1917"/>
+              <a:t>• Potential Challenge 2: </a:t>
+            </a:r>
+            <a:r>
+              <a:rPr sz="1000">
+                <a:solidFill>
+                  <a:srgbClr val="1E293B"/>
                 </a:solidFill>
               </a:rPr>
               <a:t>Autoplay restrictions in modern browsers may mute Web Audio API soundscape chimes until user interaction occurs.</a:t>
@@ -4897,21 +6111,21 @@
           <a:p>
             <a:pPr>
               <a:spcAft>
-                <a:spcPts val="500"/>
+                <a:spcPts val="400"/>
               </a:spcAft>
             </a:pPr>
             <a:r>
-              <a:rPr b="1" sz="1100">
+              <a:rPr b="1" sz="1000">
                 <a:solidFill>
                   <a:srgbClr val="059669"/>
                 </a:solidFill>
               </a:rPr>
-              <a:t>• Mitigation 2: </a:t>
-            </a:r>
-            <a:r>
-              <a:rPr sz="1100">
-                <a:solidFill>
-                  <a:srgbClr val="1C1917"/>
+              <a:t>• Mitigation Strategy 2: </a:t>
+            </a:r>
+            <a:r>
+              <a:rPr sz="1000">
+                <a:solidFill>
+                  <a:srgbClr val="1E293B"/>
                 </a:solidFill>
               </a:rPr>
               <a:t>Explicit User Gesture Handlers: Triggers audio chimes via click events (btn-audio-toggle) with status feedback.</a:t>
@@ -4920,21 +6134,21 @@
           <a:p>
             <a:pPr>
               <a:spcAft>
-                <a:spcPts val="500"/>
+                <a:spcPts val="400"/>
               </a:spcAft>
             </a:pPr>
             <a:r>
-              <a:rPr b="1" sz="1100">
-                <a:solidFill>
-                  <a:srgbClr val="082419"/>
+              <a:rPr b="1" sz="1000">
+                <a:solidFill>
+                  <a:srgbClr val="0F1E36"/>
                 </a:solidFill>
               </a:rPr>
-              <a:t>• Challenge 3: Offline Clinic Needs: </a:t>
-            </a:r>
-            <a:r>
-              <a:rPr sz="1100">
-                <a:solidFill>
-                  <a:srgbClr val="1C1917"/>
+              <a:t>• Potential Challenge 3: </a:t>
+            </a:r>
+            <a:r>
+              <a:rPr sz="1000">
+                <a:solidFill>
+                  <a:srgbClr val="1E293B"/>
                 </a:solidFill>
               </a:rPr>
               <a:t>Rural Ayush clinics may lack continuous high-speed internet connectivity for cloud databases.</a:t>
@@ -4943,21 +6157,21 @@
           <a:p>
             <a:pPr>
               <a:spcAft>
-                <a:spcPts val="500"/>
+                <a:spcPts val="400"/>
               </a:spcAft>
             </a:pPr>
             <a:r>
-              <a:rPr b="1" sz="1100">
+              <a:rPr b="1" sz="1000">
                 <a:solidFill>
                   <a:srgbClr val="059669"/>
                 </a:solidFill>
               </a:rPr>
-              <a:t>• Mitigation 3: </a:t>
-            </a:r>
-            <a:r>
-              <a:rPr sz="1100">
-                <a:solidFill>
-                  <a:srgbClr val="1C1917"/>
+              <a:t>• Mitigation Strategy 3: </a:t>
+            </a:r>
+            <a:r>
+              <a:rPr sz="1000">
+                <a:solidFill>
+                  <a:srgbClr val="1E293B"/>
                 </a:solidFill>
               </a:rPr>
               <a:t>Local SQL Script Exporter: Enables offline local persistence with 1-click .sql file download for batch phpMyAdmin sync.</a:t>
@@ -4965,6 +6179,110 @@
           </a:p>
         </p:txBody>
       </p:sp>
+      <p:sp>
+        <p:nvSpPr>
+          <p:cNvPr id="11" name="Rounded Rectangle 10"/>
+          <p:cNvSpPr/>
+          <p:nvPr/>
+        </p:nvSpPr>
+        <p:spPr>
+          <a:xfrm>
+            <a:off x="7772400" y="1188720"/>
+            <a:ext cx="3657600" cy="4937760"/>
+          </a:xfrm>
+          <a:prstGeom prst="roundRect">
+            <a:avLst/>
+          </a:prstGeom>
+          <a:solidFill>
+            <a:srgbClr val="FFFFFF"/>
+          </a:solidFill>
+          <a:ln w="25400">
+            <a:solidFill>
+              <a:srgbClr val="0284C7"/>
+            </a:solidFill>
+          </a:ln>
+        </p:spPr>
+        <p:style>
+          <a:lnRef idx="1">
+            <a:schemeClr val="accent1"/>
+          </a:lnRef>
+          <a:fillRef idx="3">
+            <a:schemeClr val="accent1"/>
+          </a:fillRef>
+          <a:effectRef idx="2">
+            <a:schemeClr val="accent1"/>
+          </a:effectRef>
+          <a:fontRef idx="minor">
+            <a:schemeClr val="lt1"/>
+          </a:fontRef>
+        </p:style>
+        <p:txBody>
+          <a:bodyPr rtlCol="0" anchor="ctr"/>
+          <a:lstStyle/>
+          <a:p>
+            <a:pPr algn="ctr"/>
+          </a:p>
+        </p:txBody>
+      </p:sp>
+      <p:sp>
+        <p:nvSpPr>
+          <p:cNvPr id="12" name="TextBox 11"/>
+          <p:cNvSpPr txBox="1"/>
+          <p:nvPr/>
+        </p:nvSpPr>
+        <p:spPr>
+          <a:xfrm>
+            <a:off x="7863840" y="1280160"/>
+            <a:ext cx="3474720" cy="365760"/>
+          </a:xfrm>
+          <a:prstGeom prst="rect">
+            <a:avLst/>
+          </a:prstGeom>
+          <a:noFill/>
+        </p:spPr>
+        <p:txBody>
+          <a:bodyPr wrap="none">
+            <a:spAutoFit/>
+          </a:bodyPr>
+          <a:lstStyle/>
+          <a:p>
+            <a:pPr>
+              <a:defRPr sz="1000" b="1">
+                <a:solidFill>
+                  <a:srgbClr val="0F1E36"/>
+                </a:solidFill>
+              </a:defRPr>
+            </a:pPr>
+            <a:r>
+              <a:t>PROTOTYPE: FORCED VERIFICATION UI</a:t>
+            </a:r>
+          </a:p>
+        </p:txBody>
+      </p:sp>
+      <p:pic>
+        <p:nvPicPr>
+          <p:cNvPr id="13" name="Picture 12" descr="03_forced_manual_verification.png"/>
+          <p:cNvPicPr>
+            <a:picLocks noChangeAspect="1"/>
+          </p:cNvPicPr>
+          <p:nvPr/>
+        </p:nvPicPr>
+        <p:blipFill>
+          <a:blip r:embed="rId2"/>
+          <a:stretch>
+            <a:fillRect/>
+          </a:stretch>
+        </p:blipFill>
+        <p:spPr>
+          <a:xfrm>
+            <a:off x="7863840" y="1691640"/>
+            <a:ext cx="3474720" cy="1650492"/>
+          </a:xfrm>
+          <a:prstGeom prst="rect">
+            <a:avLst/>
+          </a:prstGeom>
+        </p:spPr>
+      </p:pic>
     </p:spTree>
   </p:cSld>
   <p:clrMapOvr>
@@ -4992,18 +6310,16 @@
         <p:spPr>
           <a:xfrm>
             <a:off x="0" y="0"/>
-            <a:ext cx="12191695" cy="109728"/>
+            <a:ext cx="12191695" cy="6858000"/>
           </a:xfrm>
           <a:prstGeom prst="rect">
             <a:avLst/>
           </a:prstGeom>
           <a:solidFill>
-            <a:srgbClr val="D4AF37"/>
+            <a:srgbClr val="F8FAFC"/>
           </a:solidFill>
           <a:ln>
-            <a:solidFill>
-              <a:srgbClr val="D4AF37"/>
-            </a:solidFill>
+            <a:noFill/>
           </a:ln>
         </p:spPr>
         <p:style>
@@ -5030,95 +6346,24 @@
       </p:sp>
       <p:sp>
         <p:nvSpPr>
-          <p:cNvPr id="3" name="TextBox 2"/>
-          <p:cNvSpPr txBox="1"/>
-          <p:nvPr/>
-        </p:nvSpPr>
-        <p:spPr>
-          <a:xfrm>
-            <a:off x="731520" y="365760"/>
-            <a:ext cx="10728655" cy="731520"/>
+          <p:cNvPr id="3" name="Rectangle 2"/>
+          <p:cNvSpPr/>
+          <p:nvPr/>
+        </p:nvSpPr>
+        <p:spPr>
+          <a:xfrm>
+            <a:off x="0" y="0"/>
+            <a:ext cx="12191695" cy="91440"/>
           </a:xfrm>
           <a:prstGeom prst="rect">
             <a:avLst/>
           </a:prstGeom>
-          <a:noFill/>
-        </p:spPr>
-        <p:txBody>
-          <a:bodyPr wrap="square">
-            <a:spAutoFit/>
-          </a:bodyPr>
-          <a:lstStyle/>
-          <a:p>
-            <a:pPr>
-              <a:defRPr sz="2200" b="1">
-                <a:solidFill>
-                  <a:srgbClr val="082419"/>
-                </a:solidFill>
-                <a:latin typeface="Georgia"/>
-              </a:defRPr>
-            </a:pPr>
-            <a:r>
-              <a:t>SYSTEM IMPACT, SOCIAL &amp; ECONOMIC BENEFITS</a:t>
-            </a:r>
-          </a:p>
-        </p:txBody>
-      </p:sp>
-      <p:sp>
-        <p:nvSpPr>
-          <p:cNvPr id="4" name="TextBox 3"/>
-          <p:cNvSpPr txBox="1"/>
-          <p:nvPr/>
-        </p:nvSpPr>
-        <p:spPr>
-          <a:xfrm>
-            <a:off x="8686800" y="320040"/>
-            <a:ext cx="2743200" cy="548640"/>
-          </a:xfrm>
-          <a:prstGeom prst="rect">
-            <a:avLst/>
-          </a:prstGeom>
-          <a:noFill/>
-        </p:spPr>
-        <p:txBody>
-          <a:bodyPr wrap="none">
-            <a:spAutoFit/>
-          </a:bodyPr>
-          <a:lstStyle/>
-          <a:p>
-            <a:pPr algn="r">
-              <a:defRPr sz="1000" b="1">
-                <a:solidFill>
-                  <a:srgbClr val="059669"/>
-                </a:solidFill>
-              </a:defRPr>
-            </a:pPr>
-            <a:r>
-              <a:t>SMART INDIA HACKATHON 2025</a:t>
-            </a:r>
-          </a:p>
-        </p:txBody>
-      </p:sp>
-      <p:sp>
-        <p:nvSpPr>
-          <p:cNvPr id="5" name="Rectangle 4"/>
-          <p:cNvSpPr/>
-          <p:nvPr/>
-        </p:nvSpPr>
-        <p:spPr>
-          <a:xfrm>
-            <a:off x="0" y="6400800"/>
-            <a:ext cx="12191695" cy="457200"/>
-          </a:xfrm>
-          <a:prstGeom prst="rect">
-            <a:avLst/>
-          </a:prstGeom>
           <a:solidFill>
-            <a:srgbClr val="047857"/>
+            <a:srgbClr val="0284C7"/>
           </a:solidFill>
           <a:ln>
             <a:solidFill>
-              <a:srgbClr val="047857"/>
+              <a:srgbClr val="0284C7"/>
             </a:solidFill>
           </a:ln>
         </p:spPr>
@@ -5146,14 +6391,50 @@
       </p:sp>
       <p:sp>
         <p:nvSpPr>
-          <p:cNvPr id="6" name="TextBox 5"/>
+          <p:cNvPr id="4" name="TextBox 3"/>
           <p:cNvSpPr txBox="1"/>
           <p:nvPr/>
         </p:nvSpPr>
         <p:spPr>
           <a:xfrm>
-            <a:off x="731520" y="6446520"/>
-            <a:ext cx="9144000" cy="365760"/>
+            <a:off x="731520" y="320040"/>
+            <a:ext cx="8229600" cy="731520"/>
+          </a:xfrm>
+          <a:prstGeom prst="rect">
+            <a:avLst/>
+          </a:prstGeom>
+          <a:noFill/>
+        </p:spPr>
+        <p:txBody>
+          <a:bodyPr wrap="square">
+            <a:spAutoFit/>
+          </a:bodyPr>
+          <a:lstStyle/>
+          <a:p>
+            <a:pPr>
+              <a:defRPr sz="2200" b="1">
+                <a:solidFill>
+                  <a:srgbClr val="0F1E36"/>
+                </a:solidFill>
+                <a:latin typeface="Georgia"/>
+              </a:defRPr>
+            </a:pPr>
+            <a:r>
+              <a:t>IMPACT AND BENEFITS OF SOLUTION</a:t>
+            </a:r>
+          </a:p>
+        </p:txBody>
+      </p:sp>
+      <p:sp>
+        <p:nvSpPr>
+          <p:cNvPr id="5" name="TextBox 4"/>
+          <p:cNvSpPr txBox="1"/>
+          <p:nvPr/>
+        </p:nvSpPr>
+        <p:spPr>
+          <a:xfrm>
+            <a:off x="8412480" y="320040"/>
+            <a:ext cx="3017520" cy="548640"/>
           </a:xfrm>
           <a:prstGeom prst="rect">
             <a:avLst/>
@@ -5166,16 +6447,73 @@
           </a:bodyPr>
           <a:lstStyle/>
           <a:p>
-            <a:pPr>
-              <a:defRPr sz="1000">
-                <a:solidFill>
-                  <a:srgbClr val="F5F5F4"/>
-                </a:solidFill>
-              </a:defRPr>
-            </a:pPr>
-            <a:r>
-              <a:t>@SIH Idea submission- Template | Team: AyurSutra Innovators</a:t>
-            </a:r>
+            <a:pPr algn="r">
+              <a:defRPr sz="1100" b="1">
+                <a:solidFill>
+                  <a:srgbClr val="E36209"/>
+                </a:solidFill>
+              </a:defRPr>
+            </a:pPr>
+            <a:r>
+              <a:t>SMART INDIA HACKATHON 2025</a:t>
+            </a:r>
+          </a:p>
+          <a:p>
+            <a:pPr algn="r">
+              <a:defRPr sz="900">
+                <a:solidFill>
+                  <a:srgbClr val="64748B"/>
+                </a:solidFill>
+              </a:defRPr>
+            </a:pPr>
+            <a:r>
+              <a:t>Official Idea Submission Template</a:t>
+            </a:r>
+          </a:p>
+        </p:txBody>
+      </p:sp>
+      <p:sp>
+        <p:nvSpPr>
+          <p:cNvPr id="6" name="Rectangle 5"/>
+          <p:cNvSpPr/>
+          <p:nvPr/>
+        </p:nvSpPr>
+        <p:spPr>
+          <a:xfrm>
+            <a:off x="0" y="6400800"/>
+            <a:ext cx="12191695" cy="457200"/>
+          </a:xfrm>
+          <a:prstGeom prst="rect">
+            <a:avLst/>
+          </a:prstGeom>
+          <a:solidFill>
+            <a:srgbClr val="0284C7"/>
+          </a:solidFill>
+          <a:ln>
+            <a:solidFill>
+              <a:srgbClr val="0284C7"/>
+            </a:solidFill>
+          </a:ln>
+        </p:spPr>
+        <p:style>
+          <a:lnRef idx="1">
+            <a:schemeClr val="accent1"/>
+          </a:lnRef>
+          <a:fillRef idx="3">
+            <a:schemeClr val="accent1"/>
+          </a:fillRef>
+          <a:effectRef idx="2">
+            <a:schemeClr val="accent1"/>
+          </a:effectRef>
+          <a:fontRef idx="minor">
+            <a:schemeClr val="lt1"/>
+          </a:fontRef>
+        </p:style>
+        <p:txBody>
+          <a:bodyPr rtlCol="0" anchor="ctr"/>
+          <a:lstStyle/>
+          <a:p>
+            <a:pPr algn="ctr"/>
           </a:p>
         </p:txBody>
       </p:sp>
@@ -5187,8 +6525,8 @@
         </p:nvSpPr>
         <p:spPr>
           <a:xfrm>
-            <a:off x="10515600" y="6446520"/>
-            <a:ext cx="914400" cy="365760"/>
+            <a:off x="731520" y="6446520"/>
+            <a:ext cx="9144000" cy="365760"/>
           </a:xfrm>
           <a:prstGeom prst="rect">
             <a:avLst/>
@@ -5201,10 +6539,45 @@
           </a:bodyPr>
           <a:lstStyle/>
           <a:p>
+            <a:pPr>
+              <a:defRPr sz="1000" b="1">
+                <a:solidFill>
+                  <a:srgbClr val="FFFFFF"/>
+                </a:solidFill>
+              </a:defRPr>
+            </a:pPr>
+            <a:r>
+              <a:t>@SIH Idea submission- Template | Team: AyurSutra Innovators</a:t>
+            </a:r>
+          </a:p>
+        </p:txBody>
+      </p:sp>
+      <p:sp>
+        <p:nvSpPr>
+          <p:cNvPr id="8" name="TextBox 7"/>
+          <p:cNvSpPr txBox="1"/>
+          <p:nvPr/>
+        </p:nvSpPr>
+        <p:spPr>
+          <a:xfrm>
+            <a:off x="10789920" y="6446520"/>
+            <a:ext cx="731520" cy="365760"/>
+          </a:xfrm>
+          <a:prstGeom prst="rect">
+            <a:avLst/>
+          </a:prstGeom>
+          <a:noFill/>
+        </p:spPr>
+        <p:txBody>
+          <a:bodyPr wrap="none">
+            <a:spAutoFit/>
+          </a:bodyPr>
+          <a:lstStyle/>
+          <a:p>
             <a:pPr algn="r">
               <a:defRPr sz="1100" b="1">
                 <a:solidFill>
-                  <a:srgbClr val="D4AF37"/>
+                  <a:srgbClr val="FFFFFF"/>
                 </a:solidFill>
               </a:defRPr>
             </a:pPr>
@@ -5216,14 +6589,14 @@
       </p:sp>
       <p:sp>
         <p:nvSpPr>
-          <p:cNvPr id="8" name="Rounded Rectangle 7"/>
+          <p:cNvPr id="9" name="Rounded Rectangle 8"/>
           <p:cNvSpPr/>
           <p:nvPr/>
         </p:nvSpPr>
         <p:spPr>
           <a:xfrm>
-            <a:off x="731520" y="1280160"/>
-            <a:ext cx="2560320" cy="1371600"/>
+            <a:off x="731520" y="1188720"/>
+            <a:ext cx="1572768" cy="1280160"/>
           </a:xfrm>
           <a:prstGeom prst="roundRect">
             <a:avLst/>
@@ -5233,7 +6606,7 @@
           </a:solidFill>
           <a:ln w="25400">
             <a:solidFill>
-              <a:srgbClr val="082419"/>
+              <a:srgbClr val="0F1E36"/>
             </a:solidFill>
           </a:ln>
         </p:spPr>
@@ -5261,14 +6634,14 @@
       </p:sp>
       <p:sp>
         <p:nvSpPr>
-          <p:cNvPr id="9" name="TextBox 8"/>
+          <p:cNvPr id="10" name="TextBox 9"/>
           <p:cNvSpPr txBox="1"/>
           <p:nvPr/>
         </p:nvSpPr>
         <p:spPr>
           <a:xfrm>
-            <a:off x="822960" y="1371600"/>
-            <a:ext cx="2377440" cy="1188720"/>
+            <a:off x="777240" y="1234440"/>
+            <a:ext cx="1481328" cy="1188720"/>
           </a:xfrm>
           <a:prstGeom prst="rect">
             <a:avLst/>
@@ -5282,9 +6655,9 @@
           <a:lstStyle/>
           <a:p>
             <a:pPr algn="ctr">
-              <a:defRPr sz="2800" b="1">
-                <a:solidFill>
-                  <a:srgbClr val="082419"/>
+              <a:defRPr sz="2200" b="1">
+                <a:solidFill>
+                  <a:srgbClr val="0F1E36"/>
                 </a:solidFill>
               </a:defRPr>
             </a:pPr>
@@ -5294,28 +6667,28 @@
           </a:p>
           <a:p>
             <a:pPr algn="ctr">
-              <a:defRPr sz="1000" b="1">
-                <a:solidFill>
-                  <a:srgbClr val="1C1917"/>
-                </a:solidFill>
-              </a:defRPr>
-            </a:pPr>
-            <a:r>
-              <a:t>Intake Turnaround Reduction</a:t>
-            </a:r>
-          </a:p>
-        </p:txBody>
-      </p:sp>
-      <p:sp>
-        <p:nvSpPr>
-          <p:cNvPr id="10" name="Rounded Rectangle 9"/>
+              <a:defRPr sz="900" b="1">
+                <a:solidFill>
+                  <a:srgbClr val="1E293B"/>
+                </a:solidFill>
+              </a:defRPr>
+            </a:pPr>
+            <a:r>
+              <a:t>Intake Turnaround Speedup</a:t>
+            </a:r>
+          </a:p>
+        </p:txBody>
+      </p:sp>
+      <p:sp>
+        <p:nvSpPr>
+          <p:cNvPr id="11" name="Rounded Rectangle 10"/>
           <p:cNvSpPr/>
           <p:nvPr/>
         </p:nvSpPr>
         <p:spPr>
           <a:xfrm>
-            <a:off x="3456432" y="1280160"/>
-            <a:ext cx="2560320" cy="1371600"/>
+            <a:off x="2423160" y="1188720"/>
+            <a:ext cx="1572768" cy="1280160"/>
           </a:xfrm>
           <a:prstGeom prst="roundRect">
             <a:avLst/>
@@ -5353,14 +6726,14 @@
       </p:sp>
       <p:sp>
         <p:nvSpPr>
-          <p:cNvPr id="11" name="TextBox 10"/>
+          <p:cNvPr id="12" name="TextBox 11"/>
           <p:cNvSpPr txBox="1"/>
           <p:nvPr/>
         </p:nvSpPr>
         <p:spPr>
           <a:xfrm>
-            <a:off x="3547872" y="1371600"/>
-            <a:ext cx="2377440" cy="1188720"/>
+            <a:off x="2468880" y="1234440"/>
+            <a:ext cx="1481328" cy="1188720"/>
           </a:xfrm>
           <a:prstGeom prst="rect">
             <a:avLst/>
@@ -5374,7 +6747,7 @@
           <a:lstStyle/>
           <a:p>
             <a:pPr algn="ctr">
-              <a:defRPr sz="2800" b="1">
+              <a:defRPr sz="2200" b="1">
                 <a:solidFill>
                   <a:srgbClr val="059669"/>
                 </a:solidFill>
@@ -5386,28 +6759,28 @@
           </a:p>
           <a:p>
             <a:pPr algn="ctr">
-              <a:defRPr sz="1000" b="1">
-                <a:solidFill>
-                  <a:srgbClr val="1C1917"/>
-                </a:solidFill>
-              </a:defRPr>
-            </a:pPr>
-            <a:r>
-              <a:t>Clinical Matching Accuracy</a:t>
-            </a:r>
-          </a:p>
-        </p:txBody>
-      </p:sp>
-      <p:sp>
-        <p:nvSpPr>
-          <p:cNvPr id="12" name="Rounded Rectangle 11"/>
+              <a:defRPr sz="900" b="1">
+                <a:solidFill>
+                  <a:srgbClr val="1E293B"/>
+                </a:solidFill>
+              </a:defRPr>
+            </a:pPr>
+            <a:r>
+              <a:t>Clinical Vaidya Match</a:t>
+            </a:r>
+          </a:p>
+        </p:txBody>
+      </p:sp>
+      <p:sp>
+        <p:nvSpPr>
+          <p:cNvPr id="13" name="Rounded Rectangle 12"/>
           <p:cNvSpPr/>
           <p:nvPr/>
         </p:nvSpPr>
         <p:spPr>
           <a:xfrm>
-            <a:off x="6181344" y="1280160"/>
-            <a:ext cx="2560320" cy="1371600"/>
+            <a:off x="4114800" y="1188720"/>
+            <a:ext cx="1572768" cy="1280160"/>
           </a:xfrm>
           <a:prstGeom prst="roundRect">
             <a:avLst/>
@@ -5417,7 +6790,7 @@
           </a:solidFill>
           <a:ln w="25400">
             <a:solidFill>
-              <a:srgbClr val="D4AF37"/>
+              <a:srgbClr val="E36209"/>
             </a:solidFill>
           </a:ln>
         </p:spPr>
@@ -5445,14 +6818,14 @@
       </p:sp>
       <p:sp>
         <p:nvSpPr>
-          <p:cNvPr id="13" name="TextBox 12"/>
+          <p:cNvPr id="14" name="TextBox 13"/>
           <p:cNvSpPr txBox="1"/>
           <p:nvPr/>
         </p:nvSpPr>
         <p:spPr>
           <a:xfrm>
-            <a:off x="6272784" y="1371600"/>
-            <a:ext cx="2377440" cy="1188720"/>
+            <a:off x="4160520" y="1234440"/>
+            <a:ext cx="1481328" cy="1188720"/>
           </a:xfrm>
           <a:prstGeom prst="rect">
             <a:avLst/>
@@ -5466,9 +6839,9 @@
           <a:lstStyle/>
           <a:p>
             <a:pPr algn="ctr">
-              <a:defRPr sz="2800" b="1">
-                <a:solidFill>
-                  <a:srgbClr val="D4AF37"/>
+              <a:defRPr sz="2200" b="1">
+                <a:solidFill>
+                  <a:srgbClr val="E36209"/>
                 </a:solidFill>
               </a:defRPr>
             </a:pPr>
@@ -5478,9 +6851,9 @@
           </a:p>
           <a:p>
             <a:pPr algn="ctr">
-              <a:defRPr sz="1000" b="1">
-                <a:solidFill>
-                  <a:srgbClr val="1C1917"/>
+              <a:defRPr sz="900" b="1">
+                <a:solidFill>
+                  <a:srgbClr val="1E293B"/>
                 </a:solidFill>
               </a:defRPr>
             </a:pPr>
@@ -5492,14 +6865,14 @@
       </p:sp>
       <p:sp>
         <p:nvSpPr>
-          <p:cNvPr id="14" name="Rounded Rectangle 13"/>
+          <p:cNvPr id="15" name="Rounded Rectangle 14"/>
           <p:cNvSpPr/>
           <p:nvPr/>
         </p:nvSpPr>
         <p:spPr>
           <a:xfrm>
-            <a:off x="8906256" y="1280160"/>
-            <a:ext cx="2560320" cy="1371600"/>
+            <a:off x="5806440" y="1188720"/>
+            <a:ext cx="1572768" cy="1280160"/>
           </a:xfrm>
           <a:prstGeom prst="roundRect">
             <a:avLst/>
@@ -5509,7 +6882,7 @@
           </a:solidFill>
           <a:ln w="25400">
             <a:solidFill>
-              <a:srgbClr val="082419"/>
+              <a:srgbClr val="0F1E36"/>
             </a:solidFill>
           </a:ln>
         </p:spPr>
@@ -5537,14 +6910,14 @@
       </p:sp>
       <p:sp>
         <p:nvSpPr>
-          <p:cNvPr id="15" name="TextBox 14"/>
+          <p:cNvPr id="16" name="TextBox 15"/>
           <p:cNvSpPr txBox="1"/>
           <p:nvPr/>
         </p:nvSpPr>
         <p:spPr>
           <a:xfrm>
-            <a:off x="8997696" y="1371600"/>
-            <a:ext cx="2377440" cy="1188720"/>
+            <a:off x="5852160" y="1234440"/>
+            <a:ext cx="1481328" cy="1188720"/>
           </a:xfrm>
           <a:prstGeom prst="rect">
             <a:avLst/>
@@ -5558,9 +6931,9 @@
           <a:lstStyle/>
           <a:p>
             <a:pPr algn="ctr">
-              <a:defRPr sz="2800" b="1">
-                <a:solidFill>
-                  <a:srgbClr val="082419"/>
+              <a:defRPr sz="2200" b="1">
+                <a:solidFill>
+                  <a:srgbClr val="0F1E36"/>
                 </a:solidFill>
               </a:defRPr>
             </a:pPr>
@@ -5570,9 +6943,9 @@
           </a:p>
           <a:p>
             <a:pPr algn="ctr">
-              <a:defRPr sz="1000" b="1">
-                <a:solidFill>
-                  <a:srgbClr val="1C1917"/>
+              <a:defRPr sz="900" b="1">
+                <a:solidFill>
+                  <a:srgbClr val="1E293B"/>
                 </a:solidFill>
               </a:defRPr>
             </a:pPr>
@@ -5584,14 +6957,14 @@
       </p:sp>
       <p:sp>
         <p:nvSpPr>
-          <p:cNvPr id="16" name="Rounded Rectangle 15"/>
+          <p:cNvPr id="17" name="Rounded Rectangle 16"/>
           <p:cNvSpPr/>
           <p:nvPr/>
         </p:nvSpPr>
         <p:spPr>
           <a:xfrm>
-            <a:off x="731520" y="2926080"/>
-            <a:ext cx="10728655" cy="3200400"/>
+            <a:off x="731520" y="2651760"/>
+            <a:ext cx="6858000" cy="3474720"/>
           </a:xfrm>
           <a:prstGeom prst="roundRect">
             <a:avLst/>
@@ -5629,14 +7002,14 @@
       </p:sp>
       <p:sp>
         <p:nvSpPr>
-          <p:cNvPr id="17" name="TextBox 16"/>
+          <p:cNvPr id="18" name="TextBox 17"/>
           <p:cNvSpPr txBox="1"/>
           <p:nvPr/>
         </p:nvSpPr>
         <p:spPr>
           <a:xfrm>
-            <a:off x="914400" y="3017520"/>
-            <a:ext cx="10362895" cy="3017520"/>
+            <a:off x="914400" y="2743200"/>
+            <a:ext cx="6492240" cy="3291840"/>
           </a:xfrm>
           <a:prstGeom prst="rect">
             <a:avLst/>
@@ -5648,74 +7021,74 @@
             <a:spAutoFit/>
           </a:bodyPr>
           <a:lstStyle/>
-          <a:p>
-            <a:pPr>
-              <a:spcAft>
-                <a:spcPts val="800"/>
-              </a:spcAft>
-              <a:defRPr sz="1400" b="1">
-                <a:solidFill>
-                  <a:srgbClr val="082419"/>
-                </a:solidFill>
-              </a:defRPr>
-            </a:pPr>
-            <a:r>
-              <a:t>TARGET AUDIENCE IMPACT &amp; BROAD BENEFITS</a:t>
-            </a:r>
-          </a:p>
           <a:p>
             <a:pPr>
               <a:spcAft>
                 <a:spcPts val="600"/>
               </a:spcAft>
-              <a:defRPr sz="1100">
-                <a:solidFill>
-                  <a:srgbClr val="1C1917"/>
-                </a:solidFill>
-              </a:defRPr>
-            </a:pPr>
-            <a:r>
-              <a:t>• Target Audience Reach: Serves 500+ Ayush hospitals, Panchakarma sanctuaries, Vaidyas, Acharyas, and patients seeking authentic classical treatments.</a:t>
+              <a:defRPr sz="1200" b="1">
+                <a:solidFill>
+                  <a:srgbClr val="0F1E36"/>
+                </a:solidFill>
+              </a:defRPr>
+            </a:pPr>
+            <a:r>
+              <a:t>• Potential impact &amp; broad benefits (social, economic, environmental)</a:t>
             </a:r>
           </a:p>
           <a:p>
             <a:pPr>
               <a:spcAft>
-                <a:spcPts val="600"/>
+                <a:spcPts val="500"/>
               </a:spcAft>
-              <a:defRPr sz="1100">
-                <a:solidFill>
-                  <a:srgbClr val="1C1917"/>
-                </a:solidFill>
-              </a:defRPr>
-            </a:pPr>
-            <a:r>
-              <a:t>• Social Benefits: Standardizes traditional Indian medicine (Ayurveda) digitized infrastructure, facilitating public trust and formal healthcare Integration.</a:t>
+              <a:defRPr sz="1000">
+                <a:solidFill>
+                  <a:srgbClr val="1E293B"/>
+                </a:solidFill>
+              </a:defRPr>
+            </a:pPr>
+            <a:r>
+              <a:t>• Potential Impact on Target Audience: Serves 500+ Ayush hospitals, Panchakarma sanctuaries, Vaidyas, Acharyas, and patients seeking authentic classical treatments.</a:t>
             </a:r>
           </a:p>
           <a:p>
             <a:pPr>
               <a:spcAft>
-                <a:spcPts val="600"/>
+                <a:spcPts val="500"/>
               </a:spcAft>
-              <a:defRPr sz="1100">
-                <a:solidFill>
-                  <a:srgbClr val="1C1917"/>
-                </a:solidFill>
-              </a:defRPr>
-            </a:pPr>
-            <a:r>
-              <a:t>• Economic Benefits: Enables cashless Ayush TPA insurance claims, transparent hospital billing, and reduces operational overhead costs by up to 35%.</a:t>
+              <a:defRPr sz="1000">
+                <a:solidFill>
+                  <a:srgbClr val="1E293B"/>
+                </a:solidFill>
+              </a:defRPr>
+            </a:pPr>
+            <a:r>
+              <a:t>• Social Benefits: Standardizes traditional Indian medicine (Ayurveda) digitized infrastructure, facilitating public trust and formal healthcare Integration.</a:t>
             </a:r>
           </a:p>
           <a:p>
             <a:pPr>
               <a:spcAft>
-                <a:spcPts val="600"/>
+                <a:spcPts val="500"/>
               </a:spcAft>
-              <a:defRPr sz="1100">
-                <a:solidFill>
-                  <a:srgbClr val="1C1917"/>
+              <a:defRPr sz="1000">
+                <a:solidFill>
+                  <a:srgbClr val="1E293B"/>
+                </a:solidFill>
+              </a:defRPr>
+            </a:pPr>
+            <a:r>
+              <a:t>• Economic Benefits: Enables cashless Ayush TPA insurance claims, transparent hospital billing, and reduces operational overhead costs by up to 35%.</a:t>
+            </a:r>
+          </a:p>
+          <a:p>
+            <a:pPr>
+              <a:spcAft>
+                <a:spcPts val="500"/>
+              </a:spcAft>
+              <a:defRPr sz="1000">
+                <a:solidFill>
+                  <a:srgbClr val="1E293B"/>
                 </a:solidFill>
               </a:defRPr>
             </a:pPr>
@@ -5725,6 +7098,110 @@
           </a:p>
         </p:txBody>
       </p:sp>
+      <p:sp>
+        <p:nvSpPr>
+          <p:cNvPr id="19" name="Rounded Rectangle 18"/>
+          <p:cNvSpPr/>
+          <p:nvPr/>
+        </p:nvSpPr>
+        <p:spPr>
+          <a:xfrm>
+            <a:off x="7772400" y="1188720"/>
+            <a:ext cx="3657600" cy="4937760"/>
+          </a:xfrm>
+          <a:prstGeom prst="roundRect">
+            <a:avLst/>
+          </a:prstGeom>
+          <a:solidFill>
+            <a:srgbClr val="FFFFFF"/>
+          </a:solidFill>
+          <a:ln w="25400">
+            <a:solidFill>
+              <a:srgbClr val="059669"/>
+            </a:solidFill>
+          </a:ln>
+        </p:spPr>
+        <p:style>
+          <a:lnRef idx="1">
+            <a:schemeClr val="accent1"/>
+          </a:lnRef>
+          <a:fillRef idx="3">
+            <a:schemeClr val="accent1"/>
+          </a:fillRef>
+          <a:effectRef idx="2">
+            <a:schemeClr val="accent1"/>
+          </a:effectRef>
+          <a:fontRef idx="minor">
+            <a:schemeClr val="lt1"/>
+          </a:fontRef>
+        </p:style>
+        <p:txBody>
+          <a:bodyPr rtlCol="0" anchor="ctr"/>
+          <a:lstStyle/>
+          <a:p>
+            <a:pPr algn="ctr"/>
+          </a:p>
+        </p:txBody>
+      </p:sp>
+      <p:sp>
+        <p:nvSpPr>
+          <p:cNvPr id="20" name="TextBox 19"/>
+          <p:cNvSpPr txBox="1"/>
+          <p:nvPr/>
+        </p:nvSpPr>
+        <p:spPr>
+          <a:xfrm>
+            <a:off x="7863840" y="1280160"/>
+            <a:ext cx="3474720" cy="365760"/>
+          </a:xfrm>
+          <a:prstGeom prst="rect">
+            <a:avLst/>
+          </a:prstGeom>
+          <a:noFill/>
+        </p:spPr>
+        <p:txBody>
+          <a:bodyPr wrap="none">
+            <a:spAutoFit/>
+          </a:bodyPr>
+          <a:lstStyle/>
+          <a:p>
+            <a:pPr>
+              <a:defRPr sz="1000" b="1">
+                <a:solidFill>
+                  <a:srgbClr val="0F1E36"/>
+                </a:solidFill>
+              </a:defRPr>
+            </a:pPr>
+            <a:r>
+              <a:t>PROTOTYPE: MATCHED VAIDYAS UI</a:t>
+            </a:r>
+          </a:p>
+        </p:txBody>
+      </p:sp>
+      <p:pic>
+        <p:nvPicPr>
+          <p:cNvPr id="21" name="Picture 20" descr="04_matched_adequate_vaidyas.png"/>
+          <p:cNvPicPr>
+            <a:picLocks noChangeAspect="1"/>
+          </p:cNvPicPr>
+          <p:nvPr/>
+        </p:nvPicPr>
+        <p:blipFill>
+          <a:blip r:embed="rId2"/>
+          <a:stretch>
+            <a:fillRect/>
+          </a:stretch>
+        </p:blipFill>
+        <p:spPr>
+          <a:xfrm>
+            <a:off x="7863840" y="1691640"/>
+            <a:ext cx="3474720" cy="1650492"/>
+          </a:xfrm>
+          <a:prstGeom prst="rect">
+            <a:avLst/>
+          </a:prstGeom>
+        </p:spPr>
+      </p:pic>
     </p:spTree>
   </p:cSld>
   <p:clrMapOvr>
@@ -5752,18 +7229,16 @@
         <p:spPr>
           <a:xfrm>
             <a:off x="0" y="0"/>
-            <a:ext cx="12191695" cy="109728"/>
+            <a:ext cx="12191695" cy="6858000"/>
           </a:xfrm>
           <a:prstGeom prst="rect">
             <a:avLst/>
           </a:prstGeom>
           <a:solidFill>
-            <a:srgbClr val="D4AF37"/>
+            <a:srgbClr val="F8FAFC"/>
           </a:solidFill>
           <a:ln>
-            <a:solidFill>
-              <a:srgbClr val="D4AF37"/>
-            </a:solidFill>
+            <a:noFill/>
           </a:ln>
         </p:spPr>
         <p:style>
@@ -5790,95 +7265,24 @@
       </p:sp>
       <p:sp>
         <p:nvSpPr>
-          <p:cNvPr id="3" name="TextBox 2"/>
-          <p:cNvSpPr txBox="1"/>
-          <p:nvPr/>
-        </p:nvSpPr>
-        <p:spPr>
-          <a:xfrm>
-            <a:off x="731520" y="365760"/>
-            <a:ext cx="10728655" cy="731520"/>
+          <p:cNvPr id="3" name="Rectangle 2"/>
+          <p:cNvSpPr/>
+          <p:nvPr/>
+        </p:nvSpPr>
+        <p:spPr>
+          <a:xfrm>
+            <a:off x="0" y="0"/>
+            <a:ext cx="12191695" cy="91440"/>
           </a:xfrm>
           <a:prstGeom prst="rect">
             <a:avLst/>
           </a:prstGeom>
-          <a:noFill/>
-        </p:spPr>
-        <p:txBody>
-          <a:bodyPr wrap="square">
-            <a:spAutoFit/>
-          </a:bodyPr>
-          <a:lstStyle/>
-          <a:p>
-            <a:pPr>
-              <a:defRPr sz="2200" b="1">
-                <a:solidFill>
-                  <a:srgbClr val="082419"/>
-                </a:solidFill>
-                <a:latin typeface="Georgia"/>
-              </a:defRPr>
-            </a:pPr>
-            <a:r>
-              <a:t>RESEARCH FOUNDATIONS &amp; OFFICIAL REFERENCES</a:t>
-            </a:r>
-          </a:p>
-        </p:txBody>
-      </p:sp>
-      <p:sp>
-        <p:nvSpPr>
-          <p:cNvPr id="4" name="TextBox 3"/>
-          <p:cNvSpPr txBox="1"/>
-          <p:nvPr/>
-        </p:nvSpPr>
-        <p:spPr>
-          <a:xfrm>
-            <a:off x="8686800" y="320040"/>
-            <a:ext cx="2743200" cy="548640"/>
-          </a:xfrm>
-          <a:prstGeom prst="rect">
-            <a:avLst/>
-          </a:prstGeom>
-          <a:noFill/>
-        </p:spPr>
-        <p:txBody>
-          <a:bodyPr wrap="none">
-            <a:spAutoFit/>
-          </a:bodyPr>
-          <a:lstStyle/>
-          <a:p>
-            <a:pPr algn="r">
-              <a:defRPr sz="1000" b="1">
-                <a:solidFill>
-                  <a:srgbClr val="059669"/>
-                </a:solidFill>
-              </a:defRPr>
-            </a:pPr>
-            <a:r>
-              <a:t>SMART INDIA HACKATHON 2025</a:t>
-            </a:r>
-          </a:p>
-        </p:txBody>
-      </p:sp>
-      <p:sp>
-        <p:nvSpPr>
-          <p:cNvPr id="5" name="Rectangle 4"/>
-          <p:cNvSpPr/>
-          <p:nvPr/>
-        </p:nvSpPr>
-        <p:spPr>
-          <a:xfrm>
-            <a:off x="0" y="6400800"/>
-            <a:ext cx="12191695" cy="457200"/>
-          </a:xfrm>
-          <a:prstGeom prst="rect">
-            <a:avLst/>
-          </a:prstGeom>
           <a:solidFill>
-            <a:srgbClr val="047857"/>
+            <a:srgbClr val="0284C7"/>
           </a:solidFill>
           <a:ln>
             <a:solidFill>
-              <a:srgbClr val="047857"/>
+              <a:srgbClr val="0284C7"/>
             </a:solidFill>
           </a:ln>
         </p:spPr>
@@ -5906,14 +7310,50 @@
       </p:sp>
       <p:sp>
         <p:nvSpPr>
-          <p:cNvPr id="6" name="TextBox 5"/>
+          <p:cNvPr id="4" name="TextBox 3"/>
           <p:cNvSpPr txBox="1"/>
           <p:nvPr/>
         </p:nvSpPr>
         <p:spPr>
           <a:xfrm>
-            <a:off x="731520" y="6446520"/>
-            <a:ext cx="9144000" cy="365760"/>
+            <a:off x="731520" y="320040"/>
+            <a:ext cx="8229600" cy="731520"/>
+          </a:xfrm>
+          <a:prstGeom prst="rect">
+            <a:avLst/>
+          </a:prstGeom>
+          <a:noFill/>
+        </p:spPr>
+        <p:txBody>
+          <a:bodyPr wrap="square">
+            <a:spAutoFit/>
+          </a:bodyPr>
+          <a:lstStyle/>
+          <a:p>
+            <a:pPr>
+              <a:defRPr sz="2200" b="1">
+                <a:solidFill>
+                  <a:srgbClr val="0F1E36"/>
+                </a:solidFill>
+                <a:latin typeface="Georgia"/>
+              </a:defRPr>
+            </a:pPr>
+            <a:r>
+              <a:t>RESEARCH AND REFERENCES</a:t>
+            </a:r>
+          </a:p>
+        </p:txBody>
+      </p:sp>
+      <p:sp>
+        <p:nvSpPr>
+          <p:cNvPr id="5" name="TextBox 4"/>
+          <p:cNvSpPr txBox="1"/>
+          <p:nvPr/>
+        </p:nvSpPr>
+        <p:spPr>
+          <a:xfrm>
+            <a:off x="8412480" y="320040"/>
+            <a:ext cx="3017520" cy="548640"/>
           </a:xfrm>
           <a:prstGeom prst="rect">
             <a:avLst/>
@@ -5926,16 +7366,73 @@
           </a:bodyPr>
           <a:lstStyle/>
           <a:p>
-            <a:pPr>
-              <a:defRPr sz="1000">
-                <a:solidFill>
-                  <a:srgbClr val="F5F5F4"/>
-                </a:solidFill>
-              </a:defRPr>
-            </a:pPr>
-            <a:r>
-              <a:t>@SIH Idea submission- Template | Team: AyurSutra Innovators</a:t>
-            </a:r>
+            <a:pPr algn="r">
+              <a:defRPr sz="1100" b="1">
+                <a:solidFill>
+                  <a:srgbClr val="E36209"/>
+                </a:solidFill>
+              </a:defRPr>
+            </a:pPr>
+            <a:r>
+              <a:t>SMART INDIA HACKATHON 2025</a:t>
+            </a:r>
+          </a:p>
+          <a:p>
+            <a:pPr algn="r">
+              <a:defRPr sz="900">
+                <a:solidFill>
+                  <a:srgbClr val="64748B"/>
+                </a:solidFill>
+              </a:defRPr>
+            </a:pPr>
+            <a:r>
+              <a:t>Official Idea Submission Template</a:t>
+            </a:r>
+          </a:p>
+        </p:txBody>
+      </p:sp>
+      <p:sp>
+        <p:nvSpPr>
+          <p:cNvPr id="6" name="Rectangle 5"/>
+          <p:cNvSpPr/>
+          <p:nvPr/>
+        </p:nvSpPr>
+        <p:spPr>
+          <a:xfrm>
+            <a:off x="0" y="6400800"/>
+            <a:ext cx="12191695" cy="457200"/>
+          </a:xfrm>
+          <a:prstGeom prst="rect">
+            <a:avLst/>
+          </a:prstGeom>
+          <a:solidFill>
+            <a:srgbClr val="0284C7"/>
+          </a:solidFill>
+          <a:ln>
+            <a:solidFill>
+              <a:srgbClr val="0284C7"/>
+            </a:solidFill>
+          </a:ln>
+        </p:spPr>
+        <p:style>
+          <a:lnRef idx="1">
+            <a:schemeClr val="accent1"/>
+          </a:lnRef>
+          <a:fillRef idx="3">
+            <a:schemeClr val="accent1"/>
+          </a:fillRef>
+          <a:effectRef idx="2">
+            <a:schemeClr val="accent1"/>
+          </a:effectRef>
+          <a:fontRef idx="minor">
+            <a:schemeClr val="lt1"/>
+          </a:fontRef>
+        </p:style>
+        <p:txBody>
+          <a:bodyPr rtlCol="0" anchor="ctr"/>
+          <a:lstStyle/>
+          <a:p>
+            <a:pPr algn="ctr"/>
           </a:p>
         </p:txBody>
       </p:sp>
@@ -5947,8 +7444,8 @@
         </p:nvSpPr>
         <p:spPr>
           <a:xfrm>
-            <a:off x="10515600" y="6446520"/>
-            <a:ext cx="914400" cy="365760"/>
+            <a:off x="731520" y="6446520"/>
+            <a:ext cx="9144000" cy="365760"/>
           </a:xfrm>
           <a:prstGeom prst="rect">
             <a:avLst/>
@@ -5961,10 +7458,45 @@
           </a:bodyPr>
           <a:lstStyle/>
           <a:p>
+            <a:pPr>
+              <a:defRPr sz="1000" b="1">
+                <a:solidFill>
+                  <a:srgbClr val="FFFFFF"/>
+                </a:solidFill>
+              </a:defRPr>
+            </a:pPr>
+            <a:r>
+              <a:t>@SIH Idea submission- Template | Team: AyurSutra Innovators</a:t>
+            </a:r>
+          </a:p>
+        </p:txBody>
+      </p:sp>
+      <p:sp>
+        <p:nvSpPr>
+          <p:cNvPr id="8" name="TextBox 7"/>
+          <p:cNvSpPr txBox="1"/>
+          <p:nvPr/>
+        </p:nvSpPr>
+        <p:spPr>
+          <a:xfrm>
+            <a:off x="10789920" y="6446520"/>
+            <a:ext cx="731520" cy="365760"/>
+          </a:xfrm>
+          <a:prstGeom prst="rect">
+            <a:avLst/>
+          </a:prstGeom>
+          <a:noFill/>
+        </p:spPr>
+        <p:txBody>
+          <a:bodyPr wrap="none">
+            <a:spAutoFit/>
+          </a:bodyPr>
+          <a:lstStyle/>
+          <a:p>
             <a:pPr algn="r">
               <a:defRPr sz="1100" b="1">
                 <a:solidFill>
-                  <a:srgbClr val="D4AF37"/>
+                  <a:srgbClr val="FFFFFF"/>
                 </a:solidFill>
               </a:defRPr>
             </a:pPr>
@@ -5976,14 +7508,14 @@
       </p:sp>
       <p:sp>
         <p:nvSpPr>
-          <p:cNvPr id="8" name="Rounded Rectangle 7"/>
+          <p:cNvPr id="9" name="Rounded Rectangle 8"/>
           <p:cNvSpPr/>
           <p:nvPr/>
         </p:nvSpPr>
         <p:spPr>
           <a:xfrm>
-            <a:off x="731520" y="1280160"/>
-            <a:ext cx="10728655" cy="4846320"/>
+            <a:off x="731520" y="1188720"/>
+            <a:ext cx="10728655" cy="4937760"/>
           </a:xfrm>
           <a:prstGeom prst="roundRect">
             <a:avLst/>
@@ -6021,14 +7553,14 @@
       </p:sp>
       <p:sp>
         <p:nvSpPr>
-          <p:cNvPr id="9" name="TextBox 8"/>
+          <p:cNvPr id="10" name="TextBox 9"/>
           <p:cNvSpPr txBox="1"/>
           <p:nvPr/>
         </p:nvSpPr>
         <p:spPr>
           <a:xfrm>
-            <a:off x="914400" y="1371600"/>
-            <a:ext cx="10362895" cy="4663440"/>
+            <a:off x="914400" y="1280160"/>
+            <a:ext cx="10362895" cy="4754880"/>
           </a:xfrm>
           <a:prstGeom prst="rect">
             <a:avLst/>
@@ -6045,14 +7577,14 @@
               <a:spcAft>
                 <a:spcPts val="1000"/>
               </a:spcAft>
-              <a:defRPr sz="1400" b="1">
-                <a:solidFill>
-                  <a:srgbClr val="082419"/>
-                </a:solidFill>
-              </a:defRPr>
-            </a:pPr>
-            <a:r>
-              <a:t>REFERENCES &amp; CLINICAL CITATIONS</a:t>
+              <a:defRPr sz="1300" b="1">
+                <a:solidFill>
+                  <a:srgbClr val="0F1E36"/>
+                </a:solidFill>
+              </a:defRPr>
+            </a:pPr>
+            <a:r>
+              <a:t>• Details / Links of reference and research work</a:t>
             </a:r>
           </a:p>
           <a:p>
@@ -6072,7 +7604,7 @@
             <a:r>
               <a:rPr sz="1100">
                 <a:solidFill>
-                  <a:srgbClr val="1C1917"/>
+                  <a:srgbClr val="1E293B"/>
                 </a:solidFill>
               </a:rPr>
               <a:t>Classical Panchakarma Shodhana Protocols, Nadi Pariksha diagnostic standards &amp; Samsarjana Krama post-karma diet regimens.</a:t>
@@ -6095,7 +7627,7 @@
             <a:r>
               <a:rPr sz="1100">
                 <a:solidFill>
-                  <a:srgbClr val="1C1917"/>
+                  <a:srgbClr val="1E293B"/>
                 </a:solidFill>
               </a:rPr>
               <a:t>Ministry of Health and Family Welfare, Govt. of India — Health Data Management Policy &amp; Health ID Guidelines (https://abdm.gov.in/).</a:t>
@@ -6118,7 +7650,7 @@
             <a:r>
               <a:rPr sz="1100">
                 <a:solidFill>
-                  <a:srgbClr val="1C1917"/>
+                  <a:srgbClr val="1E293B"/>
                 </a:solidFill>
               </a:rPr>
               <a:t>Central Board of Indirect Taxes and Customs — Healthcare Service Tax Tariffs &amp; 5% GST structure (https://www.gst.gov.in/).</a:t>
@@ -6136,12 +7668,12 @@
                   <a:srgbClr val="059669"/>
                 </a:solidFill>
               </a:rPr>
-              <a:t>• Tesseract.js Open Source OCR: </a:t>
+              <a:t>• Tesseract.js Open Source OCR Engine: </a:t>
             </a:r>
             <a:r>
               <a:rPr sz="1100">
                 <a:solidFill>
-                  <a:srgbClr val="1C1917"/>
+                  <a:srgbClr val="1E293B"/>
                 </a:solidFill>
               </a:rPr>
               <a:t>Client-Side Optical Character Recognition Engine for Web Browsers (https://github.com/naptha/tesseract.js).</a:t>
@@ -6159,12 +7691,12 @@
                   <a:srgbClr val="059669"/>
                 </a:solidFill>
               </a:rPr>
-              <a:t>• AyurSutra Codebase &amp; Repository: </a:t>
+              <a:t>• AyurSutra GitHub Codebase &amp; Repository: </a:t>
             </a:r>
             <a:r>
               <a:rPr sz="1100">
                 <a:solidFill>
-                  <a:srgbClr val="1C1917"/>
+                  <a:srgbClr val="1E293B"/>
                 </a:solidFill>
               </a:rPr>
               <a:t>GitHub Repository: https://github.com/2025ucp1468-Mayank/SIH_PROJECT (Branch: mayank).</a:t>

</xml_diff>

<commit_message>
Fix UI mockup alignment and image framing with cropped high-res prototype screenshots in SIH_ppt.pptx
</commit_message>
<xml_diff>
--- a/SIH_ppt.pptx
+++ b/SIH_ppt.pptx
@@ -3189,8 +3189,8 @@
         </p:nvSpPr>
         <p:spPr>
           <a:xfrm>
-            <a:off x="731520" y="457200"/>
-            <a:ext cx="10728655" cy="1097280"/>
+            <a:off x="731520" y="365760"/>
+            <a:ext cx="10728655" cy="1005840"/>
           </a:xfrm>
           <a:prstGeom prst="rect">
             <a:avLst/>
@@ -3204,7 +3204,7 @@
           <a:lstStyle/>
           <a:p>
             <a:pPr>
-              <a:defRPr sz="3000" b="1">
+              <a:defRPr sz="2800" b="1">
                 <a:solidFill>
                   <a:srgbClr val="0F1E36"/>
                 </a:solidFill>
@@ -3217,7 +3217,7 @@
           </a:p>
           <a:p>
             <a:pPr>
-              <a:defRPr sz="1400" b="1">
+              <a:defRPr sz="1300" b="1">
                 <a:solidFill>
                   <a:srgbClr val="E36209"/>
                 </a:solidFill>
@@ -3237,8 +3237,8 @@
         </p:nvSpPr>
         <p:spPr>
           <a:xfrm>
-            <a:off x="731520" y="1645920"/>
-            <a:ext cx="6583680" cy="4572000"/>
+            <a:off x="731520" y="1463040"/>
+            <a:ext cx="6583680" cy="4663440"/>
           </a:xfrm>
           <a:prstGeom prst="roundRect">
             <a:avLst/>
@@ -3282,8 +3282,8 @@
         </p:nvSpPr>
         <p:spPr>
           <a:xfrm>
-            <a:off x="914400" y="1783080"/>
-            <a:ext cx="6217920" cy="4297680"/>
+            <a:off x="914400" y="1600200"/>
+            <a:ext cx="6217920" cy="4389120"/>
           </a:xfrm>
           <a:prstGeom prst="rect">
             <a:avLst/>
@@ -3298,11 +3298,11 @@
           <a:p>
             <a:pPr>
               <a:spcAft>
-                <a:spcPts val="700"/>
+                <a:spcPts val="600"/>
               </a:spcAft>
             </a:pPr>
             <a:r>
-              <a:rPr b="1" sz="1200">
+              <a:rPr b="1" sz="1150">
                 <a:solidFill>
                   <a:srgbClr val="0F1E36"/>
                 </a:solidFill>
@@ -3310,7 +3310,7 @@
               <a:t>• Problem Statement ID – </a:t>
             </a:r>
             <a:r>
-              <a:rPr sz="1200" b="1">
+              <a:rPr sz="1150" b="1">
                 <a:solidFill>
                   <a:srgbClr val="059669"/>
                 </a:solidFill>
@@ -3321,11 +3321,11 @@
           <a:p>
             <a:pPr>
               <a:spcAft>
-                <a:spcPts val="700"/>
+                <a:spcPts val="600"/>
               </a:spcAft>
             </a:pPr>
             <a:r>
-              <a:rPr b="1" sz="1200">
+              <a:rPr b="1" sz="1150">
                 <a:solidFill>
                   <a:srgbClr val="0F1E36"/>
                 </a:solidFill>
@@ -3333,7 +3333,7 @@
               <a:t>• Problem Statement Title – </a:t>
             </a:r>
             <a:r>
-              <a:rPr sz="1200" b="1">
+              <a:rPr sz="1150" b="1">
                 <a:solidFill>
                   <a:srgbClr val="059669"/>
                 </a:solidFill>
@@ -3344,11 +3344,11 @@
           <a:p>
             <a:pPr>
               <a:spcAft>
-                <a:spcPts val="700"/>
+                <a:spcPts val="600"/>
               </a:spcAft>
             </a:pPr>
             <a:r>
-              <a:rPr b="1" sz="1200">
+              <a:rPr b="1" sz="1150">
                 <a:solidFill>
                   <a:srgbClr val="0F1E36"/>
                 </a:solidFill>
@@ -3356,7 +3356,7 @@
               <a:t>• Theme – </a:t>
             </a:r>
             <a:r>
-              <a:rPr sz="1200" b="1">
+              <a:rPr sz="1150" b="1">
                 <a:solidFill>
                   <a:srgbClr val="059669"/>
                 </a:solidFill>
@@ -3367,11 +3367,11 @@
           <a:p>
             <a:pPr>
               <a:spcAft>
-                <a:spcPts val="700"/>
+                <a:spcPts val="600"/>
               </a:spcAft>
             </a:pPr>
             <a:r>
-              <a:rPr b="1" sz="1200">
+              <a:rPr b="1" sz="1150">
                 <a:solidFill>
                   <a:srgbClr val="0F1E36"/>
                 </a:solidFill>
@@ -3379,7 +3379,7 @@
               <a:t>• PS Category – </a:t>
             </a:r>
             <a:r>
-              <a:rPr sz="1200" b="1">
+              <a:rPr sz="1150" b="1">
                 <a:solidFill>
                   <a:srgbClr val="059669"/>
                 </a:solidFill>
@@ -3390,11 +3390,11 @@
           <a:p>
             <a:pPr>
               <a:spcAft>
-                <a:spcPts val="700"/>
+                <a:spcPts val="600"/>
               </a:spcAft>
             </a:pPr>
             <a:r>
-              <a:rPr b="1" sz="1200">
+              <a:rPr b="1" sz="1150">
                 <a:solidFill>
                   <a:srgbClr val="0F1E36"/>
                 </a:solidFill>
@@ -3402,7 +3402,7 @@
               <a:t>• Team ID – </a:t>
             </a:r>
             <a:r>
-              <a:rPr sz="1200" b="1">
+              <a:rPr sz="1150" b="1">
                 <a:solidFill>
                   <a:srgbClr val="059669"/>
                 </a:solidFill>
@@ -3413,11 +3413,11 @@
           <a:p>
             <a:pPr>
               <a:spcAft>
-                <a:spcPts val="700"/>
+                <a:spcPts val="600"/>
               </a:spcAft>
             </a:pPr>
             <a:r>
-              <a:rPr b="1" sz="1200">
+              <a:rPr b="1" sz="1150">
                 <a:solidFill>
                   <a:srgbClr val="0F1E36"/>
                 </a:solidFill>
@@ -3425,7 +3425,7 @@
               <a:t>• Team Name – </a:t>
             </a:r>
             <a:r>
-              <a:rPr sz="1200" b="1">
+              <a:rPr sz="1150" b="1">
                 <a:solidFill>
                   <a:srgbClr val="059669"/>
                 </a:solidFill>
@@ -3436,11 +3436,11 @@
           <a:p>
             <a:pPr>
               <a:spcAft>
-                <a:spcPts val="700"/>
+                <a:spcPts val="600"/>
               </a:spcAft>
             </a:pPr>
             <a:r>
-              <a:rPr b="1" sz="1200">
+              <a:rPr b="1" sz="1150">
                 <a:solidFill>
                   <a:srgbClr val="0F1E36"/>
                 </a:solidFill>
@@ -3448,7 +3448,7 @@
               <a:t>• GitHub Repository – </a:t>
             </a:r>
             <a:r>
-              <a:rPr sz="1200" b="1">
+              <a:rPr sz="1150" b="1">
                 <a:solidFill>
                   <a:srgbClr val="059669"/>
                 </a:solidFill>
@@ -3466,8 +3466,8 @@
         </p:nvSpPr>
         <p:spPr>
           <a:xfrm>
-            <a:off x="7589520" y="1645920"/>
-            <a:ext cx="3840480" cy="4572000"/>
+            <a:off x="7589520" y="1463040"/>
+            <a:ext cx="3840480" cy="4663440"/>
           </a:xfrm>
           <a:prstGeom prst="roundRect">
             <a:avLst/>
@@ -3475,7 +3475,7 @@
           <a:solidFill>
             <a:srgbClr val="FFFFFF"/>
           </a:solidFill>
-          <a:ln w="25400">
+          <a:ln w="19050">
             <a:solidFill>
               <a:srgbClr val="0284C7"/>
             </a:solidFill>
@@ -3505,14 +3505,59 @@
       </p:sp>
       <p:sp>
         <p:nvSpPr>
-          <p:cNvPr id="8" name="TextBox 7"/>
+          <p:cNvPr id="8" name="Rectangle 7"/>
+          <p:cNvSpPr/>
+          <p:nvPr/>
+        </p:nvSpPr>
+        <p:spPr>
+          <a:xfrm>
+            <a:off x="7589520" y="1463040"/>
+            <a:ext cx="3840480" cy="365760"/>
+          </a:xfrm>
+          <a:prstGeom prst="rect">
+            <a:avLst/>
+          </a:prstGeom>
+          <a:solidFill>
+            <a:srgbClr val="0F1E36"/>
+          </a:solidFill>
+          <a:ln>
+            <a:solidFill>
+              <a:srgbClr val="0F1E36"/>
+            </a:solidFill>
+          </a:ln>
+        </p:spPr>
+        <p:style>
+          <a:lnRef idx="1">
+            <a:schemeClr val="accent1"/>
+          </a:lnRef>
+          <a:fillRef idx="3">
+            <a:schemeClr val="accent1"/>
+          </a:fillRef>
+          <a:effectRef idx="2">
+            <a:schemeClr val="accent1"/>
+          </a:effectRef>
+          <a:fontRef idx="minor">
+            <a:schemeClr val="lt1"/>
+          </a:fontRef>
+        </p:style>
+        <p:txBody>
+          <a:bodyPr rtlCol="0" anchor="ctr"/>
+          <a:lstStyle/>
+          <a:p>
+            <a:pPr algn="ctr"/>
+          </a:p>
+        </p:txBody>
+      </p:sp>
+      <p:sp>
+        <p:nvSpPr>
+          <p:cNvPr id="9" name="TextBox 8"/>
           <p:cNvSpPr txBox="1"/>
           <p:nvPr/>
         </p:nvSpPr>
         <p:spPr>
           <a:xfrm>
-            <a:off x="7680960" y="1737360"/>
-            <a:ext cx="3657600" cy="365760"/>
+            <a:off x="7680960" y="1508760"/>
+            <a:ext cx="3657600" cy="274320"/>
           </a:xfrm>
           <a:prstGeom prst="rect">
             <a:avLst/>
@@ -3525,22 +3570,22 @@
           </a:bodyPr>
           <a:lstStyle/>
           <a:p>
-            <a:pPr>
-              <a:defRPr sz="1000" b="1">
-                <a:solidFill>
-                  <a:srgbClr val="0F1E36"/>
-                </a:solidFill>
-              </a:defRPr>
-            </a:pPr>
-            <a:r>
-              <a:t>LIVE SYSTEM PROTOTYPE PREVIEW</a:t>
+            <a:pPr algn="ctr">
+              <a:defRPr sz="900" b="1">
+                <a:solidFill>
+                  <a:srgbClr val="FFFFFF"/>
+                </a:solidFill>
+              </a:defRPr>
+            </a:pPr>
+            <a:r>
+              <a:t>LIVE SYSTEM PREVIEW</a:t>
             </a:r>
           </a:p>
         </p:txBody>
       </p:sp>
       <p:pic>
         <p:nvPicPr>
-          <p:cNvPr id="9" name="Picture 8" descr="01_patient_intake_sanctuary.png"/>
+          <p:cNvPr id="10" name="Picture 9" descr="01_cropped.png"/>
           <p:cNvPicPr>
             <a:picLocks noChangeAspect="1"/>
           </p:cNvPicPr>
@@ -3554,8 +3599,8 @@
         </p:blipFill>
         <p:spPr>
           <a:xfrm>
-            <a:off x="7680960" y="2103120"/>
-            <a:ext cx="3657600" cy="1737360"/>
+            <a:off x="7607808" y="1847088"/>
+            <a:ext cx="3803904" cy="4261104"/>
           </a:xfrm>
           <a:prstGeom prst="rect">
             <a:avLst/>
@@ -3632,7 +3677,7 @@
         <p:spPr>
           <a:xfrm>
             <a:off x="0" y="0"/>
-            <a:ext cx="12191695" cy="91440"/>
+            <a:ext cx="12191695" cy="109728"/>
           </a:xfrm>
           <a:prstGeom prst="rect">
             <a:avLst/>
@@ -3676,7 +3721,7 @@
         </p:nvSpPr>
         <p:spPr>
           <a:xfrm>
-            <a:off x="731520" y="320040"/>
+            <a:off x="731520" y="274320"/>
             <a:ext cx="8229600" cy="731520"/>
           </a:xfrm>
           <a:prstGeom prst="rect">
@@ -3691,7 +3736,7 @@
           <a:lstStyle/>
           <a:p>
             <a:pPr>
-              <a:defRPr sz="2200" b="1">
+              <a:defRPr sz="2000" b="1">
                 <a:solidFill>
                   <a:srgbClr val="0F1E36"/>
                 </a:solidFill>
@@ -3712,7 +3757,7 @@
         </p:nvSpPr>
         <p:spPr>
           <a:xfrm>
-            <a:off x="8412480" y="320040"/>
+            <a:off x="8412480" y="274320"/>
             <a:ext cx="3017520" cy="548640"/>
           </a:xfrm>
           <a:prstGeom prst="rect">
@@ -3727,7 +3772,7 @@
           <a:lstStyle/>
           <a:p>
             <a:pPr algn="r">
-              <a:defRPr sz="1100" b="1">
+              <a:defRPr sz="1000" b="1">
                 <a:solidFill>
                   <a:srgbClr val="E36209"/>
                 </a:solidFill>
@@ -3739,7 +3784,7 @@
           </a:p>
           <a:p>
             <a:pPr algn="r">
-              <a:defRPr sz="900">
+              <a:defRPr sz="850">
                 <a:solidFill>
                   <a:srgbClr val="64748B"/>
                 </a:solidFill>
@@ -3819,7 +3864,7 @@
           <a:lstStyle/>
           <a:p>
             <a:pPr>
-              <a:defRPr sz="1000" b="1">
+              <a:defRPr sz="950" b="1">
                 <a:solidFill>
                   <a:srgbClr val="FFFFFF"/>
                 </a:solidFill>
@@ -3854,7 +3899,7 @@
           <a:lstStyle/>
           <a:p>
             <a:pPr algn="r">
-              <a:defRPr sz="1100" b="1">
+              <a:defRPr sz="1050" b="1">
                 <a:solidFill>
                   <a:srgbClr val="FFFFFF"/>
                 </a:solidFill>
@@ -3950,9 +3995,9 @@
           <a:p>
             <a:pPr>
               <a:spcAft>
-                <a:spcPts val="700"/>
+                <a:spcPts val="600"/>
               </a:spcAft>
-              <a:defRPr sz="1100">
+              <a:defRPr sz="1050">
                 <a:solidFill>
                   <a:srgbClr val="1E293B"/>
                 </a:solidFill>
@@ -3965,9 +4010,9 @@
           <a:p>
             <a:pPr>
               <a:spcAft>
-                <a:spcPts val="700"/>
+                <a:spcPts val="600"/>
               </a:spcAft>
-              <a:defRPr sz="1100">
+              <a:defRPr sz="1050">
                 <a:solidFill>
                   <a:srgbClr val="1E293B"/>
                 </a:solidFill>
@@ -3980,9 +4025,9 @@
           <a:p>
             <a:pPr>
               <a:spcAft>
-                <a:spcPts val="700"/>
+                <a:spcPts val="600"/>
               </a:spcAft>
-              <a:defRPr sz="1100">
+              <a:defRPr sz="1050">
                 <a:solidFill>
                   <a:srgbClr val="1E293B"/>
                 </a:solidFill>
@@ -3995,9 +4040,9 @@
           <a:p>
             <a:pPr>
               <a:spcAft>
-                <a:spcPts val="700"/>
+                <a:spcPts val="600"/>
               </a:spcAft>
-              <a:defRPr sz="1100">
+              <a:defRPr sz="1050">
                 <a:solidFill>
                   <a:srgbClr val="1E293B"/>
                 </a:solidFill>
@@ -4010,9 +4055,9 @@
           <a:p>
             <a:pPr>
               <a:spcAft>
-                <a:spcPts val="700"/>
+                <a:spcPts val="600"/>
               </a:spcAft>
-              <a:defRPr sz="1100">
+              <a:defRPr sz="1050">
                 <a:solidFill>
                   <a:srgbClr val="1E293B"/>
                 </a:solidFill>
@@ -4041,9 +4086,9 @@
           <a:solidFill>
             <a:srgbClr val="FFFFFF"/>
           </a:solidFill>
-          <a:ln w="25400">
+          <a:ln w="19050">
             <a:solidFill>
-              <a:srgbClr val="059669"/>
+              <a:srgbClr val="0284C7"/>
             </a:solidFill>
           </a:ln>
         </p:spPr>
@@ -4071,14 +4116,59 @@
       </p:sp>
       <p:sp>
         <p:nvSpPr>
-          <p:cNvPr id="12" name="TextBox 11"/>
+          <p:cNvPr id="12" name="Rectangle 11"/>
+          <p:cNvSpPr/>
+          <p:nvPr/>
+        </p:nvSpPr>
+        <p:spPr>
+          <a:xfrm>
+            <a:off x="6858000" y="1188720"/>
+            <a:ext cx="4572000" cy="365760"/>
+          </a:xfrm>
+          <a:prstGeom prst="rect">
+            <a:avLst/>
+          </a:prstGeom>
+          <a:solidFill>
+            <a:srgbClr val="0F1E36"/>
+          </a:solidFill>
+          <a:ln>
+            <a:solidFill>
+              <a:srgbClr val="0F1E36"/>
+            </a:solidFill>
+          </a:ln>
+        </p:spPr>
+        <p:style>
+          <a:lnRef idx="1">
+            <a:schemeClr val="accent1"/>
+          </a:lnRef>
+          <a:fillRef idx="3">
+            <a:schemeClr val="accent1"/>
+          </a:fillRef>
+          <a:effectRef idx="2">
+            <a:schemeClr val="accent1"/>
+          </a:effectRef>
+          <a:fontRef idx="minor">
+            <a:schemeClr val="lt1"/>
+          </a:fontRef>
+        </p:style>
+        <p:txBody>
+          <a:bodyPr rtlCol="0" anchor="ctr"/>
+          <a:lstStyle/>
+          <a:p>
+            <a:pPr algn="ctr"/>
+          </a:p>
+        </p:txBody>
+      </p:sp>
+      <p:sp>
+        <p:nvSpPr>
+          <p:cNvPr id="13" name="TextBox 12"/>
           <p:cNvSpPr txBox="1"/>
           <p:nvPr/>
         </p:nvSpPr>
         <p:spPr>
           <a:xfrm>
-            <a:off x="6949440" y="1280160"/>
-            <a:ext cx="4389120" cy="365760"/>
+            <a:off x="6949440" y="1234440"/>
+            <a:ext cx="4389120" cy="274320"/>
           </a:xfrm>
           <a:prstGeom prst="rect">
             <a:avLst/>
@@ -4091,22 +4181,22 @@
           </a:bodyPr>
           <a:lstStyle/>
           <a:p>
-            <a:pPr>
-              <a:defRPr sz="1000" b="1">
-                <a:solidFill>
-                  <a:srgbClr val="0F1E36"/>
-                </a:solidFill>
-              </a:defRPr>
-            </a:pPr>
-            <a:r>
-              <a:t>SYSTEM PROTOTYPE: PATIENT SANCTUARY UI</a:t>
+            <a:pPr algn="ctr">
+              <a:defRPr sz="900" b="1">
+                <a:solidFill>
+                  <a:srgbClr val="FFFFFF"/>
+                </a:solidFill>
+              </a:defRPr>
+            </a:pPr>
+            <a:r>
+              <a:t>PATIENT INTAKE SANCTUARY UI</a:t>
             </a:r>
           </a:p>
         </p:txBody>
       </p:sp>
       <p:pic>
         <p:nvPicPr>
-          <p:cNvPr id="13" name="Picture 12" descr="01_patient_intake_sanctuary.png"/>
+          <p:cNvPr id="14" name="Picture 13" descr="01_cropped.png"/>
           <p:cNvPicPr>
             <a:picLocks noChangeAspect="1"/>
           </p:cNvPicPr>
@@ -4120,8 +4210,8 @@
         </p:blipFill>
         <p:spPr>
           <a:xfrm>
-            <a:off x="6949440" y="1691640"/>
-            <a:ext cx="4389120" cy="2084832"/>
+            <a:off x="6876288" y="1572768"/>
+            <a:ext cx="4535424" cy="4535424"/>
           </a:xfrm>
           <a:prstGeom prst="rect">
             <a:avLst/>
@@ -4198,7 +4288,7 @@
         <p:spPr>
           <a:xfrm>
             <a:off x="0" y="0"/>
-            <a:ext cx="12191695" cy="91440"/>
+            <a:ext cx="12191695" cy="109728"/>
           </a:xfrm>
           <a:prstGeom prst="rect">
             <a:avLst/>
@@ -4242,7 +4332,7 @@
         </p:nvSpPr>
         <p:spPr>
           <a:xfrm>
-            <a:off x="731520" y="320040"/>
+            <a:off x="731520" y="274320"/>
             <a:ext cx="8229600" cy="731520"/>
           </a:xfrm>
           <a:prstGeom prst="rect">
@@ -4257,7 +4347,7 @@
           <a:lstStyle/>
           <a:p>
             <a:pPr>
-              <a:defRPr sz="2200" b="1">
+              <a:defRPr sz="2000" b="1">
                 <a:solidFill>
                   <a:srgbClr val="0F1E36"/>
                 </a:solidFill>
@@ -4278,7 +4368,7 @@
         </p:nvSpPr>
         <p:spPr>
           <a:xfrm>
-            <a:off x="8412480" y="320040"/>
+            <a:off x="8412480" y="274320"/>
             <a:ext cx="3017520" cy="548640"/>
           </a:xfrm>
           <a:prstGeom prst="rect">
@@ -4293,7 +4383,7 @@
           <a:lstStyle/>
           <a:p>
             <a:pPr algn="r">
-              <a:defRPr sz="1100" b="1">
+              <a:defRPr sz="1000" b="1">
                 <a:solidFill>
                   <a:srgbClr val="E36209"/>
                 </a:solidFill>
@@ -4305,7 +4395,7 @@
           </a:p>
           <a:p>
             <a:pPr algn="r">
-              <a:defRPr sz="900">
+              <a:defRPr sz="850">
                 <a:solidFill>
                   <a:srgbClr val="64748B"/>
                 </a:solidFill>
@@ -4385,7 +4475,7 @@
           <a:lstStyle/>
           <a:p>
             <a:pPr>
-              <a:defRPr sz="1000" b="1">
+              <a:defRPr sz="950" b="1">
                 <a:solidFill>
                   <a:srgbClr val="FFFFFF"/>
                 </a:solidFill>
@@ -4420,7 +4510,7 @@
           <a:lstStyle/>
           <a:p>
             <a:pPr algn="r">
-              <a:defRPr sz="1100" b="1">
+              <a:defRPr sz="1050" b="1">
                 <a:solidFill>
                   <a:srgbClr val="FFFFFF"/>
                 </a:solidFill>
@@ -4518,7 +4608,7 @@
               <a:spcAft>
                 <a:spcPts val="300"/>
               </a:spcAft>
-              <a:defRPr sz="1000">
+              <a:defRPr sz="950">
                 <a:solidFill>
                   <a:srgbClr val="1E293B"/>
                 </a:solidFill>
@@ -4533,7 +4623,7 @@
               <a:spcAft>
                 <a:spcPts val="300"/>
               </a:spcAft>
-              <a:defRPr sz="1000">
+              <a:defRPr sz="950">
                 <a:solidFill>
                   <a:srgbClr val="1E293B"/>
                 </a:solidFill>
@@ -4548,7 +4638,7 @@
               <a:spcAft>
                 <a:spcPts val="300"/>
               </a:spcAft>
-              <a:defRPr sz="1000">
+              <a:defRPr sz="950">
                 <a:solidFill>
                   <a:srgbClr val="1E293B"/>
                 </a:solidFill>
@@ -4577,9 +4667,9 @@
           <a:solidFill>
             <a:srgbClr val="FFFFFF"/>
           </a:solidFill>
-          <a:ln w="25400">
+          <a:ln w="19050">
             <a:solidFill>
-              <a:srgbClr val="059669"/>
+              <a:srgbClr val="0284C7"/>
             </a:solidFill>
           </a:ln>
         </p:spPr>
@@ -4607,14 +4697,59 @@
       </p:sp>
       <p:sp>
         <p:nvSpPr>
-          <p:cNvPr id="12" name="TextBox 11"/>
+          <p:cNvPr id="12" name="Rectangle 11"/>
+          <p:cNvSpPr/>
+          <p:nvPr/>
+        </p:nvSpPr>
+        <p:spPr>
+          <a:xfrm>
+            <a:off x="7772400" y="1188720"/>
+            <a:ext cx="3657600" cy="365760"/>
+          </a:xfrm>
+          <a:prstGeom prst="rect">
+            <a:avLst/>
+          </a:prstGeom>
+          <a:solidFill>
+            <a:srgbClr val="0F1E36"/>
+          </a:solidFill>
+          <a:ln>
+            <a:solidFill>
+              <a:srgbClr val="0F1E36"/>
+            </a:solidFill>
+          </a:ln>
+        </p:spPr>
+        <p:style>
+          <a:lnRef idx="1">
+            <a:schemeClr val="accent1"/>
+          </a:lnRef>
+          <a:fillRef idx="3">
+            <a:schemeClr val="accent1"/>
+          </a:fillRef>
+          <a:effectRef idx="2">
+            <a:schemeClr val="accent1"/>
+          </a:effectRef>
+          <a:fontRef idx="minor">
+            <a:schemeClr val="lt1"/>
+          </a:fontRef>
+        </p:style>
+        <p:txBody>
+          <a:bodyPr rtlCol="0" anchor="ctr"/>
+          <a:lstStyle/>
+          <a:p>
+            <a:pPr algn="ctr"/>
+          </a:p>
+        </p:txBody>
+      </p:sp>
+      <p:sp>
+        <p:nvSpPr>
+          <p:cNvPr id="13" name="TextBox 12"/>
           <p:cNvSpPr txBox="1"/>
           <p:nvPr/>
         </p:nvSpPr>
         <p:spPr>
           <a:xfrm>
-            <a:off x="7863840" y="1280160"/>
-            <a:ext cx="3474720" cy="365760"/>
+            <a:off x="7863840" y="1234440"/>
+            <a:ext cx="3474720" cy="274320"/>
           </a:xfrm>
           <a:prstGeom prst="rect">
             <a:avLst/>
@@ -4627,22 +4762,22 @@
           </a:bodyPr>
           <a:lstStyle/>
           <a:p>
-            <a:pPr>
-              <a:defRPr sz="1000" b="1">
-                <a:solidFill>
-                  <a:srgbClr val="0F1E36"/>
-                </a:solidFill>
-              </a:defRPr>
-            </a:pPr>
-            <a:r>
-              <a:t>PROTOTYPE: OCR DIAGNOSTIC EXTRACTOR</a:t>
+            <a:pPr algn="ctr">
+              <a:defRPr sz="900" b="1">
+                <a:solidFill>
+                  <a:srgbClr val="FFFFFF"/>
+                </a:solidFill>
+              </a:defRPr>
+            </a:pPr>
+            <a:r>
+              <a:t>OCR DIAGNOSTIC EXTRACTOR</a:t>
             </a:r>
           </a:p>
         </p:txBody>
       </p:sp>
       <p:pic>
         <p:nvPicPr>
-          <p:cNvPr id="13" name="Picture 12" descr="02_ocr_medical_report_extractor.png"/>
+          <p:cNvPr id="14" name="Picture 13" descr="02_cropped.png"/>
           <p:cNvPicPr>
             <a:picLocks noChangeAspect="1"/>
           </p:cNvPicPr>
@@ -4656,8 +4791,8 @@
         </p:blipFill>
         <p:spPr>
           <a:xfrm>
-            <a:off x="7863840" y="1691640"/>
-            <a:ext cx="3474720" cy="1650492"/>
+            <a:off x="7790688" y="1572768"/>
+            <a:ext cx="3621024" cy="4535424"/>
           </a:xfrm>
           <a:prstGeom prst="rect">
             <a:avLst/>
@@ -4666,7 +4801,7 @@
       </p:pic>
       <p:sp>
         <p:nvSpPr>
-          <p:cNvPr id="14" name="Rounded Rectangle 13"/>
+          <p:cNvPr id="15" name="Rounded Rectangle 14"/>
           <p:cNvSpPr/>
           <p:nvPr/>
         </p:nvSpPr>
@@ -4681,7 +4816,7 @@
           <a:solidFill>
             <a:srgbClr val="FFFFFF"/>
           </a:solidFill>
-          <a:ln w="25400">
+          <a:ln w="19050">
             <a:solidFill>
               <a:srgbClr val="059669"/>
             </a:solidFill>
@@ -4711,14 +4846,14 @@
       </p:sp>
       <p:sp>
         <p:nvSpPr>
-          <p:cNvPr id="15" name="Rectangle 14"/>
+          <p:cNvPr id="16" name="Rectangle 15"/>
           <p:cNvSpPr/>
           <p:nvPr/>
         </p:nvSpPr>
         <p:spPr>
           <a:xfrm>
             <a:off x="731520" y="3200400"/>
-            <a:ext cx="1554480" cy="457200"/>
+            <a:ext cx="1554480" cy="411480"/>
           </a:xfrm>
           <a:prstGeom prst="rect">
             <a:avLst/>
@@ -4756,14 +4891,14 @@
       </p:sp>
       <p:sp>
         <p:nvSpPr>
-          <p:cNvPr id="16" name="TextBox 15"/>
+          <p:cNvPr id="17" name="TextBox 16"/>
           <p:cNvSpPr txBox="1"/>
           <p:nvPr/>
         </p:nvSpPr>
         <p:spPr>
           <a:xfrm>
             <a:off x="731520" y="3246120"/>
-            <a:ext cx="1554480" cy="365760"/>
+            <a:ext cx="1554480" cy="320040"/>
           </a:xfrm>
           <a:prstGeom prst="rect">
             <a:avLst/>
@@ -4777,7 +4912,7 @@
           <a:lstStyle/>
           <a:p>
             <a:pPr algn="ctr">
-              <a:defRPr sz="900" b="1">
+              <a:defRPr sz="850" b="1">
                 <a:solidFill>
                   <a:srgbClr val="FFFFFF"/>
                 </a:solidFill>
@@ -4791,14 +4926,14 @@
       </p:sp>
       <p:sp>
         <p:nvSpPr>
-          <p:cNvPr id="17" name="TextBox 16"/>
+          <p:cNvPr id="18" name="TextBox 17"/>
           <p:cNvSpPr txBox="1"/>
           <p:nvPr/>
         </p:nvSpPr>
         <p:spPr>
           <a:xfrm>
-            <a:off x="804672" y="3703320"/>
-            <a:ext cx="1408176" cy="2377440"/>
+            <a:off x="804672" y="3657600"/>
+            <a:ext cx="1408176" cy="2423160"/>
           </a:xfrm>
           <a:prstGeom prst="rect">
             <a:avLst/>
@@ -4813,9 +4948,9 @@
           <a:p>
             <a:pPr>
               <a:spcAft>
-                <a:spcPts val="400"/>
+                <a:spcPts val="300"/>
               </a:spcAft>
-              <a:defRPr sz="900" b="1">
+              <a:defRPr sz="850" b="1">
                 <a:solidFill>
                   <a:srgbClr val="1E293B"/>
                 </a:solidFill>
@@ -4830,7 +4965,7 @@
               <a:spcAft>
                 <a:spcPts val="200"/>
               </a:spcAft>
-              <a:defRPr sz="800">
+              <a:defRPr sz="750">
                 <a:solidFill>
                   <a:srgbClr val="64748B"/>
                 </a:solidFill>
@@ -4845,7 +4980,7 @@
               <a:spcAft>
                 <a:spcPts val="200"/>
               </a:spcAft>
-              <a:defRPr sz="800">
+              <a:defRPr sz="750">
                 <a:solidFill>
                   <a:srgbClr val="64748B"/>
                 </a:solidFill>
@@ -4860,7 +4995,7 @@
               <a:spcAft>
                 <a:spcPts val="200"/>
               </a:spcAft>
-              <a:defRPr sz="800">
+              <a:defRPr sz="750">
                 <a:solidFill>
                   <a:srgbClr val="64748B"/>
                 </a:solidFill>
@@ -4874,7 +5009,7 @@
       </p:sp>
       <p:sp>
         <p:nvSpPr>
-          <p:cNvPr id="18" name="Right Arrow 17"/>
+          <p:cNvPr id="19" name="Right Arrow 18"/>
           <p:cNvSpPr/>
           <p:nvPr/>
         </p:nvSpPr>
@@ -4919,7 +5054,7 @@
       </p:sp>
       <p:sp>
         <p:nvSpPr>
-          <p:cNvPr id="19" name="Rounded Rectangle 18"/>
+          <p:cNvPr id="20" name="Rounded Rectangle 19"/>
           <p:cNvSpPr/>
           <p:nvPr/>
         </p:nvSpPr>
@@ -4934,7 +5069,7 @@
           <a:solidFill>
             <a:srgbClr val="FFFFFF"/>
           </a:solidFill>
-          <a:ln w="25400">
+          <a:ln w="19050">
             <a:solidFill>
               <a:srgbClr val="0F1E36"/>
             </a:solidFill>
@@ -4964,14 +5099,14 @@
       </p:sp>
       <p:sp>
         <p:nvSpPr>
-          <p:cNvPr id="20" name="Rectangle 19"/>
+          <p:cNvPr id="21" name="Rectangle 20"/>
           <p:cNvSpPr/>
           <p:nvPr/>
         </p:nvSpPr>
         <p:spPr>
           <a:xfrm>
             <a:off x="2450591" y="3200400"/>
-            <a:ext cx="1554480" cy="457200"/>
+            <a:ext cx="1554480" cy="411480"/>
           </a:xfrm>
           <a:prstGeom prst="rect">
             <a:avLst/>
@@ -5009,14 +5144,14 @@
       </p:sp>
       <p:sp>
         <p:nvSpPr>
-          <p:cNvPr id="21" name="TextBox 20"/>
+          <p:cNvPr id="22" name="TextBox 21"/>
           <p:cNvSpPr txBox="1"/>
           <p:nvPr/>
         </p:nvSpPr>
         <p:spPr>
           <a:xfrm>
             <a:off x="2450591" y="3246120"/>
-            <a:ext cx="1554480" cy="365760"/>
+            <a:ext cx="1554480" cy="320040"/>
           </a:xfrm>
           <a:prstGeom prst="rect">
             <a:avLst/>
@@ -5030,7 +5165,7 @@
           <a:lstStyle/>
           <a:p>
             <a:pPr algn="ctr">
-              <a:defRPr sz="900" b="1">
+              <a:defRPr sz="850" b="1">
                 <a:solidFill>
                   <a:srgbClr val="FFFFFF"/>
                 </a:solidFill>
@@ -5044,14 +5179,14 @@
       </p:sp>
       <p:sp>
         <p:nvSpPr>
-          <p:cNvPr id="22" name="TextBox 21"/>
+          <p:cNvPr id="23" name="TextBox 22"/>
           <p:cNvSpPr txBox="1"/>
           <p:nvPr/>
         </p:nvSpPr>
         <p:spPr>
           <a:xfrm>
-            <a:off x="2523743" y="3703320"/>
-            <a:ext cx="1408176" cy="2377440"/>
+            <a:off x="2523743" y="3657600"/>
+            <a:ext cx="1408176" cy="2423160"/>
           </a:xfrm>
           <a:prstGeom prst="rect">
             <a:avLst/>
@@ -5066,9 +5201,9 @@
           <a:p>
             <a:pPr>
               <a:spcAft>
-                <a:spcPts val="400"/>
+                <a:spcPts val="300"/>
               </a:spcAft>
-              <a:defRPr sz="900" b="1">
+              <a:defRPr sz="850" b="1">
                 <a:solidFill>
                   <a:srgbClr val="1E293B"/>
                 </a:solidFill>
@@ -5083,7 +5218,7 @@
               <a:spcAft>
                 <a:spcPts val="200"/>
               </a:spcAft>
-              <a:defRPr sz="800">
+              <a:defRPr sz="750">
                 <a:solidFill>
                   <a:srgbClr val="64748B"/>
                 </a:solidFill>
@@ -5098,7 +5233,7 @@
               <a:spcAft>
                 <a:spcPts val="200"/>
               </a:spcAft>
-              <a:defRPr sz="800">
+              <a:defRPr sz="750">
                 <a:solidFill>
                   <a:srgbClr val="64748B"/>
                 </a:solidFill>
@@ -5113,7 +5248,7 @@
               <a:spcAft>
                 <a:spcPts val="200"/>
               </a:spcAft>
-              <a:defRPr sz="800">
+              <a:defRPr sz="750">
                 <a:solidFill>
                   <a:srgbClr val="64748B"/>
                 </a:solidFill>
@@ -5127,7 +5262,7 @@
       </p:sp>
       <p:sp>
         <p:nvSpPr>
-          <p:cNvPr id="23" name="Right Arrow 22"/>
+          <p:cNvPr id="24" name="Right Arrow 23"/>
           <p:cNvSpPr/>
           <p:nvPr/>
         </p:nvSpPr>
@@ -5172,7 +5307,7 @@
       </p:sp>
       <p:sp>
         <p:nvSpPr>
-          <p:cNvPr id="24" name="Rounded Rectangle 23"/>
+          <p:cNvPr id="25" name="Rounded Rectangle 24"/>
           <p:cNvSpPr/>
           <p:nvPr/>
         </p:nvSpPr>
@@ -5187,7 +5322,7 @@
           <a:solidFill>
             <a:srgbClr val="FFFFFF"/>
           </a:solidFill>
-          <a:ln w="25400">
+          <a:ln w="19050">
             <a:solidFill>
               <a:srgbClr val="E36209"/>
             </a:solidFill>
@@ -5217,14 +5352,14 @@
       </p:sp>
       <p:sp>
         <p:nvSpPr>
-          <p:cNvPr id="25" name="Rectangle 24"/>
+          <p:cNvPr id="26" name="Rectangle 25"/>
           <p:cNvSpPr/>
           <p:nvPr/>
         </p:nvSpPr>
         <p:spPr>
           <a:xfrm>
             <a:off x="4169663" y="3200400"/>
-            <a:ext cx="1554480" cy="457200"/>
+            <a:ext cx="1554480" cy="411480"/>
           </a:xfrm>
           <a:prstGeom prst="rect">
             <a:avLst/>
@@ -5262,14 +5397,14 @@
       </p:sp>
       <p:sp>
         <p:nvSpPr>
-          <p:cNvPr id="26" name="TextBox 25"/>
+          <p:cNvPr id="27" name="TextBox 26"/>
           <p:cNvSpPr txBox="1"/>
           <p:nvPr/>
         </p:nvSpPr>
         <p:spPr>
           <a:xfrm>
             <a:off x="4169663" y="3246120"/>
-            <a:ext cx="1554480" cy="365760"/>
+            <a:ext cx="1554480" cy="320040"/>
           </a:xfrm>
           <a:prstGeom prst="rect">
             <a:avLst/>
@@ -5283,7 +5418,7 @@
           <a:lstStyle/>
           <a:p>
             <a:pPr algn="ctr">
-              <a:defRPr sz="900" b="1">
+              <a:defRPr sz="850" b="1">
                 <a:solidFill>
                   <a:srgbClr val="FFFFFF"/>
                 </a:solidFill>
@@ -5297,14 +5432,14 @@
       </p:sp>
       <p:sp>
         <p:nvSpPr>
-          <p:cNvPr id="27" name="TextBox 26"/>
+          <p:cNvPr id="28" name="TextBox 27"/>
           <p:cNvSpPr txBox="1"/>
           <p:nvPr/>
         </p:nvSpPr>
         <p:spPr>
           <a:xfrm>
-            <a:off x="4242815" y="3703320"/>
-            <a:ext cx="1408176" cy="2377440"/>
+            <a:off x="4242815" y="3657600"/>
+            <a:ext cx="1408176" cy="2423160"/>
           </a:xfrm>
           <a:prstGeom prst="rect">
             <a:avLst/>
@@ -5319,9 +5454,9 @@
           <a:p>
             <a:pPr>
               <a:spcAft>
-                <a:spcPts val="400"/>
+                <a:spcPts val="300"/>
               </a:spcAft>
-              <a:defRPr sz="900" b="1">
+              <a:defRPr sz="850" b="1">
                 <a:solidFill>
                   <a:srgbClr val="1E293B"/>
                 </a:solidFill>
@@ -5336,7 +5471,7 @@
               <a:spcAft>
                 <a:spcPts val="200"/>
               </a:spcAft>
-              <a:defRPr sz="800">
+              <a:defRPr sz="750">
                 <a:solidFill>
                   <a:srgbClr val="64748B"/>
                 </a:solidFill>
@@ -5351,7 +5486,7 @@
               <a:spcAft>
                 <a:spcPts val="200"/>
               </a:spcAft>
-              <a:defRPr sz="800">
+              <a:defRPr sz="750">
                 <a:solidFill>
                   <a:srgbClr val="64748B"/>
                 </a:solidFill>
@@ -5366,7 +5501,7 @@
               <a:spcAft>
                 <a:spcPts val="200"/>
               </a:spcAft>
-              <a:defRPr sz="800">
+              <a:defRPr sz="750">
                 <a:solidFill>
                   <a:srgbClr val="64748B"/>
                 </a:solidFill>
@@ -5380,7 +5515,7 @@
       </p:sp>
       <p:sp>
         <p:nvSpPr>
-          <p:cNvPr id="28" name="Right Arrow 27"/>
+          <p:cNvPr id="29" name="Right Arrow 28"/>
           <p:cNvSpPr/>
           <p:nvPr/>
         </p:nvSpPr>
@@ -5425,7 +5560,7 @@
       </p:sp>
       <p:sp>
         <p:nvSpPr>
-          <p:cNvPr id="29" name="Rounded Rectangle 28"/>
+          <p:cNvPr id="30" name="Rounded Rectangle 29"/>
           <p:cNvSpPr/>
           <p:nvPr/>
         </p:nvSpPr>
@@ -5440,7 +5575,7 @@
           <a:solidFill>
             <a:srgbClr val="FFFFFF"/>
           </a:solidFill>
-          <a:ln w="25400">
+          <a:ln w="19050">
             <a:solidFill>
               <a:srgbClr val="059669"/>
             </a:solidFill>
@@ -5470,14 +5605,14 @@
       </p:sp>
       <p:sp>
         <p:nvSpPr>
-          <p:cNvPr id="30" name="Rectangle 29"/>
+          <p:cNvPr id="31" name="Rectangle 30"/>
           <p:cNvSpPr/>
           <p:nvPr/>
         </p:nvSpPr>
         <p:spPr>
           <a:xfrm>
             <a:off x="5888736" y="3200400"/>
-            <a:ext cx="1554480" cy="457200"/>
+            <a:ext cx="1554480" cy="411480"/>
           </a:xfrm>
           <a:prstGeom prst="rect">
             <a:avLst/>
@@ -5515,14 +5650,14 @@
       </p:sp>
       <p:sp>
         <p:nvSpPr>
-          <p:cNvPr id="31" name="TextBox 30"/>
+          <p:cNvPr id="32" name="TextBox 31"/>
           <p:cNvSpPr txBox="1"/>
           <p:nvPr/>
         </p:nvSpPr>
         <p:spPr>
           <a:xfrm>
             <a:off x="5888736" y="3246120"/>
-            <a:ext cx="1554480" cy="365760"/>
+            <a:ext cx="1554480" cy="320040"/>
           </a:xfrm>
           <a:prstGeom prst="rect">
             <a:avLst/>
@@ -5536,7 +5671,7 @@
           <a:lstStyle/>
           <a:p>
             <a:pPr algn="ctr">
-              <a:defRPr sz="900" b="1">
+              <a:defRPr sz="850" b="1">
                 <a:solidFill>
                   <a:srgbClr val="FFFFFF"/>
                 </a:solidFill>
@@ -5550,14 +5685,14 @@
       </p:sp>
       <p:sp>
         <p:nvSpPr>
-          <p:cNvPr id="32" name="TextBox 31"/>
+          <p:cNvPr id="33" name="TextBox 32"/>
           <p:cNvSpPr txBox="1"/>
           <p:nvPr/>
         </p:nvSpPr>
         <p:spPr>
           <a:xfrm>
-            <a:off x="5961888" y="3703320"/>
-            <a:ext cx="1408176" cy="2377440"/>
+            <a:off x="5961888" y="3657600"/>
+            <a:ext cx="1408176" cy="2423160"/>
           </a:xfrm>
           <a:prstGeom prst="rect">
             <a:avLst/>
@@ -5572,9 +5707,9 @@
           <a:p>
             <a:pPr>
               <a:spcAft>
-                <a:spcPts val="400"/>
+                <a:spcPts val="300"/>
               </a:spcAft>
-              <a:defRPr sz="900" b="1">
+              <a:defRPr sz="850" b="1">
                 <a:solidFill>
                   <a:srgbClr val="1E293B"/>
                 </a:solidFill>
@@ -5589,7 +5724,7 @@
               <a:spcAft>
                 <a:spcPts val="200"/>
               </a:spcAft>
-              <a:defRPr sz="800">
+              <a:defRPr sz="750">
                 <a:solidFill>
                   <a:srgbClr val="64748B"/>
                 </a:solidFill>
@@ -5604,7 +5739,7 @@
               <a:spcAft>
                 <a:spcPts val="200"/>
               </a:spcAft>
-              <a:defRPr sz="800">
+              <a:defRPr sz="750">
                 <a:solidFill>
                   <a:srgbClr val="64748B"/>
                 </a:solidFill>
@@ -5619,7 +5754,7 @@
               <a:spcAft>
                 <a:spcPts val="200"/>
               </a:spcAft>
-              <a:defRPr sz="800">
+              <a:defRPr sz="750">
                 <a:solidFill>
                   <a:srgbClr val="64748B"/>
                 </a:solidFill>
@@ -5701,7 +5836,7 @@
         <p:spPr>
           <a:xfrm>
             <a:off x="0" y="0"/>
-            <a:ext cx="12191695" cy="91440"/>
+            <a:ext cx="12191695" cy="109728"/>
           </a:xfrm>
           <a:prstGeom prst="rect">
             <a:avLst/>
@@ -5745,7 +5880,7 @@
         </p:nvSpPr>
         <p:spPr>
           <a:xfrm>
-            <a:off x="731520" y="320040"/>
+            <a:off x="731520" y="274320"/>
             <a:ext cx="8229600" cy="731520"/>
           </a:xfrm>
           <a:prstGeom prst="rect">
@@ -5760,7 +5895,7 @@
           <a:lstStyle/>
           <a:p>
             <a:pPr>
-              <a:defRPr sz="2200" b="1">
+              <a:defRPr sz="2000" b="1">
                 <a:solidFill>
                   <a:srgbClr val="0F1E36"/>
                 </a:solidFill>
@@ -5781,7 +5916,7 @@
         </p:nvSpPr>
         <p:spPr>
           <a:xfrm>
-            <a:off x="8412480" y="320040"/>
+            <a:off x="8412480" y="274320"/>
             <a:ext cx="3017520" cy="548640"/>
           </a:xfrm>
           <a:prstGeom prst="rect">
@@ -5796,7 +5931,7 @@
           <a:lstStyle/>
           <a:p>
             <a:pPr algn="r">
-              <a:defRPr sz="1100" b="1">
+              <a:defRPr sz="1000" b="1">
                 <a:solidFill>
                   <a:srgbClr val="E36209"/>
                 </a:solidFill>
@@ -5808,7 +5943,7 @@
           </a:p>
           <a:p>
             <a:pPr algn="r">
-              <a:defRPr sz="900">
+              <a:defRPr sz="850">
                 <a:solidFill>
                   <a:srgbClr val="64748B"/>
                 </a:solidFill>
@@ -5888,7 +6023,7 @@
           <a:lstStyle/>
           <a:p>
             <a:pPr>
-              <a:defRPr sz="1000" b="1">
+              <a:defRPr sz="950" b="1">
                 <a:solidFill>
                   <a:srgbClr val="FFFFFF"/>
                 </a:solidFill>
@@ -5923,7 +6058,7 @@
           <a:lstStyle/>
           <a:p>
             <a:pPr algn="r">
-              <a:defRPr sz="1100" b="1">
+              <a:defRPr sz="1050" b="1">
                 <a:solidFill>
                   <a:srgbClr val="FFFFFF"/>
                 </a:solidFill>
@@ -6019,11 +6154,11 @@
           <a:p>
             <a:pPr>
               <a:spcAft>
-                <a:spcPts val="400"/>
+                <a:spcPts val="300"/>
               </a:spcAft>
             </a:pPr>
             <a:r>
-              <a:rPr b="1" sz="1000">
+              <a:rPr b="1" sz="950">
                 <a:solidFill>
                   <a:srgbClr val="0F1E36"/>
                 </a:solidFill>
@@ -6031,7 +6166,7 @@
               <a:t>• Analysis of Feasibility: </a:t>
             </a:r>
             <a:r>
-              <a:rPr sz="1000">
+              <a:rPr sz="950">
                 <a:solidFill>
                   <a:srgbClr val="1E293B"/>
                 </a:solidFill>
@@ -6042,11 +6177,11 @@
           <a:p>
             <a:pPr>
               <a:spcAft>
-                <a:spcPts val="400"/>
+                <a:spcPts val="300"/>
               </a:spcAft>
             </a:pPr>
             <a:r>
-              <a:rPr b="1" sz="1000">
+              <a:rPr b="1" sz="950">
                 <a:solidFill>
                   <a:srgbClr val="0F1E36"/>
                 </a:solidFill>
@@ -6054,7 +6189,7 @@
               <a:t>• Potential Challenge 1: </a:t>
             </a:r>
             <a:r>
-              <a:rPr sz="1000">
+              <a:rPr sz="950">
                 <a:solidFill>
                   <a:srgbClr val="1E293B"/>
                 </a:solidFill>
@@ -6065,11 +6200,11 @@
           <a:p>
             <a:pPr>
               <a:spcAft>
-                <a:spcPts val="400"/>
+                <a:spcPts val="300"/>
               </a:spcAft>
             </a:pPr>
             <a:r>
-              <a:rPr b="1" sz="1000">
+              <a:rPr b="1" sz="950">
                 <a:solidFill>
                   <a:srgbClr val="059669"/>
                 </a:solidFill>
@@ -6077,7 +6212,7 @@
               <a:t>• Mitigation Strategy 1: </a:t>
             </a:r>
             <a:r>
-              <a:rPr sz="1000">
+              <a:rPr sz="950">
                 <a:solidFill>
                   <a:srgbClr val="1E293B"/>
                 </a:solidFill>
@@ -6088,11 +6223,11 @@
           <a:p>
             <a:pPr>
               <a:spcAft>
-                <a:spcPts val="400"/>
+                <a:spcPts val="300"/>
               </a:spcAft>
             </a:pPr>
             <a:r>
-              <a:rPr b="1" sz="1000">
+              <a:rPr b="1" sz="950">
                 <a:solidFill>
                   <a:srgbClr val="0F1E36"/>
                 </a:solidFill>
@@ -6100,7 +6235,7 @@
               <a:t>• Potential Challenge 2: </a:t>
             </a:r>
             <a:r>
-              <a:rPr sz="1000">
+              <a:rPr sz="950">
                 <a:solidFill>
                   <a:srgbClr val="1E293B"/>
                 </a:solidFill>
@@ -6111,11 +6246,11 @@
           <a:p>
             <a:pPr>
               <a:spcAft>
-                <a:spcPts val="400"/>
+                <a:spcPts val="300"/>
               </a:spcAft>
             </a:pPr>
             <a:r>
-              <a:rPr b="1" sz="1000">
+              <a:rPr b="1" sz="950">
                 <a:solidFill>
                   <a:srgbClr val="059669"/>
                 </a:solidFill>
@@ -6123,7 +6258,7 @@
               <a:t>• Mitigation Strategy 2: </a:t>
             </a:r>
             <a:r>
-              <a:rPr sz="1000">
+              <a:rPr sz="950">
                 <a:solidFill>
                   <a:srgbClr val="1E293B"/>
                 </a:solidFill>
@@ -6134,11 +6269,11 @@
           <a:p>
             <a:pPr>
               <a:spcAft>
-                <a:spcPts val="400"/>
+                <a:spcPts val="300"/>
               </a:spcAft>
             </a:pPr>
             <a:r>
-              <a:rPr b="1" sz="1000">
+              <a:rPr b="1" sz="950">
                 <a:solidFill>
                   <a:srgbClr val="0F1E36"/>
                 </a:solidFill>
@@ -6146,7 +6281,7 @@
               <a:t>• Potential Challenge 3: </a:t>
             </a:r>
             <a:r>
-              <a:rPr sz="1000">
+              <a:rPr sz="950">
                 <a:solidFill>
                   <a:srgbClr val="1E293B"/>
                 </a:solidFill>
@@ -6157,11 +6292,11 @@
           <a:p>
             <a:pPr>
               <a:spcAft>
-                <a:spcPts val="400"/>
+                <a:spcPts val="300"/>
               </a:spcAft>
             </a:pPr>
             <a:r>
-              <a:rPr b="1" sz="1000">
+              <a:rPr b="1" sz="950">
                 <a:solidFill>
                   <a:srgbClr val="059669"/>
                 </a:solidFill>
@@ -6169,7 +6304,7 @@
               <a:t>• Mitigation Strategy 3: </a:t>
             </a:r>
             <a:r>
-              <a:rPr sz="1000">
+              <a:rPr sz="950">
                 <a:solidFill>
                   <a:srgbClr val="1E293B"/>
                 </a:solidFill>
@@ -6196,7 +6331,7 @@
           <a:solidFill>
             <a:srgbClr val="FFFFFF"/>
           </a:solidFill>
-          <a:ln w="25400">
+          <a:ln w="19050">
             <a:solidFill>
               <a:srgbClr val="0284C7"/>
             </a:solidFill>
@@ -6226,14 +6361,59 @@
       </p:sp>
       <p:sp>
         <p:nvSpPr>
-          <p:cNvPr id="12" name="TextBox 11"/>
+          <p:cNvPr id="12" name="Rectangle 11"/>
+          <p:cNvSpPr/>
+          <p:nvPr/>
+        </p:nvSpPr>
+        <p:spPr>
+          <a:xfrm>
+            <a:off x="7772400" y="1188720"/>
+            <a:ext cx="3657600" cy="365760"/>
+          </a:xfrm>
+          <a:prstGeom prst="rect">
+            <a:avLst/>
+          </a:prstGeom>
+          <a:solidFill>
+            <a:srgbClr val="0F1E36"/>
+          </a:solidFill>
+          <a:ln>
+            <a:solidFill>
+              <a:srgbClr val="0F1E36"/>
+            </a:solidFill>
+          </a:ln>
+        </p:spPr>
+        <p:style>
+          <a:lnRef idx="1">
+            <a:schemeClr val="accent1"/>
+          </a:lnRef>
+          <a:fillRef idx="3">
+            <a:schemeClr val="accent1"/>
+          </a:fillRef>
+          <a:effectRef idx="2">
+            <a:schemeClr val="accent1"/>
+          </a:effectRef>
+          <a:fontRef idx="minor">
+            <a:schemeClr val="lt1"/>
+          </a:fontRef>
+        </p:style>
+        <p:txBody>
+          <a:bodyPr rtlCol="0" anchor="ctr"/>
+          <a:lstStyle/>
+          <a:p>
+            <a:pPr algn="ctr"/>
+          </a:p>
+        </p:txBody>
+      </p:sp>
+      <p:sp>
+        <p:nvSpPr>
+          <p:cNvPr id="13" name="TextBox 12"/>
           <p:cNvSpPr txBox="1"/>
           <p:nvPr/>
         </p:nvSpPr>
         <p:spPr>
           <a:xfrm>
-            <a:off x="7863840" y="1280160"/>
-            <a:ext cx="3474720" cy="365760"/>
+            <a:off x="7863840" y="1234440"/>
+            <a:ext cx="3474720" cy="274320"/>
           </a:xfrm>
           <a:prstGeom prst="rect">
             <a:avLst/>
@@ -6246,22 +6426,22 @@
           </a:bodyPr>
           <a:lstStyle/>
           <a:p>
-            <a:pPr>
-              <a:defRPr sz="1000" b="1">
-                <a:solidFill>
-                  <a:srgbClr val="0F1E36"/>
-                </a:solidFill>
-              </a:defRPr>
-            </a:pPr>
-            <a:r>
-              <a:t>PROTOTYPE: FORCED VERIFICATION UI</a:t>
+            <a:pPr algn="ctr">
+              <a:defRPr sz="900" b="1">
+                <a:solidFill>
+                  <a:srgbClr val="FFFFFF"/>
+                </a:solidFill>
+              </a:defRPr>
+            </a:pPr>
+            <a:r>
+              <a:t>FORCED VERIFICATION UI</a:t>
             </a:r>
           </a:p>
         </p:txBody>
       </p:sp>
       <p:pic>
         <p:nvPicPr>
-          <p:cNvPr id="13" name="Picture 12" descr="03_forced_manual_verification.png"/>
+          <p:cNvPr id="14" name="Picture 13" descr="03_cropped.png"/>
           <p:cNvPicPr>
             <a:picLocks noChangeAspect="1"/>
           </p:cNvPicPr>
@@ -6275,8 +6455,8 @@
         </p:blipFill>
         <p:spPr>
           <a:xfrm>
-            <a:off x="7863840" y="1691640"/>
-            <a:ext cx="3474720" cy="1650492"/>
+            <a:off x="7790688" y="1572768"/>
+            <a:ext cx="3621024" cy="4535424"/>
           </a:xfrm>
           <a:prstGeom prst="rect">
             <a:avLst/>
@@ -6353,7 +6533,7 @@
         <p:spPr>
           <a:xfrm>
             <a:off x="0" y="0"/>
-            <a:ext cx="12191695" cy="91440"/>
+            <a:ext cx="12191695" cy="109728"/>
           </a:xfrm>
           <a:prstGeom prst="rect">
             <a:avLst/>
@@ -6397,7 +6577,7 @@
         </p:nvSpPr>
         <p:spPr>
           <a:xfrm>
-            <a:off x="731520" y="320040"/>
+            <a:off x="731520" y="274320"/>
             <a:ext cx="8229600" cy="731520"/>
           </a:xfrm>
           <a:prstGeom prst="rect">
@@ -6412,7 +6592,7 @@
           <a:lstStyle/>
           <a:p>
             <a:pPr>
-              <a:defRPr sz="2200" b="1">
+              <a:defRPr sz="2000" b="1">
                 <a:solidFill>
                   <a:srgbClr val="0F1E36"/>
                 </a:solidFill>
@@ -6433,7 +6613,7 @@
         </p:nvSpPr>
         <p:spPr>
           <a:xfrm>
-            <a:off x="8412480" y="320040"/>
+            <a:off x="8412480" y="274320"/>
             <a:ext cx="3017520" cy="548640"/>
           </a:xfrm>
           <a:prstGeom prst="rect">
@@ -6448,7 +6628,7 @@
           <a:lstStyle/>
           <a:p>
             <a:pPr algn="r">
-              <a:defRPr sz="1100" b="1">
+              <a:defRPr sz="1000" b="1">
                 <a:solidFill>
                   <a:srgbClr val="E36209"/>
                 </a:solidFill>
@@ -6460,7 +6640,7 @@
           </a:p>
           <a:p>
             <a:pPr algn="r">
-              <a:defRPr sz="900">
+              <a:defRPr sz="850">
                 <a:solidFill>
                   <a:srgbClr val="64748B"/>
                 </a:solidFill>
@@ -6540,7 +6720,7 @@
           <a:lstStyle/>
           <a:p>
             <a:pPr>
-              <a:defRPr sz="1000" b="1">
+              <a:defRPr sz="950" b="1">
                 <a:solidFill>
                   <a:srgbClr val="FFFFFF"/>
                 </a:solidFill>
@@ -6575,7 +6755,7 @@
           <a:lstStyle/>
           <a:p>
             <a:pPr algn="r">
-              <a:defRPr sz="1100" b="1">
+              <a:defRPr sz="1050" b="1">
                 <a:solidFill>
                   <a:srgbClr val="FFFFFF"/>
                 </a:solidFill>
@@ -6604,7 +6784,7 @@
           <a:solidFill>
             <a:srgbClr val="FFFFFF"/>
           </a:solidFill>
-          <a:ln w="25400">
+          <a:ln w="19050">
             <a:solidFill>
               <a:srgbClr val="0F1E36"/>
             </a:solidFill>
@@ -6667,7 +6847,7 @@
           </a:p>
           <a:p>
             <a:pPr algn="ctr">
-              <a:defRPr sz="900" b="1">
+              <a:defRPr sz="850" b="1">
                 <a:solidFill>
                   <a:srgbClr val="1E293B"/>
                 </a:solidFill>
@@ -6696,7 +6876,7 @@
           <a:solidFill>
             <a:srgbClr val="FFFFFF"/>
           </a:solidFill>
-          <a:ln w="25400">
+          <a:ln w="19050">
             <a:solidFill>
               <a:srgbClr val="059669"/>
             </a:solidFill>
@@ -6759,7 +6939,7 @@
           </a:p>
           <a:p>
             <a:pPr algn="ctr">
-              <a:defRPr sz="900" b="1">
+              <a:defRPr sz="850" b="1">
                 <a:solidFill>
                   <a:srgbClr val="1E293B"/>
                 </a:solidFill>
@@ -6788,7 +6968,7 @@
           <a:solidFill>
             <a:srgbClr val="FFFFFF"/>
           </a:solidFill>
-          <a:ln w="25400">
+          <a:ln w="19050">
             <a:solidFill>
               <a:srgbClr val="E36209"/>
             </a:solidFill>
@@ -6851,7 +7031,7 @@
           </a:p>
           <a:p>
             <a:pPr algn="ctr">
-              <a:defRPr sz="900" b="1">
+              <a:defRPr sz="850" b="1">
                 <a:solidFill>
                   <a:srgbClr val="1E293B"/>
                 </a:solidFill>
@@ -6880,7 +7060,7 @@
           <a:solidFill>
             <a:srgbClr val="FFFFFF"/>
           </a:solidFill>
-          <a:ln w="25400">
+          <a:ln w="19050">
             <a:solidFill>
               <a:srgbClr val="0F1E36"/>
             </a:solidFill>
@@ -6943,7 +7123,7 @@
           </a:p>
           <a:p>
             <a:pPr algn="ctr">
-              <a:defRPr sz="900" b="1">
+              <a:defRPr sz="850" b="1">
                 <a:solidFill>
                   <a:srgbClr val="1E293B"/>
                 </a:solidFill>
@@ -7039,9 +7219,9 @@
           <a:p>
             <a:pPr>
               <a:spcAft>
-                <a:spcPts val="500"/>
+                <a:spcPts val="400"/>
               </a:spcAft>
-              <a:defRPr sz="1000">
+              <a:defRPr sz="950">
                 <a:solidFill>
                   <a:srgbClr val="1E293B"/>
                 </a:solidFill>
@@ -7054,9 +7234,9 @@
           <a:p>
             <a:pPr>
               <a:spcAft>
-                <a:spcPts val="500"/>
+                <a:spcPts val="400"/>
               </a:spcAft>
-              <a:defRPr sz="1000">
+              <a:defRPr sz="950">
                 <a:solidFill>
                   <a:srgbClr val="1E293B"/>
                 </a:solidFill>
@@ -7069,9 +7249,9 @@
           <a:p>
             <a:pPr>
               <a:spcAft>
-                <a:spcPts val="500"/>
+                <a:spcPts val="400"/>
               </a:spcAft>
-              <a:defRPr sz="1000">
+              <a:defRPr sz="950">
                 <a:solidFill>
                   <a:srgbClr val="1E293B"/>
                 </a:solidFill>
@@ -7084,9 +7264,9 @@
           <a:p>
             <a:pPr>
               <a:spcAft>
-                <a:spcPts val="500"/>
+                <a:spcPts val="400"/>
               </a:spcAft>
-              <a:defRPr sz="1000">
+              <a:defRPr sz="950">
                 <a:solidFill>
                   <a:srgbClr val="1E293B"/>
                 </a:solidFill>
@@ -7115,9 +7295,9 @@
           <a:solidFill>
             <a:srgbClr val="FFFFFF"/>
           </a:solidFill>
-          <a:ln w="25400">
+          <a:ln w="19050">
             <a:solidFill>
-              <a:srgbClr val="059669"/>
+              <a:srgbClr val="0284C7"/>
             </a:solidFill>
           </a:ln>
         </p:spPr>
@@ -7145,14 +7325,59 @@
       </p:sp>
       <p:sp>
         <p:nvSpPr>
-          <p:cNvPr id="20" name="TextBox 19"/>
+          <p:cNvPr id="20" name="Rectangle 19"/>
+          <p:cNvSpPr/>
+          <p:nvPr/>
+        </p:nvSpPr>
+        <p:spPr>
+          <a:xfrm>
+            <a:off x="7772400" y="1188720"/>
+            <a:ext cx="3657600" cy="365760"/>
+          </a:xfrm>
+          <a:prstGeom prst="rect">
+            <a:avLst/>
+          </a:prstGeom>
+          <a:solidFill>
+            <a:srgbClr val="0F1E36"/>
+          </a:solidFill>
+          <a:ln>
+            <a:solidFill>
+              <a:srgbClr val="0F1E36"/>
+            </a:solidFill>
+          </a:ln>
+        </p:spPr>
+        <p:style>
+          <a:lnRef idx="1">
+            <a:schemeClr val="accent1"/>
+          </a:lnRef>
+          <a:fillRef idx="3">
+            <a:schemeClr val="accent1"/>
+          </a:fillRef>
+          <a:effectRef idx="2">
+            <a:schemeClr val="accent1"/>
+          </a:effectRef>
+          <a:fontRef idx="minor">
+            <a:schemeClr val="lt1"/>
+          </a:fontRef>
+        </p:style>
+        <p:txBody>
+          <a:bodyPr rtlCol="0" anchor="ctr"/>
+          <a:lstStyle/>
+          <a:p>
+            <a:pPr algn="ctr"/>
+          </a:p>
+        </p:txBody>
+      </p:sp>
+      <p:sp>
+        <p:nvSpPr>
+          <p:cNvPr id="21" name="TextBox 20"/>
           <p:cNvSpPr txBox="1"/>
           <p:nvPr/>
         </p:nvSpPr>
         <p:spPr>
           <a:xfrm>
-            <a:off x="7863840" y="1280160"/>
-            <a:ext cx="3474720" cy="365760"/>
+            <a:off x="7863840" y="1234440"/>
+            <a:ext cx="3474720" cy="274320"/>
           </a:xfrm>
           <a:prstGeom prst="rect">
             <a:avLst/>
@@ -7165,22 +7390,22 @@
           </a:bodyPr>
           <a:lstStyle/>
           <a:p>
-            <a:pPr>
-              <a:defRPr sz="1000" b="1">
-                <a:solidFill>
-                  <a:srgbClr val="0F1E36"/>
-                </a:solidFill>
-              </a:defRPr>
-            </a:pPr>
-            <a:r>
-              <a:t>PROTOTYPE: MATCHED VAIDYAS UI</a:t>
+            <a:pPr algn="ctr">
+              <a:defRPr sz="900" b="1">
+                <a:solidFill>
+                  <a:srgbClr val="FFFFFF"/>
+                </a:solidFill>
+              </a:defRPr>
+            </a:pPr>
+            <a:r>
+              <a:t>MATCHED VAIDYAS UI</a:t>
             </a:r>
           </a:p>
         </p:txBody>
       </p:sp>
       <p:pic>
         <p:nvPicPr>
-          <p:cNvPr id="21" name="Picture 20" descr="04_matched_adequate_vaidyas.png"/>
+          <p:cNvPr id="22" name="Picture 21" descr="04_cropped.png"/>
           <p:cNvPicPr>
             <a:picLocks noChangeAspect="1"/>
           </p:cNvPicPr>
@@ -7194,8 +7419,8 @@
         </p:blipFill>
         <p:spPr>
           <a:xfrm>
-            <a:off x="7863840" y="1691640"/>
-            <a:ext cx="3474720" cy="1650492"/>
+            <a:off x="7790688" y="1572768"/>
+            <a:ext cx="3621024" cy="4535424"/>
           </a:xfrm>
           <a:prstGeom prst="rect">
             <a:avLst/>
@@ -7272,7 +7497,7 @@
         <p:spPr>
           <a:xfrm>
             <a:off x="0" y="0"/>
-            <a:ext cx="12191695" cy="91440"/>
+            <a:ext cx="12191695" cy="109728"/>
           </a:xfrm>
           <a:prstGeom prst="rect">
             <a:avLst/>
@@ -7316,7 +7541,7 @@
         </p:nvSpPr>
         <p:spPr>
           <a:xfrm>
-            <a:off x="731520" y="320040"/>
+            <a:off x="731520" y="274320"/>
             <a:ext cx="8229600" cy="731520"/>
           </a:xfrm>
           <a:prstGeom prst="rect">
@@ -7331,7 +7556,7 @@
           <a:lstStyle/>
           <a:p>
             <a:pPr>
-              <a:defRPr sz="2200" b="1">
+              <a:defRPr sz="2000" b="1">
                 <a:solidFill>
                   <a:srgbClr val="0F1E36"/>
                 </a:solidFill>
@@ -7352,7 +7577,7 @@
         </p:nvSpPr>
         <p:spPr>
           <a:xfrm>
-            <a:off x="8412480" y="320040"/>
+            <a:off x="8412480" y="274320"/>
             <a:ext cx="3017520" cy="548640"/>
           </a:xfrm>
           <a:prstGeom prst="rect">
@@ -7367,7 +7592,7 @@
           <a:lstStyle/>
           <a:p>
             <a:pPr algn="r">
-              <a:defRPr sz="1100" b="1">
+              <a:defRPr sz="1000" b="1">
                 <a:solidFill>
                   <a:srgbClr val="E36209"/>
                 </a:solidFill>
@@ -7379,7 +7604,7 @@
           </a:p>
           <a:p>
             <a:pPr algn="r">
-              <a:defRPr sz="900">
+              <a:defRPr sz="850">
                 <a:solidFill>
                   <a:srgbClr val="64748B"/>
                 </a:solidFill>
@@ -7459,7 +7684,7 @@
           <a:lstStyle/>
           <a:p>
             <a:pPr>
-              <a:defRPr sz="1000" b="1">
+              <a:defRPr sz="950" b="1">
                 <a:solidFill>
                   <a:srgbClr val="FFFFFF"/>
                 </a:solidFill>
@@ -7494,7 +7719,7 @@
           <a:lstStyle/>
           <a:p>
             <a:pPr algn="r">
-              <a:defRPr sz="1100" b="1">
+              <a:defRPr sz="1050" b="1">
                 <a:solidFill>
                   <a:srgbClr val="FFFFFF"/>
                 </a:solidFill>

</xml_diff>